<commit_message>
docs: add REAC mapping slide to presentation (12 slides total)
</commit_message>
<xml_diff>
--- a/documentation/Presentation_iac-infra_ASD.pptx
+++ b/documentation/Presentation_iac-infra_ASD.pptx
@@ -16,9 +16,10 @@
     <p:sldId id="264" r:id="rId10"/>
     <p:sldId id="265" r:id="rId11"/>
     <p:sldId id="266" r:id="rId12"/>
+    <p:sldId id="267" r:id="rId13"/>
   </p:sldIdLst>
   <p:notesMasterIdLst>
-    <p:notesMasterId r:id="rId13"/>
+    <p:notesMasterId r:id="rId14"/>
   </p:notesMasterIdLst>
   <p:sldSz cx="12192000" cy="6858000"/>
   <p:notesSz cx="6858000" cy="12192000"/>
@@ -730,6 +731,94 @@
 </p:notes>
 </file>
 
+<file path=ppt/notesSlides/notesSlide12.xml><?xml version="1.0" encoding="utf-8"?>
+<p:notes xmlns:a="http://schemas.openxmlformats.org/drawingml/2006/main" xmlns:r="http://schemas.openxmlformats.org/officeDocument/2006/relationships" xmlns:p="http://schemas.openxmlformats.org/presentationml/2006/main">
+  <p:cSld>
+    <p:spTree>
+      <p:nvGrpSpPr>
+        <p:cNvPr id="1" name=""/>
+        <p:cNvGrpSpPr/>
+        <p:nvPr/>
+      </p:nvGrpSpPr>
+      <p:grpSpPr>
+        <a:xfrm>
+          <a:off x="0" y="0"/>
+          <a:ext cx="0" cy="0"/>
+          <a:chOff x="0" y="0"/>
+          <a:chExt cx="0" cy="0"/>
+        </a:xfrm>
+      </p:grpSpPr>
+      <p:sp>
+        <p:nvSpPr>
+          <p:cNvPr id="2" name="Slide Image Placeholder 1"/>
+          <p:cNvSpPr>
+            <a:spLocks noGrp="1" noRot="1" noChangeAspect="1"/>
+          </p:cNvSpPr>
+          <p:nvPr>
+            <p:ph type="sldImg"/>
+          </p:nvPr>
+        </p:nvSpPr>
+        <p:spPr/>
+      </p:sp>
+      <p:sp>
+        <p:nvSpPr>
+          <p:cNvPr id="3" name="Notes Placeholder 2"/>
+          <p:cNvSpPr>
+            <a:spLocks noGrp="1"/>
+          </p:cNvSpPr>
+          <p:nvPr>
+            <p:ph type="body" idx="1"/>
+          </p:nvPr>
+        </p:nvSpPr>
+        <p:spPr/>
+        <p:txBody>
+          <a:bodyPr/>
+          <a:lstStyle/>
+          <a:p>
+            <a:r>
+              <a:rPr lang="en-US" dirty="0"/>
+              <a:t/>
+            </a:r>
+            <a:endParaRPr lang="en-US" dirty="0"/>
+          </a:p>
+        </p:txBody>
+      </p:sp>
+      <p:sp>
+        <p:nvSpPr>
+          <p:cNvPr id="4" name="Slide Number Placeholder 3"/>
+          <p:cNvSpPr>
+            <a:spLocks noGrp="1"/>
+          </p:cNvSpPr>
+          <p:nvPr>
+            <p:ph type="sldNum" sz="quarter" idx="10"/>
+          </p:nvPr>
+        </p:nvSpPr>
+        <p:spPr/>
+        <p:txBody>
+          <a:bodyPr/>
+          <a:lstStyle/>
+          <a:p>
+            <a:fld id="{F7021451-1387-4CA6-816F-3879F97B5CBC}" type="slidenum">
+              <a:rPr lang="en-US"/>
+              <a:t>12</a:t>
+            </a:fld>
+            <a:endParaRPr lang="en-US"/>
+          </a:p>
+        </p:txBody>
+      </p:sp>
+    </p:spTree>
+    <p:extLst>
+      <p:ext uri="{BB962C8B-B14F-4D97-AF65-F5344CB8AC3E}">
+        <p14:creationId xmlns:p14="http://schemas.microsoft.com/office/powerpoint/2010/main" val="1024086991"/>
+      </p:ext>
+    </p:extLst>
+  </p:cSld>
+  <p:clrMapOvr>
+    <a:masterClrMapping/>
+  </p:clrMapOvr>
+</p:notes>
+</file>
+
 <file path=ppt/notesSlides/notesSlide2.xml><?xml version="1.0" encoding="utf-8"?>
 <p:notes xmlns:a="http://schemas.openxmlformats.org/drawingml/2006/main" xmlns:r="http://schemas.openxmlformats.org/officeDocument/2006/relationships" xmlns:p="http://schemas.openxmlformats.org/presentationml/2006/main">
   <p:cSld>
@@ -2654,11 +2743,11 @@
             <a:avLst/>
           </a:prstGeom>
           <a:solidFill>
-            <a:srgbClr val="0D1B2A"/>
+            <a:srgbClr val="F5F5F5"/>
           </a:solidFill>
           <a:ln w="12700">
             <a:solidFill>
-              <a:srgbClr val="0D1B2A"/>
+              <a:srgbClr val="F5F5F5"/>
             </a:solidFill>
             <a:prstDash val="solid"/>
           </a:ln>
@@ -2704,6 +2793,237 @@
             <a:avLst/>
           </a:prstGeom>
           <a:solidFill>
+            <a:srgbClr val="1A237E"/>
+          </a:solidFill>
+          <a:ln w="12700">
+            <a:solidFill>
+              <a:srgbClr val="1A237E"/>
+            </a:solidFill>
+            <a:prstDash val="solid"/>
+          </a:ln>
+        </p:spPr>
+      </p:sp>
+      <p:sp>
+        <p:nvSpPr>
+          <p:cNvPr id="5" name="Text 3"/>
+          <p:cNvSpPr/>
+          <p:nvPr/>
+        </p:nvSpPr>
+        <p:spPr>
+          <a:xfrm>
+            <a:off x="244145" y="137160"/>
+            <a:ext cx="9751162" cy="822960"/>
+          </a:xfrm>
+          <a:prstGeom prst="rect">
+            <a:avLst/>
+          </a:prstGeom>
+          <a:noFill/>
+          <a:ln/>
+        </p:spPr>
+        <p:txBody>
+          <a:bodyPr wrap="square" rtlCol="0" anchor="ctr"/>
+          <a:lstStyle/>
+          <a:p>
+            <a:pPr indent="0" marL="0">
+              <a:buNone/>
+            </a:pPr>
+            <a:r>
+              <a:rPr lang="en-US" sz="2600" b="1" dirty="0">
+                <a:solidFill>
+                  <a:srgbClr val="FFFFFF"/>
+                </a:solidFill>
+                <a:latin typeface="Arial" pitchFamily="34" charset="0"/>
+                <a:ea typeface="Arial" pitchFamily="34" charset="-122"/>
+                <a:cs typeface="Arial" pitchFamily="34" charset="-120"/>
+              </a:rPr>
+              <a:t>Projet → Compétences REAC</a:t>
+            </a:r>
+            <a:endParaRPr lang="en-US" sz="2600" dirty="0"/>
+          </a:p>
+        </p:txBody>
+      </p:sp>
+      <p:sp>
+        <p:nvSpPr>
+          <p:cNvPr id="6" name="Text 4"/>
+          <p:cNvSpPr/>
+          <p:nvPr/>
+        </p:nvSpPr>
+        <p:spPr>
+          <a:xfrm>
+            <a:off x="244145" y="685800"/>
+            <a:ext cx="9751162" cy="548640"/>
+          </a:xfrm>
+          <a:prstGeom prst="rect">
+            <a:avLst/>
+          </a:prstGeom>
+          <a:noFill/>
+          <a:ln/>
+        </p:spPr>
+        <p:txBody>
+          <a:bodyPr wrap="square" rtlCol="0" anchor="ctr"/>
+          <a:lstStyle/>
+          <a:p>
+            <a:pPr indent="0" marL="0">
+              <a:buNone/>
+            </a:pPr>
+            <a:r>
+              <a:rPr lang="en-US" sz="1300" i="1" dirty="0">
+                <a:solidFill>
+                  <a:srgbClr val="AACCFF"/>
+                </a:solidFill>
+                <a:latin typeface="Arial" pitchFamily="34" charset="0"/>
+                <a:ea typeface="Arial" pitchFamily="34" charset="-122"/>
+                <a:cs typeface="Arial" pitchFamily="34" charset="-120"/>
+              </a:rPr>
+              <a:t>Chaque partie du projet coche une compétence du titre</a:t>
+            </a:r>
+            <a:endParaRPr lang="en-US" sz="1300" dirty="0"/>
+          </a:p>
+        </p:txBody>
+      </p:sp>
+      <p:sp>
+        <p:nvSpPr>
+          <p:cNvPr id="7" name="Shape 5"/>
+          <p:cNvSpPr/>
+          <p:nvPr/>
+        </p:nvSpPr>
+        <p:spPr>
+          <a:xfrm>
+            <a:off x="244145" y="1371600"/>
+            <a:ext cx="2925166" cy="480060"/>
+          </a:xfrm>
+          <a:prstGeom prst="rect">
+            <a:avLst/>
+          </a:prstGeom>
+          <a:solidFill>
+            <a:srgbClr val="1A237E"/>
+          </a:solidFill>
+          <a:ln w="12700">
+            <a:solidFill>
+              <a:srgbClr val="1A237E"/>
+            </a:solidFill>
+            <a:prstDash val="solid"/>
+          </a:ln>
+        </p:spPr>
+      </p:sp>
+      <p:sp>
+        <p:nvSpPr>
+          <p:cNvPr id="8" name="Text 6"/>
+          <p:cNvSpPr/>
+          <p:nvPr/>
+        </p:nvSpPr>
+        <p:spPr>
+          <a:xfrm>
+            <a:off x="244145" y="1371600"/>
+            <a:ext cx="2925166" cy="480060"/>
+          </a:xfrm>
+          <a:prstGeom prst="rect">
+            <a:avLst/>
+          </a:prstGeom>
+          <a:noFill/>
+          <a:ln/>
+        </p:spPr>
+        <p:txBody>
+          <a:bodyPr wrap="square" rtlCol="0" anchor="ctr"/>
+          <a:lstStyle/>
+          <a:p>
+            <a:pPr algn="ctr" indent="0" marL="0">
+              <a:buNone/>
+            </a:pPr>
+            <a:r>
+              <a:rPr lang="en-US" sz="1100" b="1" dirty="0">
+                <a:solidFill>
+                  <a:srgbClr val="FFFFFF"/>
+                </a:solidFill>
+                <a:latin typeface="Arial" pitchFamily="34" charset="0"/>
+                <a:ea typeface="Arial" pitchFamily="34" charset="-122"/>
+                <a:cs typeface="Arial" pitchFamily="34" charset="-120"/>
+              </a:rPr>
+              <a:t>Partie du projet</a:t>
+            </a:r>
+            <a:endParaRPr lang="en-US" sz="1100" dirty="0"/>
+          </a:p>
+        </p:txBody>
+      </p:sp>
+      <p:sp>
+        <p:nvSpPr>
+          <p:cNvPr id="9" name="Shape 7"/>
+          <p:cNvSpPr/>
+          <p:nvPr/>
+        </p:nvSpPr>
+        <p:spPr>
+          <a:xfrm>
+            <a:off x="3290926" y="1371600"/>
+            <a:ext cx="4144061" cy="480060"/>
+          </a:xfrm>
+          <a:prstGeom prst="rect">
+            <a:avLst/>
+          </a:prstGeom>
+          <a:solidFill>
+            <a:srgbClr val="1565C0"/>
+          </a:solidFill>
+          <a:ln w="12700">
+            <a:solidFill>
+              <a:srgbClr val="1565C0"/>
+            </a:solidFill>
+            <a:prstDash val="solid"/>
+          </a:ln>
+        </p:spPr>
+      </p:sp>
+      <p:sp>
+        <p:nvSpPr>
+          <p:cNvPr id="10" name="Text 8"/>
+          <p:cNvSpPr/>
+          <p:nvPr/>
+        </p:nvSpPr>
+        <p:spPr>
+          <a:xfrm>
+            <a:off x="3290926" y="1371600"/>
+            <a:ext cx="4144061" cy="480060"/>
+          </a:xfrm>
+          <a:prstGeom prst="rect">
+            <a:avLst/>
+          </a:prstGeom>
+          <a:noFill/>
+          <a:ln/>
+        </p:spPr>
+        <p:txBody>
+          <a:bodyPr wrap="square" rtlCol="0" anchor="ctr"/>
+          <a:lstStyle/>
+          <a:p>
+            <a:pPr algn="ctr" indent="0" marL="0">
+              <a:buNone/>
+            </a:pPr>
+            <a:r>
+              <a:rPr lang="en-US" sz="1100" b="1" dirty="0">
+                <a:solidFill>
+                  <a:srgbClr val="FFFFFF"/>
+                </a:solidFill>
+                <a:latin typeface="Arial" pitchFamily="34" charset="0"/>
+                <a:ea typeface="Arial" pitchFamily="34" charset="-122"/>
+                <a:cs typeface="Arial" pitchFamily="34" charset="-120"/>
+              </a:rPr>
+              <a:t>Compétence REAC</a:t>
+            </a:r>
+            <a:endParaRPr lang="en-US" sz="1100" dirty="0"/>
+          </a:p>
+        </p:txBody>
+      </p:sp>
+      <p:sp>
+        <p:nvSpPr>
+          <p:cNvPr id="11" name="Shape 9"/>
+          <p:cNvSpPr/>
+          <p:nvPr/>
+        </p:nvSpPr>
+        <p:spPr>
+          <a:xfrm>
+            <a:off x="7557516" y="1371600"/>
+            <a:ext cx="4388206" cy="480060"/>
+          </a:xfrm>
+          <a:prstGeom prst="rect">
+            <a:avLst/>
+          </a:prstGeom>
+          <a:solidFill>
             <a:srgbClr val="00695C"/>
           </a:solidFill>
           <a:ln w="12700">
@@ -2716,14 +3036,14 @@
       </p:sp>
       <p:sp>
         <p:nvSpPr>
-          <p:cNvPr id="5" name="Text 3"/>
-          <p:cNvSpPr/>
-          <p:nvPr/>
-        </p:nvSpPr>
-        <p:spPr>
-          <a:xfrm>
-            <a:off x="244145" y="137160"/>
-            <a:ext cx="9751162" cy="822960"/>
+          <p:cNvPr id="12" name="Text 10"/>
+          <p:cNvSpPr/>
+          <p:nvPr/>
+        </p:nvSpPr>
+        <p:spPr>
+          <a:xfrm>
+            <a:off x="7557516" y="1371600"/>
+            <a:ext cx="4388206" cy="480060"/>
           </a:xfrm>
           <a:prstGeom prst="rect">
             <a:avLst/>
@@ -2735,11 +3055,11 @@
           <a:bodyPr wrap="square" rtlCol="0" anchor="ctr"/>
           <a:lstStyle/>
           <a:p>
-            <a:pPr indent="0" marL="0">
-              <a:buNone/>
-            </a:pPr>
-            <a:r>
-              <a:rPr lang="en-US" sz="2600" b="1" dirty="0">
+            <a:pPr algn="ctr" indent="0" marL="0">
+              <a:buNone/>
+            </a:pPr>
+            <a:r>
+              <a:rPr lang="en-US" sz="1100" b="1" dirty="0">
                 <a:solidFill>
                   <a:srgbClr val="FFFFFF"/>
                 </a:solidFill>
@@ -2747,61 +3067,22 @@
                 <a:ea typeface="Arial" pitchFamily="34" charset="-122"/>
                 <a:cs typeface="Arial" pitchFamily="34" charset="-120"/>
               </a:rPr>
-              <a:t>Démonstration Live</a:t>
-            </a:r>
-            <a:endParaRPr lang="en-US" sz="2600" dirty="0"/>
-          </a:p>
-        </p:txBody>
-      </p:sp>
-      <p:sp>
-        <p:nvSpPr>
-          <p:cNvPr id="6" name="Text 4"/>
-          <p:cNvSpPr/>
-          <p:nvPr/>
-        </p:nvSpPr>
-        <p:spPr>
-          <a:xfrm>
-            <a:off x="244145" y="685800"/>
-            <a:ext cx="9751162" cy="548640"/>
-          </a:xfrm>
-          <a:prstGeom prst="rect">
-            <a:avLst/>
-          </a:prstGeom>
-          <a:noFill/>
-          <a:ln/>
-        </p:spPr>
-        <p:txBody>
-          <a:bodyPr wrap="square" rtlCol="0" anchor="ctr"/>
-          <a:lstStyle/>
-          <a:p>
-            <a:pPr indent="0" marL="0">
-              <a:buNone/>
-            </a:pPr>
-            <a:r>
-              <a:rPr lang="en-US" sz="1300" i="1" dirty="0">
-                <a:solidFill>
-                  <a:srgbClr val="AACCFF"/>
-                </a:solidFill>
-                <a:latin typeface="Arial" pitchFamily="34" charset="0"/>
-                <a:ea typeface="Arial" pitchFamily="34" charset="-122"/>
-                <a:cs typeface="Arial" pitchFamily="34" charset="-120"/>
-              </a:rPr>
-              <a:t>Séquence de commandes — prêt à l'emploi</a:t>
-            </a:r>
-            <a:endParaRPr lang="en-US" sz="1300" dirty="0"/>
-          </a:p>
-        </p:txBody>
-      </p:sp>
-      <p:sp>
-        <p:nvSpPr>
-          <p:cNvPr id="7" name="Shape 5"/>
-          <p:cNvSpPr/>
-          <p:nvPr/>
-        </p:nvSpPr>
-        <p:spPr>
-          <a:xfrm>
-            <a:off x="244145" y="1508760"/>
-            <a:ext cx="5728716" cy="685800"/>
+              <a:t>Livrable / Preuve</a:t>
+            </a:r>
+            <a:endParaRPr lang="en-US" sz="1100" dirty="0"/>
+          </a:p>
+        </p:txBody>
+      </p:sp>
+      <p:sp>
+        <p:nvSpPr>
+          <p:cNvPr id="13" name="Shape 11"/>
+          <p:cNvSpPr/>
+          <p:nvPr/>
+        </p:nvSpPr>
+        <p:spPr>
+          <a:xfrm>
+            <a:off x="244145" y="1851660"/>
+            <a:ext cx="146304" cy="445313"/>
           </a:xfrm>
           <a:prstGeom prst="rect">
             <a:avLst/>
@@ -2819,63 +3100,24 @@
       </p:sp>
       <p:sp>
         <p:nvSpPr>
-          <p:cNvPr id="8" name="Text 6"/>
-          <p:cNvSpPr/>
-          <p:nvPr/>
-        </p:nvSpPr>
-        <p:spPr>
-          <a:xfrm>
-            <a:off x="244145" y="1508760"/>
-            <a:ext cx="5728716" cy="685800"/>
-          </a:xfrm>
-          <a:prstGeom prst="rect">
-            <a:avLst/>
-          </a:prstGeom>
-          <a:noFill/>
-          <a:ln/>
-        </p:spPr>
-        <p:txBody>
-          <a:bodyPr wrap="square" rtlCol="0" anchor="ctr"/>
-          <a:lstStyle/>
-          <a:p>
-            <a:pPr algn="ctr" indent="0" marL="0">
-              <a:buNone/>
-            </a:pPr>
-            <a:r>
-              <a:rPr lang="en-US" sz="1300" b="1" dirty="0">
-                <a:solidFill>
-                  <a:srgbClr val="FFFFFF"/>
-                </a:solidFill>
-                <a:latin typeface="Arial" pitchFamily="34" charset="0"/>
-                <a:ea typeface="Arial" pitchFamily="34" charset="-122"/>
-                <a:cs typeface="Arial" pitchFamily="34" charset="-120"/>
-              </a:rPr>
-              <a:t>1. VM + Ansible</a:t>
-            </a:r>
-            <a:endParaRPr lang="en-US" sz="1300" dirty="0"/>
-          </a:p>
-        </p:txBody>
-      </p:sp>
-      <p:sp>
-        <p:nvSpPr>
-          <p:cNvPr id="9" name="Shape 7"/>
-          <p:cNvSpPr/>
-          <p:nvPr/>
-        </p:nvSpPr>
-        <p:spPr>
-          <a:xfrm>
-            <a:off x="244145" y="2194560"/>
-            <a:ext cx="5728716" cy="1577340"/>
-          </a:xfrm>
-          <a:prstGeom prst="rect">
-            <a:avLst/>
-          </a:prstGeom>
-          <a:solidFill>
-            <a:srgbClr val="1E2A3A"/>
+          <p:cNvPr id="14" name="Shape 12"/>
+          <p:cNvSpPr/>
+          <p:nvPr/>
+        </p:nvSpPr>
+        <p:spPr>
+          <a:xfrm>
+            <a:off x="390449" y="1851660"/>
+            <a:ext cx="2778862" cy="445313"/>
+          </a:xfrm>
+          <a:prstGeom prst="rect">
+            <a:avLst/>
+          </a:prstGeom>
+          <a:solidFill>
+            <a:srgbClr val="FFFFFF"/>
           </a:solidFill>
           <a:ln w="12700">
             <a:solidFill>
-              <a:srgbClr val="1E2A3A"/>
+              <a:srgbClr val="DDDDDD"/>
             </a:solidFill>
             <a:prstDash val="solid"/>
           </a:ln>
@@ -2883,14 +3125,14 @@
       </p:sp>
       <p:sp>
         <p:nvSpPr>
-          <p:cNvPr id="10" name="Text 8"/>
-          <p:cNvSpPr/>
-          <p:nvPr/>
-        </p:nvSpPr>
-        <p:spPr>
-          <a:xfrm>
-            <a:off x="365760" y="2331720"/>
-            <a:ext cx="5484571" cy="411480"/>
+          <p:cNvPr id="15" name="Text 13"/>
+          <p:cNvSpPr/>
+          <p:nvPr/>
+        </p:nvSpPr>
+        <p:spPr>
+          <a:xfrm>
+            <a:off x="427025" y="1851660"/>
+            <a:ext cx="2681021" cy="445313"/>
           </a:xfrm>
           <a:prstGeom prst="rect">
             <a:avLst/>
@@ -2906,118 +3148,40 @@
               <a:buNone/>
             </a:pPr>
             <a:r>
-              <a:rPr lang="en-US" sz="1000" dirty="0">
-                <a:solidFill>
-                  <a:srgbClr val="98D982"/>
-                </a:solidFill>
-                <a:latin typeface="Courier New" pitchFamily="34" charset="0"/>
-                <a:ea typeface="Courier New" pitchFamily="34" charset="-122"/>
-                <a:cs typeface="Courier New" pitchFamily="34" charset="-120"/>
-              </a:rPr>
-              <a:t>$ vagrant up</a:t>
-            </a:r>
-            <a:endParaRPr lang="en-US" sz="1000" dirty="0"/>
-          </a:p>
-        </p:txBody>
-      </p:sp>
-      <p:sp>
-        <p:nvSpPr>
-          <p:cNvPr id="11" name="Text 9"/>
-          <p:cNvSpPr/>
-          <p:nvPr/>
-        </p:nvSpPr>
-        <p:spPr>
-          <a:xfrm>
-            <a:off x="365760" y="2811780"/>
-            <a:ext cx="5484571" cy="411480"/>
-          </a:xfrm>
-          <a:prstGeom prst="rect">
-            <a:avLst/>
-          </a:prstGeom>
-          <a:noFill/>
-          <a:ln/>
-        </p:spPr>
-        <p:txBody>
-          <a:bodyPr wrap="square" rtlCol="0" anchor="ctr"/>
-          <a:lstStyle/>
-          <a:p>
-            <a:pPr indent="0" marL="0">
-              <a:buNone/>
-            </a:pPr>
-            <a:r>
-              <a:rPr lang="en-US" sz="1000" dirty="0">
-                <a:solidFill>
-                  <a:srgbClr val="98D982"/>
-                </a:solidFill>
-                <a:latin typeface="Courier New" pitchFamily="34" charset="0"/>
-                <a:ea typeface="Courier New" pitchFamily="34" charset="-122"/>
-                <a:cs typeface="Courier New" pitchFamily="34" charset="-120"/>
-              </a:rPr>
-              <a:t>$ ansible-playbook ansible/playbook.yml</a:t>
-            </a:r>
-            <a:endParaRPr lang="en-US" sz="1000" dirty="0"/>
-          </a:p>
-        </p:txBody>
-      </p:sp>
-      <p:sp>
-        <p:nvSpPr>
-          <p:cNvPr id="12" name="Text 10"/>
-          <p:cNvSpPr/>
-          <p:nvPr/>
-        </p:nvSpPr>
-        <p:spPr>
-          <a:xfrm>
-            <a:off x="365760" y="3291840"/>
-            <a:ext cx="5484571" cy="411480"/>
-          </a:xfrm>
-          <a:prstGeom prst="rect">
-            <a:avLst/>
-          </a:prstGeom>
-          <a:noFill/>
-          <a:ln/>
-        </p:spPr>
-        <p:txBody>
-          <a:bodyPr wrap="square" rtlCol="0" anchor="ctr"/>
-          <a:lstStyle/>
-          <a:p>
-            <a:pPr indent="0" marL="0">
-              <a:buNone/>
-            </a:pPr>
-            <a:r>
-              <a:rPr lang="en-US" sz="1000" dirty="0">
-                <a:solidFill>
-                  <a:srgbClr val="98D982"/>
-                </a:solidFill>
-                <a:latin typeface="Courier New" pitchFamily="34" charset="0"/>
-                <a:ea typeface="Courier New" pitchFamily="34" charset="-122"/>
-                <a:cs typeface="Courier New" pitchFamily="34" charset="-120"/>
-              </a:rPr>
-              <a:t>$ curl http://192.168.56.10</a:t>
-            </a:r>
-            <a:endParaRPr lang="en-US" sz="1000" dirty="0"/>
-          </a:p>
-        </p:txBody>
-      </p:sp>
-      <p:sp>
-        <p:nvSpPr>
-          <p:cNvPr id="13" name="Shape 11"/>
-          <p:cNvSpPr/>
-          <p:nvPr/>
-        </p:nvSpPr>
-        <p:spPr>
-          <a:xfrm>
-            <a:off x="6217006" y="1508760"/>
-            <a:ext cx="5728716" cy="685800"/>
-          </a:xfrm>
-          <a:prstGeom prst="rect">
-            <a:avLst/>
-          </a:prstGeom>
-          <a:solidFill>
-            <a:srgbClr val="1565C0"/>
+              <a:rPr lang="en-US" sz="900" b="1" dirty="0">
+                <a:solidFill>
+                  <a:srgbClr val="222222"/>
+                </a:solidFill>
+                <a:latin typeface="Arial" pitchFamily="34" charset="0"/>
+                <a:ea typeface="Arial" pitchFamily="34" charset="-122"/>
+                <a:cs typeface="Arial" pitchFamily="34" charset="-120"/>
+              </a:rPr>
+              <a:t>Vagrantfile + Ansible (3 rôles)</a:t>
+            </a:r>
+            <a:endParaRPr lang="en-US" sz="900" dirty="0"/>
+          </a:p>
+        </p:txBody>
+      </p:sp>
+      <p:sp>
+        <p:nvSpPr>
+          <p:cNvPr id="16" name="Shape 14"/>
+          <p:cNvSpPr/>
+          <p:nvPr/>
+        </p:nvSpPr>
+        <p:spPr>
+          <a:xfrm>
+            <a:off x="3290926" y="1851660"/>
+            <a:ext cx="4144061" cy="445313"/>
+          </a:xfrm>
+          <a:prstGeom prst="rect">
+            <a:avLst/>
+          </a:prstGeom>
+          <a:solidFill>
+            <a:srgbClr val="FFFFFF"/>
           </a:solidFill>
           <a:ln w="12700">
             <a:solidFill>
-              <a:srgbClr val="1565C0"/>
+              <a:srgbClr val="DDDDDD"/>
             </a:solidFill>
             <a:prstDash val="solid"/>
           </a:ln>
@@ -3025,14 +3189,14 @@
       </p:sp>
       <p:sp>
         <p:nvSpPr>
-          <p:cNvPr id="14" name="Text 12"/>
-          <p:cNvSpPr/>
-          <p:nvPr/>
-        </p:nvSpPr>
-        <p:spPr>
-          <a:xfrm>
-            <a:off x="6217006" y="1508760"/>
-            <a:ext cx="5728716" cy="685800"/>
+          <p:cNvPr id="17" name="Text 15"/>
+          <p:cNvSpPr/>
+          <p:nvPr/>
+        </p:nvSpPr>
+        <p:spPr>
+          <a:xfrm>
+            <a:off x="3352190" y="1851660"/>
+            <a:ext cx="4022446" cy="445313"/>
           </a:xfrm>
           <a:prstGeom prst="rect">
             <a:avLst/>
@@ -3044,44 +3208,44 @@
           <a:bodyPr wrap="square" rtlCol="0" anchor="ctr"/>
           <a:lstStyle/>
           <a:p>
-            <a:pPr algn="ctr" indent="0" marL="0">
-              <a:buNone/>
-            </a:pPr>
-            <a:r>
-              <a:rPr lang="en-US" sz="1300" b="1" dirty="0">
-                <a:solidFill>
-                  <a:srgbClr val="FFFFFF"/>
-                </a:solidFill>
-                <a:latin typeface="Arial" pitchFamily="34" charset="0"/>
-                <a:ea typeface="Arial" pitchFamily="34" charset="-122"/>
-                <a:cs typeface="Arial" pitchFamily="34" charset="-120"/>
-              </a:rPr>
-              <a:t>2. Docker Compose</a:t>
-            </a:r>
-            <a:endParaRPr lang="en-US" sz="1300" dirty="0"/>
-          </a:p>
-        </p:txBody>
-      </p:sp>
-      <p:sp>
-        <p:nvSpPr>
-          <p:cNvPr id="15" name="Shape 13"/>
-          <p:cNvSpPr/>
-          <p:nvPr/>
-        </p:nvSpPr>
-        <p:spPr>
-          <a:xfrm>
-            <a:off x="6217006" y="2194560"/>
-            <a:ext cx="5728716" cy="1577340"/>
-          </a:xfrm>
-          <a:prstGeom prst="rect">
-            <a:avLst/>
-          </a:prstGeom>
-          <a:solidFill>
-            <a:srgbClr val="1E2A3A"/>
+            <a:pPr indent="0" marL="0">
+              <a:buNone/>
+            </a:pPr>
+            <a:r>
+              <a:rPr lang="en-US" sz="900" b="1" dirty="0">
+                <a:solidFill>
+                  <a:srgbClr val="00695C"/>
+                </a:solidFill>
+                <a:latin typeface="Arial" pitchFamily="34" charset="0"/>
+                <a:ea typeface="Arial" pitchFamily="34" charset="-122"/>
+                <a:cs typeface="Arial" pitchFamily="34" charset="-120"/>
+              </a:rPr>
+              <a:t>BC01-CP1 — Automatiser le provisioning</a:t>
+            </a:r>
+            <a:endParaRPr lang="en-US" sz="900" dirty="0"/>
+          </a:p>
+        </p:txBody>
+      </p:sp>
+      <p:sp>
+        <p:nvSpPr>
+          <p:cNvPr id="18" name="Shape 16"/>
+          <p:cNvSpPr/>
+          <p:nvPr/>
+        </p:nvSpPr>
+        <p:spPr>
+          <a:xfrm>
+            <a:off x="7557516" y="1851660"/>
+            <a:ext cx="4388206" cy="445313"/>
+          </a:xfrm>
+          <a:prstGeom prst="rect">
+            <a:avLst/>
+          </a:prstGeom>
+          <a:solidFill>
+            <a:srgbClr val="FFFFFF"/>
           </a:solidFill>
           <a:ln w="12700">
             <a:solidFill>
-              <a:srgbClr val="1E2A3A"/>
+              <a:srgbClr val="DDDDDD"/>
             </a:solidFill>
             <a:prstDash val="solid"/>
           </a:ln>
@@ -3089,14 +3253,14 @@
       </p:sp>
       <p:sp>
         <p:nvSpPr>
-          <p:cNvPr id="16" name="Text 14"/>
-          <p:cNvSpPr/>
-          <p:nvPr/>
-        </p:nvSpPr>
-        <p:spPr>
-          <a:xfrm>
-            <a:off x="6338621" y="2331720"/>
-            <a:ext cx="5484571" cy="411480"/>
+          <p:cNvPr id="19" name="Text 17"/>
+          <p:cNvSpPr/>
+          <p:nvPr/>
+        </p:nvSpPr>
+        <p:spPr>
+          <a:xfrm>
+            <a:off x="7618781" y="1851660"/>
+            <a:ext cx="4266590" cy="445313"/>
           </a:xfrm>
           <a:prstGeom prst="rect">
             <a:avLst/>
@@ -3112,30 +3276,80 @@
               <a:buNone/>
             </a:pPr>
             <a:r>
-              <a:rPr lang="en-US" sz="1000" dirty="0">
-                <a:solidFill>
-                  <a:srgbClr val="98D982"/>
-                </a:solidFill>
-                <a:latin typeface="Courier New" pitchFamily="34" charset="0"/>
-                <a:ea typeface="Courier New" pitchFamily="34" charset="-122"/>
-                <a:cs typeface="Courier New" pitchFamily="34" charset="-120"/>
-              </a:rPr>
-              <a:t>$ docker compose up -d</a:t>
-            </a:r>
-            <a:endParaRPr lang="en-US" sz="1000" dirty="0"/>
-          </a:p>
-        </p:txBody>
-      </p:sp>
-      <p:sp>
-        <p:nvSpPr>
-          <p:cNvPr id="17" name="Text 15"/>
-          <p:cNvSpPr/>
-          <p:nvPr/>
-        </p:nvSpPr>
-        <p:spPr>
-          <a:xfrm>
-            <a:off x="6338621" y="2811780"/>
-            <a:ext cx="5484571" cy="411480"/>
+              <a:rPr lang="en-US" sz="900" dirty="0">
+                <a:solidFill>
+                  <a:srgbClr val="333333"/>
+                </a:solidFill>
+                <a:latin typeface="Arial" pitchFamily="34" charset="0"/>
+                <a:ea typeface="Arial" pitchFamily="34" charset="-122"/>
+                <a:cs typeface="Arial" pitchFamily="34" charset="-120"/>
+              </a:rPr>
+              <a:t>vagrant up → VM Ubuntu opérationnelle</a:t>
+            </a:r>
+            <a:endParaRPr lang="en-US" sz="900" dirty="0"/>
+          </a:p>
+        </p:txBody>
+      </p:sp>
+      <p:sp>
+        <p:nvSpPr>
+          <p:cNvPr id="20" name="Shape 18"/>
+          <p:cNvSpPr/>
+          <p:nvPr/>
+        </p:nvSpPr>
+        <p:spPr>
+          <a:xfrm>
+            <a:off x="244145" y="2331720"/>
+            <a:ext cx="146304" cy="445313"/>
+          </a:xfrm>
+          <a:prstGeom prst="rect">
+            <a:avLst/>
+          </a:prstGeom>
+          <a:solidFill>
+            <a:srgbClr val="00695C"/>
+          </a:solidFill>
+          <a:ln w="12700">
+            <a:solidFill>
+              <a:srgbClr val="00695C"/>
+            </a:solidFill>
+            <a:prstDash val="solid"/>
+          </a:ln>
+        </p:spPr>
+      </p:sp>
+      <p:sp>
+        <p:nvSpPr>
+          <p:cNvPr id="21" name="Shape 19"/>
+          <p:cNvSpPr/>
+          <p:nvPr/>
+        </p:nvSpPr>
+        <p:spPr>
+          <a:xfrm>
+            <a:off x="390449" y="2331720"/>
+            <a:ext cx="2778862" cy="445313"/>
+          </a:xfrm>
+          <a:prstGeom prst="rect">
+            <a:avLst/>
+          </a:prstGeom>
+          <a:solidFill>
+            <a:srgbClr val="F0F4FF"/>
+          </a:solidFill>
+          <a:ln w="12700">
+            <a:solidFill>
+              <a:srgbClr val="DDDDDD"/>
+            </a:solidFill>
+            <a:prstDash val="solid"/>
+          </a:ln>
+        </p:spPr>
+      </p:sp>
+      <p:sp>
+        <p:nvSpPr>
+          <p:cNvPr id="22" name="Text 20"/>
+          <p:cNvSpPr/>
+          <p:nvPr/>
+        </p:nvSpPr>
+        <p:spPr>
+          <a:xfrm>
+            <a:off x="427025" y="2331720"/>
+            <a:ext cx="2681021" cy="445313"/>
           </a:xfrm>
           <a:prstGeom prst="rect">
             <a:avLst/>
@@ -3151,30 +3365,55 @@
               <a:buNone/>
             </a:pPr>
             <a:r>
-              <a:rPr lang="en-US" sz="1000" dirty="0">
-                <a:solidFill>
-                  <a:srgbClr val="98D982"/>
-                </a:solidFill>
-                <a:latin typeface="Courier New" pitchFamily="34" charset="0"/>
-                <a:ea typeface="Courier New" pitchFamily="34" charset="-122"/>
-                <a:cs typeface="Courier New" pitchFamily="34" charset="-120"/>
-              </a:rPr>
-              <a:t>$ docker compose ps</a:t>
-            </a:r>
-            <a:endParaRPr lang="en-US" sz="1000" dirty="0"/>
-          </a:p>
-        </p:txBody>
-      </p:sp>
-      <p:sp>
-        <p:nvSpPr>
-          <p:cNvPr id="18" name="Text 16"/>
-          <p:cNvSpPr/>
-          <p:nvPr/>
-        </p:nvSpPr>
-        <p:spPr>
-          <a:xfrm>
-            <a:off x="6338621" y="3291840"/>
-            <a:ext cx="5484571" cy="411480"/>
+              <a:rPr lang="en-US" sz="900" b="1" dirty="0">
+                <a:solidFill>
+                  <a:srgbClr val="222222"/>
+                </a:solidFill>
+                <a:latin typeface="Arial" pitchFamily="34" charset="0"/>
+                <a:ea typeface="Arial" pitchFamily="34" charset="-122"/>
+                <a:cs typeface="Arial" pitchFamily="34" charset="-120"/>
+              </a:rPr>
+              <a:t>Ansible roles + Terraform</a:t>
+            </a:r>
+            <a:endParaRPr lang="en-US" sz="900" dirty="0"/>
+          </a:p>
+        </p:txBody>
+      </p:sp>
+      <p:sp>
+        <p:nvSpPr>
+          <p:cNvPr id="23" name="Shape 21"/>
+          <p:cNvSpPr/>
+          <p:nvPr/>
+        </p:nvSpPr>
+        <p:spPr>
+          <a:xfrm>
+            <a:off x="3290926" y="2331720"/>
+            <a:ext cx="4144061" cy="445313"/>
+          </a:xfrm>
+          <a:prstGeom prst="rect">
+            <a:avLst/>
+          </a:prstGeom>
+          <a:solidFill>
+            <a:srgbClr val="F0F4FF"/>
+          </a:solidFill>
+          <a:ln w="12700">
+            <a:solidFill>
+              <a:srgbClr val="DDDDDD"/>
+            </a:solidFill>
+            <a:prstDash val="solid"/>
+          </a:ln>
+        </p:spPr>
+      </p:sp>
+      <p:sp>
+        <p:nvSpPr>
+          <p:cNvPr id="24" name="Text 22"/>
+          <p:cNvSpPr/>
+          <p:nvPr/>
+        </p:nvSpPr>
+        <p:spPr>
+          <a:xfrm>
+            <a:off x="3352190" y="2331720"/>
+            <a:ext cx="4022446" cy="445313"/>
           </a:xfrm>
           <a:prstGeom prst="rect">
             <a:avLst/>
@@ -3190,30 +3429,528 @@
               <a:buNone/>
             </a:pPr>
             <a:r>
-              <a:rPr lang="en-US" sz="1000" dirty="0">
-                <a:solidFill>
-                  <a:srgbClr val="98D982"/>
-                </a:solidFill>
-                <a:latin typeface="Courier New" pitchFamily="34" charset="0"/>
-                <a:ea typeface="Courier New" pitchFamily="34" charset="-122"/>
-                <a:cs typeface="Courier New" pitchFamily="34" charset="-120"/>
-              </a:rPr>
-              <a:t>$ curl http://localhost:80</a:t>
-            </a:r>
-            <a:endParaRPr lang="en-US" sz="1000" dirty="0"/>
-          </a:p>
-        </p:txBody>
-      </p:sp>
-      <p:sp>
-        <p:nvSpPr>
-          <p:cNvPr id="19" name="Shape 17"/>
-          <p:cNvSpPr/>
-          <p:nvPr/>
-        </p:nvSpPr>
-        <p:spPr>
-          <a:xfrm>
-            <a:off x="244145" y="3909060"/>
-            <a:ext cx="5728716" cy="685800"/>
+              <a:rPr lang="en-US" sz="900" b="1" dirty="0">
+                <a:solidFill>
+                  <a:srgbClr val="00695C"/>
+                </a:solidFill>
+                <a:latin typeface="Arial" pitchFamily="34" charset="0"/>
+                <a:ea typeface="Arial" pitchFamily="34" charset="-122"/>
+                <a:cs typeface="Arial" pitchFamily="34" charset="-120"/>
+              </a:rPr>
+              <a:t>BC01-CP2 — Infrastructure as Code</a:t>
+            </a:r>
+            <a:endParaRPr lang="en-US" sz="900" dirty="0"/>
+          </a:p>
+        </p:txBody>
+      </p:sp>
+      <p:sp>
+        <p:nvSpPr>
+          <p:cNvPr id="25" name="Shape 23"/>
+          <p:cNvSpPr/>
+          <p:nvPr/>
+        </p:nvSpPr>
+        <p:spPr>
+          <a:xfrm>
+            <a:off x="7557516" y="2331720"/>
+            <a:ext cx="4388206" cy="445313"/>
+          </a:xfrm>
+          <a:prstGeom prst="rect">
+            <a:avLst/>
+          </a:prstGeom>
+          <a:solidFill>
+            <a:srgbClr val="F0F4FF"/>
+          </a:solidFill>
+          <a:ln w="12700">
+            <a:solidFill>
+              <a:srgbClr val="DDDDDD"/>
+            </a:solidFill>
+            <a:prstDash val="solid"/>
+          </a:ln>
+        </p:spPr>
+      </p:sp>
+      <p:sp>
+        <p:nvSpPr>
+          <p:cNvPr id="26" name="Text 24"/>
+          <p:cNvSpPr/>
+          <p:nvPr/>
+        </p:nvSpPr>
+        <p:spPr>
+          <a:xfrm>
+            <a:off x="7618781" y="2331720"/>
+            <a:ext cx="4266590" cy="445313"/>
+          </a:xfrm>
+          <a:prstGeom prst="rect">
+            <a:avLst/>
+          </a:prstGeom>
+          <a:noFill/>
+          <a:ln/>
+        </p:spPr>
+        <p:txBody>
+          <a:bodyPr wrap="square" rtlCol="0" anchor="ctr"/>
+          <a:lstStyle/>
+          <a:p>
+            <a:pPr indent="0" marL="0">
+              <a:buNone/>
+            </a:pPr>
+            <a:r>
+              <a:rPr lang="en-US" sz="900" dirty="0">
+                <a:solidFill>
+                  <a:srgbClr val="333333"/>
+                </a:solidFill>
+                <a:latin typeface="Arial" pitchFamily="34" charset="0"/>
+                <a:ea typeface="Arial" pitchFamily="34" charset="-122"/>
+                <a:cs typeface="Arial" pitchFamily="34" charset="-120"/>
+              </a:rPr>
+              <a:t>ansible/roles/ + terraform apply → hosts.ini</a:t>
+            </a:r>
+            <a:endParaRPr lang="en-US" sz="900" dirty="0"/>
+          </a:p>
+        </p:txBody>
+      </p:sp>
+      <p:sp>
+        <p:nvSpPr>
+          <p:cNvPr id="27" name="Shape 25"/>
+          <p:cNvSpPr/>
+          <p:nvPr/>
+        </p:nvSpPr>
+        <p:spPr>
+          <a:xfrm>
+            <a:off x="244145" y="2811780"/>
+            <a:ext cx="146304" cy="445313"/>
+          </a:xfrm>
+          <a:prstGeom prst="rect">
+            <a:avLst/>
+          </a:prstGeom>
+          <a:solidFill>
+            <a:srgbClr val="00695C"/>
+          </a:solidFill>
+          <a:ln w="12700">
+            <a:solidFill>
+              <a:srgbClr val="00695C"/>
+            </a:solidFill>
+            <a:prstDash val="solid"/>
+          </a:ln>
+        </p:spPr>
+      </p:sp>
+      <p:sp>
+        <p:nvSpPr>
+          <p:cNvPr id="28" name="Shape 26"/>
+          <p:cNvSpPr/>
+          <p:nvPr/>
+        </p:nvSpPr>
+        <p:spPr>
+          <a:xfrm>
+            <a:off x="390449" y="2811780"/>
+            <a:ext cx="2778862" cy="445313"/>
+          </a:xfrm>
+          <a:prstGeom prst="rect">
+            <a:avLst/>
+          </a:prstGeom>
+          <a:solidFill>
+            <a:srgbClr val="FFFFFF"/>
+          </a:solidFill>
+          <a:ln w="12700">
+            <a:solidFill>
+              <a:srgbClr val="DDDDDD"/>
+            </a:solidFill>
+            <a:prstDash val="solid"/>
+          </a:ln>
+        </p:spPr>
+      </p:sp>
+      <p:sp>
+        <p:nvSpPr>
+          <p:cNvPr id="29" name="Text 27"/>
+          <p:cNvSpPr/>
+          <p:nvPr/>
+        </p:nvSpPr>
+        <p:spPr>
+          <a:xfrm>
+            <a:off x="427025" y="2811780"/>
+            <a:ext cx="2681021" cy="445313"/>
+          </a:xfrm>
+          <a:prstGeom prst="rect">
+            <a:avLst/>
+          </a:prstGeom>
+          <a:noFill/>
+          <a:ln/>
+        </p:spPr>
+        <p:txBody>
+          <a:bodyPr wrap="square" rtlCol="0" anchor="ctr"/>
+          <a:lstStyle/>
+          <a:p>
+            <a:pPr indent="0" marL="0">
+              <a:buNone/>
+            </a:pPr>
+            <a:r>
+              <a:rPr lang="en-US" sz="900" b="1" dirty="0">
+                <a:solidFill>
+                  <a:srgbClr val="222222"/>
+                </a:solidFill>
+                <a:latin typeface="Arial" pitchFamily="34" charset="0"/>
+                <a:ea typeface="Arial" pitchFamily="34" charset="-122"/>
+                <a:cs typeface="Arial" pitchFamily="34" charset="-120"/>
+              </a:rPr>
+              <a:t>UFW + SSH hardening + K8s Secrets</a:t>
+            </a:r>
+            <a:endParaRPr lang="en-US" sz="900" dirty="0"/>
+          </a:p>
+        </p:txBody>
+      </p:sp>
+      <p:sp>
+        <p:nvSpPr>
+          <p:cNvPr id="30" name="Shape 28"/>
+          <p:cNvSpPr/>
+          <p:nvPr/>
+        </p:nvSpPr>
+        <p:spPr>
+          <a:xfrm>
+            <a:off x="3290926" y="2811780"/>
+            <a:ext cx="4144061" cy="445313"/>
+          </a:xfrm>
+          <a:prstGeom prst="rect">
+            <a:avLst/>
+          </a:prstGeom>
+          <a:solidFill>
+            <a:srgbClr val="FFFFFF"/>
+          </a:solidFill>
+          <a:ln w="12700">
+            <a:solidFill>
+              <a:srgbClr val="DDDDDD"/>
+            </a:solidFill>
+            <a:prstDash val="solid"/>
+          </a:ln>
+        </p:spPr>
+      </p:sp>
+      <p:sp>
+        <p:nvSpPr>
+          <p:cNvPr id="31" name="Text 29"/>
+          <p:cNvSpPr/>
+          <p:nvPr/>
+        </p:nvSpPr>
+        <p:spPr>
+          <a:xfrm>
+            <a:off x="3352190" y="2811780"/>
+            <a:ext cx="4022446" cy="445313"/>
+          </a:xfrm>
+          <a:prstGeom prst="rect">
+            <a:avLst/>
+          </a:prstGeom>
+          <a:noFill/>
+          <a:ln/>
+        </p:spPr>
+        <p:txBody>
+          <a:bodyPr wrap="square" rtlCol="0" anchor="ctr"/>
+          <a:lstStyle/>
+          <a:p>
+            <a:pPr indent="0" marL="0">
+              <a:buNone/>
+            </a:pPr>
+            <a:r>
+              <a:rPr lang="en-US" sz="900" b="1" dirty="0">
+                <a:solidFill>
+                  <a:srgbClr val="00695C"/>
+                </a:solidFill>
+                <a:latin typeface="Arial" pitchFamily="34" charset="0"/>
+                <a:ea typeface="Arial" pitchFamily="34" charset="-122"/>
+                <a:cs typeface="Arial" pitchFamily="34" charset="-120"/>
+              </a:rPr>
+              <a:t>BC01-CP3 — Sécuriser l'infrastructure</a:t>
+            </a:r>
+            <a:endParaRPr lang="en-US" sz="900" dirty="0"/>
+          </a:p>
+        </p:txBody>
+      </p:sp>
+      <p:sp>
+        <p:nvSpPr>
+          <p:cNvPr id="32" name="Shape 30"/>
+          <p:cNvSpPr/>
+          <p:nvPr/>
+        </p:nvSpPr>
+        <p:spPr>
+          <a:xfrm>
+            <a:off x="7557516" y="2811780"/>
+            <a:ext cx="4388206" cy="445313"/>
+          </a:xfrm>
+          <a:prstGeom prst="rect">
+            <a:avLst/>
+          </a:prstGeom>
+          <a:solidFill>
+            <a:srgbClr val="FFFFFF"/>
+          </a:solidFill>
+          <a:ln w="12700">
+            <a:solidFill>
+              <a:srgbClr val="DDDDDD"/>
+            </a:solidFill>
+            <a:prstDash val="solid"/>
+          </a:ln>
+        </p:spPr>
+      </p:sp>
+      <p:sp>
+        <p:nvSpPr>
+          <p:cNvPr id="33" name="Text 31"/>
+          <p:cNvSpPr/>
+          <p:nvPr/>
+        </p:nvSpPr>
+        <p:spPr>
+          <a:xfrm>
+            <a:off x="7618781" y="2811780"/>
+            <a:ext cx="4266590" cy="445313"/>
+          </a:xfrm>
+          <a:prstGeom prst="rect">
+            <a:avLst/>
+          </a:prstGeom>
+          <a:noFill/>
+          <a:ln/>
+        </p:spPr>
+        <p:txBody>
+          <a:bodyPr wrap="square" rtlCol="0" anchor="ctr"/>
+          <a:lstStyle/>
+          <a:p>
+            <a:pPr indent="0" marL="0">
+              <a:buNone/>
+            </a:pPr>
+            <a:r>
+              <a:rPr lang="en-US" sz="900" dirty="0">
+                <a:solidFill>
+                  <a:srgbClr val="333333"/>
+                </a:solidFill>
+                <a:latin typeface="Arial" pitchFamily="34" charset="0"/>
+                <a:ea typeface="Arial" pitchFamily="34" charset="-122"/>
+                <a:cs typeface="Arial" pitchFamily="34" charset="-120"/>
+              </a:rPr>
+              <a:t>PermitRootLogin no · deny all UFW · .gitignore</a:t>
+            </a:r>
+            <a:endParaRPr lang="en-US" sz="900" dirty="0"/>
+          </a:p>
+        </p:txBody>
+      </p:sp>
+      <p:sp>
+        <p:nvSpPr>
+          <p:cNvPr id="34" name="Shape 32"/>
+          <p:cNvSpPr/>
+          <p:nvPr/>
+        </p:nvSpPr>
+        <p:spPr>
+          <a:xfrm>
+            <a:off x="244145" y="3291840"/>
+            <a:ext cx="146304" cy="445313"/>
+          </a:xfrm>
+          <a:prstGeom prst="rect">
+            <a:avLst/>
+          </a:prstGeom>
+          <a:solidFill>
+            <a:srgbClr val="00695C"/>
+          </a:solidFill>
+          <a:ln w="12700">
+            <a:solidFill>
+              <a:srgbClr val="00695C"/>
+            </a:solidFill>
+            <a:prstDash val="solid"/>
+          </a:ln>
+        </p:spPr>
+      </p:sp>
+      <p:sp>
+        <p:nvSpPr>
+          <p:cNvPr id="35" name="Shape 33"/>
+          <p:cNvSpPr/>
+          <p:nvPr/>
+        </p:nvSpPr>
+        <p:spPr>
+          <a:xfrm>
+            <a:off x="390449" y="3291840"/>
+            <a:ext cx="2778862" cy="445313"/>
+          </a:xfrm>
+          <a:prstGeom prst="rect">
+            <a:avLst/>
+          </a:prstGeom>
+          <a:solidFill>
+            <a:srgbClr val="F0F4FF"/>
+          </a:solidFill>
+          <a:ln w="12700">
+            <a:solidFill>
+              <a:srgbClr val="DDDDDD"/>
+            </a:solidFill>
+            <a:prstDash val="solid"/>
+          </a:ln>
+        </p:spPr>
+      </p:sp>
+      <p:sp>
+        <p:nvSpPr>
+          <p:cNvPr id="36" name="Text 34"/>
+          <p:cNvSpPr/>
+          <p:nvPr/>
+        </p:nvSpPr>
+        <p:spPr>
+          <a:xfrm>
+            <a:off x="427025" y="3291840"/>
+            <a:ext cx="2681021" cy="445313"/>
+          </a:xfrm>
+          <a:prstGeom prst="rect">
+            <a:avLst/>
+          </a:prstGeom>
+          <a:noFill/>
+          <a:ln/>
+        </p:spPr>
+        <p:txBody>
+          <a:bodyPr wrap="square" rtlCol="0" anchor="ctr"/>
+          <a:lstStyle/>
+          <a:p>
+            <a:pPr indent="0" marL="0">
+              <a:buNone/>
+            </a:pPr>
+            <a:r>
+              <a:rPr lang="en-US" sz="900" b="1" dirty="0">
+                <a:solidFill>
+                  <a:srgbClr val="222222"/>
+                </a:solidFill>
+                <a:latin typeface="Arial" pitchFamily="34" charset="0"/>
+                <a:ea typeface="Arial" pitchFamily="34" charset="-122"/>
+                <a:cs typeface="Arial" pitchFamily="34" charset="-120"/>
+              </a:rPr>
+              <a:t>Vagrant + Kubernetes manifests</a:t>
+            </a:r>
+            <a:endParaRPr lang="en-US" sz="900" dirty="0"/>
+          </a:p>
+        </p:txBody>
+      </p:sp>
+      <p:sp>
+        <p:nvSpPr>
+          <p:cNvPr id="37" name="Shape 35"/>
+          <p:cNvSpPr/>
+          <p:nvPr/>
+        </p:nvSpPr>
+        <p:spPr>
+          <a:xfrm>
+            <a:off x="3290926" y="3291840"/>
+            <a:ext cx="4144061" cy="445313"/>
+          </a:xfrm>
+          <a:prstGeom prst="rect">
+            <a:avLst/>
+          </a:prstGeom>
+          <a:solidFill>
+            <a:srgbClr val="F0F4FF"/>
+          </a:solidFill>
+          <a:ln w="12700">
+            <a:solidFill>
+              <a:srgbClr val="DDDDDD"/>
+            </a:solidFill>
+            <a:prstDash val="solid"/>
+          </a:ln>
+        </p:spPr>
+      </p:sp>
+      <p:sp>
+        <p:nvSpPr>
+          <p:cNvPr id="38" name="Text 36"/>
+          <p:cNvSpPr/>
+          <p:nvPr/>
+        </p:nvSpPr>
+        <p:spPr>
+          <a:xfrm>
+            <a:off x="3352190" y="3291840"/>
+            <a:ext cx="4022446" cy="445313"/>
+          </a:xfrm>
+          <a:prstGeom prst="rect">
+            <a:avLst/>
+          </a:prstGeom>
+          <a:noFill/>
+          <a:ln/>
+        </p:spPr>
+        <p:txBody>
+          <a:bodyPr wrap="square" rtlCol="0" anchor="ctr"/>
+          <a:lstStyle/>
+          <a:p>
+            <a:pPr indent="0" marL="0">
+              <a:buNone/>
+            </a:pPr>
+            <a:r>
+              <a:rPr lang="en-US" sz="900" b="1" dirty="0">
+                <a:solidFill>
+                  <a:srgbClr val="00695C"/>
+                </a:solidFill>
+                <a:latin typeface="Arial" pitchFamily="34" charset="0"/>
+                <a:ea typeface="Arial" pitchFamily="34" charset="-122"/>
+                <a:cs typeface="Arial" pitchFamily="34" charset="-120"/>
+              </a:rPr>
+              <a:t>BC01-CP4 — Mettre en production</a:t>
+            </a:r>
+            <a:endParaRPr lang="en-US" sz="900" dirty="0"/>
+          </a:p>
+        </p:txBody>
+      </p:sp>
+      <p:sp>
+        <p:nvSpPr>
+          <p:cNvPr id="39" name="Shape 37"/>
+          <p:cNvSpPr/>
+          <p:nvPr/>
+        </p:nvSpPr>
+        <p:spPr>
+          <a:xfrm>
+            <a:off x="7557516" y="3291840"/>
+            <a:ext cx="4388206" cy="445313"/>
+          </a:xfrm>
+          <a:prstGeom prst="rect">
+            <a:avLst/>
+          </a:prstGeom>
+          <a:solidFill>
+            <a:srgbClr val="F0F4FF"/>
+          </a:solidFill>
+          <a:ln w="12700">
+            <a:solidFill>
+              <a:srgbClr val="DDDDDD"/>
+            </a:solidFill>
+            <a:prstDash val="solid"/>
+          </a:ln>
+        </p:spPr>
+      </p:sp>
+      <p:sp>
+        <p:nvSpPr>
+          <p:cNvPr id="40" name="Text 38"/>
+          <p:cNvSpPr/>
+          <p:nvPr/>
+        </p:nvSpPr>
+        <p:spPr>
+          <a:xfrm>
+            <a:off x="7618781" y="3291840"/>
+            <a:ext cx="4266590" cy="445313"/>
+          </a:xfrm>
+          <a:prstGeom prst="rect">
+            <a:avLst/>
+          </a:prstGeom>
+          <a:noFill/>
+          <a:ln/>
+        </p:spPr>
+        <p:txBody>
+          <a:bodyPr wrap="square" rtlCol="0" anchor="ctr"/>
+          <a:lstStyle/>
+          <a:p>
+            <a:pPr indent="0" marL="0">
+              <a:buNone/>
+            </a:pPr>
+            <a:r>
+              <a:rPr lang="en-US" sz="900" dirty="0">
+                <a:solidFill>
+                  <a:srgbClr val="333333"/>
+                </a:solidFill>
+                <a:latin typeface="Arial" pitchFamily="34" charset="0"/>
+                <a:ea typeface="Arial" pitchFamily="34" charset="-122"/>
+                <a:cs typeface="Arial" pitchFamily="34" charset="-120"/>
+              </a:rPr>
+              <a:t>Vagrantfile versionné + kubectl apply -f k8s/</a:t>
+            </a:r>
+            <a:endParaRPr lang="en-US" sz="900" dirty="0"/>
+          </a:p>
+        </p:txBody>
+      </p:sp>
+      <p:sp>
+        <p:nvSpPr>
+          <p:cNvPr id="41" name="Shape 39"/>
+          <p:cNvSpPr/>
+          <p:nvPr/>
+        </p:nvSpPr>
+        <p:spPr>
+          <a:xfrm>
+            <a:off x="244145" y="3771900"/>
+            <a:ext cx="146304" cy="445313"/>
           </a:xfrm>
           <a:prstGeom prst="rect">
             <a:avLst/>
@@ -3231,63 +3968,24 @@
       </p:sp>
       <p:sp>
         <p:nvSpPr>
-          <p:cNvPr id="20" name="Text 18"/>
-          <p:cNvSpPr/>
-          <p:nvPr/>
-        </p:nvSpPr>
-        <p:spPr>
-          <a:xfrm>
-            <a:off x="244145" y="3909060"/>
-            <a:ext cx="5728716" cy="685800"/>
-          </a:xfrm>
-          <a:prstGeom prst="rect">
-            <a:avLst/>
-          </a:prstGeom>
-          <a:noFill/>
-          <a:ln/>
-        </p:spPr>
-        <p:txBody>
-          <a:bodyPr wrap="square" rtlCol="0" anchor="ctr"/>
-          <a:lstStyle/>
-          <a:p>
-            <a:pPr algn="ctr" indent="0" marL="0">
-              <a:buNone/>
-            </a:pPr>
-            <a:r>
-              <a:rPr lang="en-US" sz="1300" b="1" dirty="0">
-                <a:solidFill>
-                  <a:srgbClr val="FFFFFF"/>
-                </a:solidFill>
-                <a:latin typeface="Arial" pitchFamily="34" charset="0"/>
-                <a:ea typeface="Arial" pitchFamily="34" charset="-122"/>
-                <a:cs typeface="Arial" pitchFamily="34" charset="-120"/>
-              </a:rPr>
-              <a:t>3. Kubernetes</a:t>
-            </a:r>
-            <a:endParaRPr lang="en-US" sz="1300" dirty="0"/>
-          </a:p>
-        </p:txBody>
-      </p:sp>
-      <p:sp>
-        <p:nvSpPr>
-          <p:cNvPr id="21" name="Shape 19"/>
-          <p:cNvSpPr/>
-          <p:nvPr/>
-        </p:nvSpPr>
-        <p:spPr>
-          <a:xfrm>
-            <a:off x="244145" y="4594860"/>
-            <a:ext cx="5728716" cy="1577340"/>
-          </a:xfrm>
-          <a:prstGeom prst="rect">
-            <a:avLst/>
-          </a:prstGeom>
-          <a:solidFill>
-            <a:srgbClr val="1E2A3A"/>
+          <p:cNvPr id="42" name="Shape 40"/>
+          <p:cNvSpPr/>
+          <p:nvPr/>
+        </p:nvSpPr>
+        <p:spPr>
+          <a:xfrm>
+            <a:off x="390449" y="3771900"/>
+            <a:ext cx="2778862" cy="445313"/>
+          </a:xfrm>
+          <a:prstGeom prst="rect">
+            <a:avLst/>
+          </a:prstGeom>
+          <a:solidFill>
+            <a:srgbClr val="FFFFFF"/>
           </a:solidFill>
           <a:ln w="12700">
             <a:solidFill>
-              <a:srgbClr val="1E2A3A"/>
+              <a:srgbClr val="DDDDDD"/>
             </a:solidFill>
             <a:prstDash val="solid"/>
           </a:ln>
@@ -3295,14 +3993,14 @@
       </p:sp>
       <p:sp>
         <p:nvSpPr>
-          <p:cNvPr id="22" name="Text 20"/>
-          <p:cNvSpPr/>
-          <p:nvPr/>
-        </p:nvSpPr>
-        <p:spPr>
-          <a:xfrm>
-            <a:off x="365760" y="4732020"/>
-            <a:ext cx="5484571" cy="411480"/>
+          <p:cNvPr id="43" name="Text 41"/>
+          <p:cNvSpPr/>
+          <p:nvPr/>
+        </p:nvSpPr>
+        <p:spPr>
+          <a:xfrm>
+            <a:off x="427025" y="3771900"/>
+            <a:ext cx="2681021" cy="445313"/>
           </a:xfrm>
           <a:prstGeom prst="rect">
             <a:avLst/>
@@ -3318,30 +4016,55 @@
               <a:buNone/>
             </a:pPr>
             <a:r>
-              <a:rPr lang="en-US" sz="1000" dirty="0">
-                <a:solidFill>
-                  <a:srgbClr val="98D982"/>
-                </a:solidFill>
-                <a:latin typeface="Courier New" pitchFamily="34" charset="0"/>
-                <a:ea typeface="Courier New" pitchFamily="34" charset="-122"/>
-                <a:cs typeface="Courier New" pitchFamily="34" charset="-120"/>
-              </a:rPr>
-              <a:t>$ kubectl apply -f k8s/</a:t>
-            </a:r>
-            <a:endParaRPr lang="en-US" sz="1000" dirty="0"/>
-          </a:p>
-        </p:txBody>
-      </p:sp>
-      <p:sp>
-        <p:nvSpPr>
-          <p:cNvPr id="23" name="Text 21"/>
-          <p:cNvSpPr/>
-          <p:nvPr/>
-        </p:nvSpPr>
-        <p:spPr>
-          <a:xfrm>
-            <a:off x="365760" y="5212080"/>
-            <a:ext cx="5484571" cy="411480"/>
+              <a:rPr lang="en-US" sz="900" b="1" dirty="0">
+                <a:solidFill>
+                  <a:srgbClr val="222222"/>
+                </a:solidFill>
+                <a:latin typeface="Arial" pitchFamily="34" charset="0"/>
+                <a:ea typeface="Arial" pitchFamily="34" charset="-122"/>
+                <a:cs typeface="Arial" pitchFamily="34" charset="-120"/>
+              </a:rPr>
+              <a:t>Docker Compose (6 services)</a:t>
+            </a:r>
+            <a:endParaRPr lang="en-US" sz="900" dirty="0"/>
+          </a:p>
+        </p:txBody>
+      </p:sp>
+      <p:sp>
+        <p:nvSpPr>
+          <p:cNvPr id="44" name="Shape 42"/>
+          <p:cNvSpPr/>
+          <p:nvPr/>
+        </p:nvSpPr>
+        <p:spPr>
+          <a:xfrm>
+            <a:off x="3290926" y="3771900"/>
+            <a:ext cx="4144061" cy="445313"/>
+          </a:xfrm>
+          <a:prstGeom prst="rect">
+            <a:avLst/>
+          </a:prstGeom>
+          <a:solidFill>
+            <a:srgbClr val="FFFFFF"/>
+          </a:solidFill>
+          <a:ln w="12700">
+            <a:solidFill>
+              <a:srgbClr val="DDDDDD"/>
+            </a:solidFill>
+            <a:prstDash val="solid"/>
+          </a:ln>
+        </p:spPr>
+      </p:sp>
+      <p:sp>
+        <p:nvSpPr>
+          <p:cNvPr id="45" name="Text 43"/>
+          <p:cNvSpPr/>
+          <p:nvPr/>
+        </p:nvSpPr>
+        <p:spPr>
+          <a:xfrm>
+            <a:off x="3352190" y="3771900"/>
+            <a:ext cx="4022446" cy="445313"/>
           </a:xfrm>
           <a:prstGeom prst="rect">
             <a:avLst/>
@@ -3357,30 +4080,55 @@
               <a:buNone/>
             </a:pPr>
             <a:r>
-              <a:rPr lang="en-US" sz="1000" dirty="0">
-                <a:solidFill>
-                  <a:srgbClr val="98D982"/>
-                </a:solidFill>
-                <a:latin typeface="Courier New" pitchFamily="34" charset="0"/>
-                <a:ea typeface="Courier New" pitchFamily="34" charset="-122"/>
-                <a:cs typeface="Courier New" pitchFamily="34" charset="-120"/>
-              </a:rPr>
-              <a:t>$ kubectl get pods,svc,hpa</a:t>
-            </a:r>
-            <a:endParaRPr lang="en-US" sz="1000" dirty="0"/>
-          </a:p>
-        </p:txBody>
-      </p:sp>
-      <p:sp>
-        <p:nvSpPr>
-          <p:cNvPr id="24" name="Text 22"/>
-          <p:cNvSpPr/>
-          <p:nvPr/>
-        </p:nvSpPr>
-        <p:spPr>
-          <a:xfrm>
-            <a:off x="365760" y="5692140"/>
-            <a:ext cx="5484571" cy="411480"/>
+              <a:rPr lang="en-US" sz="900" b="1" dirty="0">
+                <a:solidFill>
+                  <a:srgbClr val="4A148C"/>
+                </a:solidFill>
+                <a:latin typeface="Arial" pitchFamily="34" charset="0"/>
+                <a:ea typeface="Arial" pitchFamily="34" charset="-122"/>
+                <a:cs typeface="Arial" pitchFamily="34" charset="-120"/>
+              </a:rPr>
+              <a:t>BC02-CP1 — Environnement de test</a:t>
+            </a:r>
+            <a:endParaRPr lang="en-US" sz="900" dirty="0"/>
+          </a:p>
+        </p:txBody>
+      </p:sp>
+      <p:sp>
+        <p:nvSpPr>
+          <p:cNvPr id="46" name="Shape 44"/>
+          <p:cNvSpPr/>
+          <p:nvPr/>
+        </p:nvSpPr>
+        <p:spPr>
+          <a:xfrm>
+            <a:off x="7557516" y="3771900"/>
+            <a:ext cx="4388206" cy="445313"/>
+          </a:xfrm>
+          <a:prstGeom prst="rect">
+            <a:avLst/>
+          </a:prstGeom>
+          <a:solidFill>
+            <a:srgbClr val="FFFFFF"/>
+          </a:solidFill>
+          <a:ln w="12700">
+            <a:solidFill>
+              <a:srgbClr val="DDDDDD"/>
+            </a:solidFill>
+            <a:prstDash val="solid"/>
+          </a:ln>
+        </p:spPr>
+      </p:sp>
+      <p:sp>
+        <p:nvSpPr>
+          <p:cNvPr id="47" name="Text 45"/>
+          <p:cNvSpPr/>
+          <p:nvPr/>
+        </p:nvSpPr>
+        <p:spPr>
+          <a:xfrm>
+            <a:off x="7618781" y="3771900"/>
+            <a:ext cx="4266590" cy="445313"/>
           </a:xfrm>
           <a:prstGeom prst="rect">
             <a:avLst/>
@@ -3396,30 +4144,681 @@
               <a:buNone/>
             </a:pPr>
             <a:r>
-              <a:rPr lang="en-US" sz="1000" dirty="0">
-                <a:solidFill>
-                  <a:srgbClr val="98D982"/>
-                </a:solidFill>
-                <a:latin typeface="Courier New" pitchFamily="34" charset="0"/>
-                <a:ea typeface="Courier New" pitchFamily="34" charset="-122"/>
-                <a:cs typeface="Courier New" pitchFamily="34" charset="-120"/>
-              </a:rPr>
-              <a:t>$ kubectl get pvc</a:t>
-            </a:r>
-            <a:endParaRPr lang="en-US" sz="1000" dirty="0"/>
-          </a:p>
-        </p:txBody>
-      </p:sp>
-      <p:sp>
-        <p:nvSpPr>
-          <p:cNvPr id="25" name="Shape 23"/>
-          <p:cNvSpPr/>
-          <p:nvPr/>
-        </p:nvSpPr>
-        <p:spPr>
-          <a:xfrm>
-            <a:off x="6217006" y="3909060"/>
-            <a:ext cx="5728716" cy="685800"/>
+              <a:rPr lang="en-US" sz="900" dirty="0">
+                <a:solidFill>
+                  <a:srgbClr val="333333"/>
+                </a:solidFill>
+                <a:latin typeface="Arial" pitchFamily="34" charset="0"/>
+                <a:ea typeface="Arial" pitchFamily="34" charset="-122"/>
+                <a:cs typeface="Arial" pitchFamily="34" charset="-120"/>
+              </a:rPr>
+              <a:t>docker compose up -d → 6 conteneurs UP</a:t>
+            </a:r>
+            <a:endParaRPr lang="en-US" sz="900" dirty="0"/>
+          </a:p>
+        </p:txBody>
+      </p:sp>
+      <p:sp>
+        <p:nvSpPr>
+          <p:cNvPr id="48" name="Shape 46"/>
+          <p:cNvSpPr/>
+          <p:nvPr/>
+        </p:nvSpPr>
+        <p:spPr>
+          <a:xfrm>
+            <a:off x="244145" y="4251960"/>
+            <a:ext cx="146304" cy="445313"/>
+          </a:xfrm>
+          <a:prstGeom prst="rect">
+            <a:avLst/>
+          </a:prstGeom>
+          <a:solidFill>
+            <a:srgbClr val="4A148C"/>
+          </a:solidFill>
+          <a:ln w="12700">
+            <a:solidFill>
+              <a:srgbClr val="4A148C"/>
+            </a:solidFill>
+            <a:prstDash val="solid"/>
+          </a:ln>
+        </p:spPr>
+      </p:sp>
+      <p:sp>
+        <p:nvSpPr>
+          <p:cNvPr id="49" name="Shape 47"/>
+          <p:cNvSpPr/>
+          <p:nvPr/>
+        </p:nvSpPr>
+        <p:spPr>
+          <a:xfrm>
+            <a:off x="390449" y="4251960"/>
+            <a:ext cx="2778862" cy="445313"/>
+          </a:xfrm>
+          <a:prstGeom prst="rect">
+            <a:avLst/>
+          </a:prstGeom>
+          <a:solidFill>
+            <a:srgbClr val="F0F4FF"/>
+          </a:solidFill>
+          <a:ln w="12700">
+            <a:solidFill>
+              <a:srgbClr val="DDDDDD"/>
+            </a:solidFill>
+            <a:prstDash val="solid"/>
+          </a:ln>
+        </p:spPr>
+      </p:sp>
+      <p:sp>
+        <p:nvSpPr>
+          <p:cNvPr id="50" name="Text 48"/>
+          <p:cNvSpPr/>
+          <p:nvPr/>
+        </p:nvSpPr>
+        <p:spPr>
+          <a:xfrm>
+            <a:off x="427025" y="4251960"/>
+            <a:ext cx="2681021" cy="445313"/>
+          </a:xfrm>
+          <a:prstGeom prst="rect">
+            <a:avLst/>
+          </a:prstGeom>
+          <a:noFill/>
+          <a:ln/>
+        </p:spPr>
+        <p:txBody>
+          <a:bodyPr wrap="square" rtlCol="0" anchor="ctr"/>
+          <a:lstStyle/>
+          <a:p>
+            <a:pPr indent="0" marL="0">
+              <a:buNone/>
+            </a:pPr>
+            <a:r>
+              <a:rPr lang="en-US" sz="900" b="1" dirty="0">
+                <a:solidFill>
+                  <a:srgbClr val="222222"/>
+                </a:solidFill>
+                <a:latin typeface="Arial" pitchFamily="34" charset="0"/>
+                <a:ea typeface="Arial" pitchFamily="34" charset="-122"/>
+                <a:cs typeface="Arial" pitchFamily="34" charset="-120"/>
+              </a:rPr>
+              <a:t>PVC PostgreSQL + init_db/schema.sql</a:t>
+            </a:r>
+            <a:endParaRPr lang="en-US" sz="900" dirty="0"/>
+          </a:p>
+        </p:txBody>
+      </p:sp>
+      <p:sp>
+        <p:nvSpPr>
+          <p:cNvPr id="51" name="Shape 49"/>
+          <p:cNvSpPr/>
+          <p:nvPr/>
+        </p:nvSpPr>
+        <p:spPr>
+          <a:xfrm>
+            <a:off x="3290926" y="4251960"/>
+            <a:ext cx="4144061" cy="445313"/>
+          </a:xfrm>
+          <a:prstGeom prst="rect">
+            <a:avLst/>
+          </a:prstGeom>
+          <a:solidFill>
+            <a:srgbClr val="F0F4FF"/>
+          </a:solidFill>
+          <a:ln w="12700">
+            <a:solidFill>
+              <a:srgbClr val="DDDDDD"/>
+            </a:solidFill>
+            <a:prstDash val="solid"/>
+          </a:ln>
+        </p:spPr>
+      </p:sp>
+      <p:sp>
+        <p:nvSpPr>
+          <p:cNvPr id="52" name="Text 50"/>
+          <p:cNvSpPr/>
+          <p:nvPr/>
+        </p:nvSpPr>
+        <p:spPr>
+          <a:xfrm>
+            <a:off x="3352190" y="4251960"/>
+            <a:ext cx="4022446" cy="445313"/>
+          </a:xfrm>
+          <a:prstGeom prst="rect">
+            <a:avLst/>
+          </a:prstGeom>
+          <a:noFill/>
+          <a:ln/>
+        </p:spPr>
+        <p:txBody>
+          <a:bodyPr wrap="square" rtlCol="0" anchor="ctr"/>
+          <a:lstStyle/>
+          <a:p>
+            <a:pPr indent="0" marL="0">
+              <a:buNone/>
+            </a:pPr>
+            <a:r>
+              <a:rPr lang="en-US" sz="900" b="1" dirty="0">
+                <a:solidFill>
+                  <a:srgbClr val="4A148C"/>
+                </a:solidFill>
+                <a:latin typeface="Arial" pitchFamily="34" charset="0"/>
+                <a:ea typeface="Arial" pitchFamily="34" charset="-122"/>
+                <a:cs typeface="Arial" pitchFamily="34" charset="-120"/>
+              </a:rPr>
+              <a:t>BC02-CP2 — Stockage persistant</a:t>
+            </a:r>
+            <a:endParaRPr lang="en-US" sz="900" dirty="0"/>
+          </a:p>
+        </p:txBody>
+      </p:sp>
+      <p:sp>
+        <p:nvSpPr>
+          <p:cNvPr id="53" name="Shape 51"/>
+          <p:cNvSpPr/>
+          <p:nvPr/>
+        </p:nvSpPr>
+        <p:spPr>
+          <a:xfrm>
+            <a:off x="7557516" y="4251960"/>
+            <a:ext cx="4388206" cy="445313"/>
+          </a:xfrm>
+          <a:prstGeom prst="rect">
+            <a:avLst/>
+          </a:prstGeom>
+          <a:solidFill>
+            <a:srgbClr val="F0F4FF"/>
+          </a:solidFill>
+          <a:ln w="12700">
+            <a:solidFill>
+              <a:srgbClr val="DDDDDD"/>
+            </a:solidFill>
+            <a:prstDash val="solid"/>
+          </a:ln>
+        </p:spPr>
+      </p:sp>
+      <p:sp>
+        <p:nvSpPr>
+          <p:cNvPr id="54" name="Text 52"/>
+          <p:cNvSpPr/>
+          <p:nvPr/>
+        </p:nvSpPr>
+        <p:spPr>
+          <a:xfrm>
+            <a:off x="7618781" y="4251960"/>
+            <a:ext cx="4266590" cy="445313"/>
+          </a:xfrm>
+          <a:prstGeom prst="rect">
+            <a:avLst/>
+          </a:prstGeom>
+          <a:noFill/>
+          <a:ln/>
+        </p:spPr>
+        <p:txBody>
+          <a:bodyPr wrap="square" rtlCol="0" anchor="ctr"/>
+          <a:lstStyle/>
+          <a:p>
+            <a:pPr indent="0" marL="0">
+              <a:buNone/>
+            </a:pPr>
+            <a:r>
+              <a:rPr lang="en-US" sz="900" dirty="0">
+                <a:solidFill>
+                  <a:srgbClr val="333333"/>
+                </a:solidFill>
+                <a:latin typeface="Arial" pitchFamily="34" charset="0"/>
+                <a:ea typeface="Arial" pitchFamily="34" charset="-122"/>
+                <a:cs typeface="Arial" pitchFamily="34" charset="-120"/>
+              </a:rPr>
+              <a:t>PVC 1Gi · INSERT ON CONFLICT DO NOTHING</a:t>
+            </a:r>
+            <a:endParaRPr lang="en-US" sz="900" dirty="0"/>
+          </a:p>
+        </p:txBody>
+      </p:sp>
+      <p:sp>
+        <p:nvSpPr>
+          <p:cNvPr id="55" name="Shape 53"/>
+          <p:cNvSpPr/>
+          <p:nvPr/>
+        </p:nvSpPr>
+        <p:spPr>
+          <a:xfrm>
+            <a:off x="244145" y="4732020"/>
+            <a:ext cx="146304" cy="445313"/>
+          </a:xfrm>
+          <a:prstGeom prst="rect">
+            <a:avLst/>
+          </a:prstGeom>
+          <a:solidFill>
+            <a:srgbClr val="4A148C"/>
+          </a:solidFill>
+          <a:ln w="12700">
+            <a:solidFill>
+              <a:srgbClr val="4A148C"/>
+            </a:solidFill>
+            <a:prstDash val="solid"/>
+          </a:ln>
+        </p:spPr>
+      </p:sp>
+      <p:sp>
+        <p:nvSpPr>
+          <p:cNvPr id="56" name="Shape 54"/>
+          <p:cNvSpPr/>
+          <p:nvPr/>
+        </p:nvSpPr>
+        <p:spPr>
+          <a:xfrm>
+            <a:off x="390449" y="4732020"/>
+            <a:ext cx="2778862" cy="445313"/>
+          </a:xfrm>
+          <a:prstGeom prst="rect">
+            <a:avLst/>
+          </a:prstGeom>
+          <a:solidFill>
+            <a:srgbClr val="FFFFFF"/>
+          </a:solidFill>
+          <a:ln w="12700">
+            <a:solidFill>
+              <a:srgbClr val="DDDDDD"/>
+            </a:solidFill>
+            <a:prstDash val="solid"/>
+          </a:ln>
+        </p:spPr>
+      </p:sp>
+      <p:sp>
+        <p:nvSpPr>
+          <p:cNvPr id="57" name="Text 55"/>
+          <p:cNvSpPr/>
+          <p:nvPr/>
+        </p:nvSpPr>
+        <p:spPr>
+          <a:xfrm>
+            <a:off x="427025" y="4732020"/>
+            <a:ext cx="2681021" cy="445313"/>
+          </a:xfrm>
+          <a:prstGeom prst="rect">
+            <a:avLst/>
+          </a:prstGeom>
+          <a:noFill/>
+          <a:ln/>
+        </p:spPr>
+        <p:txBody>
+          <a:bodyPr wrap="square" rtlCol="0" anchor="ctr"/>
+          <a:lstStyle/>
+          <a:p>
+            <a:pPr indent="0" marL="0">
+              <a:buNone/>
+            </a:pPr>
+            <a:r>
+              <a:rPr lang="en-US" sz="900" b="1" dirty="0">
+                <a:solidFill>
+                  <a:srgbClr val="222222"/>
+                </a:solidFill>
+                <a:latin typeface="Arial" pitchFamily="34" charset="0"/>
+                <a:ea typeface="Arial" pitchFamily="34" charset="-122"/>
+                <a:cs typeface="Arial" pitchFamily="34" charset="-120"/>
+              </a:rPr>
+              <a:t>Dockerfile + image Docker Hub</a:t>
+            </a:r>
+            <a:endParaRPr lang="en-US" sz="900" dirty="0"/>
+          </a:p>
+        </p:txBody>
+      </p:sp>
+      <p:sp>
+        <p:nvSpPr>
+          <p:cNvPr id="58" name="Shape 56"/>
+          <p:cNvSpPr/>
+          <p:nvPr/>
+        </p:nvSpPr>
+        <p:spPr>
+          <a:xfrm>
+            <a:off x="3290926" y="4732020"/>
+            <a:ext cx="4144061" cy="445313"/>
+          </a:xfrm>
+          <a:prstGeom prst="rect">
+            <a:avLst/>
+          </a:prstGeom>
+          <a:solidFill>
+            <a:srgbClr val="FFFFFF"/>
+          </a:solidFill>
+          <a:ln w="12700">
+            <a:solidFill>
+              <a:srgbClr val="DDDDDD"/>
+            </a:solidFill>
+            <a:prstDash val="solid"/>
+          </a:ln>
+        </p:spPr>
+      </p:sp>
+      <p:sp>
+        <p:nvSpPr>
+          <p:cNvPr id="59" name="Text 57"/>
+          <p:cNvSpPr/>
+          <p:nvPr/>
+        </p:nvSpPr>
+        <p:spPr>
+          <a:xfrm>
+            <a:off x="3352190" y="4732020"/>
+            <a:ext cx="4022446" cy="445313"/>
+          </a:xfrm>
+          <a:prstGeom prst="rect">
+            <a:avLst/>
+          </a:prstGeom>
+          <a:noFill/>
+          <a:ln/>
+        </p:spPr>
+        <p:txBody>
+          <a:bodyPr wrap="square" rtlCol="0" anchor="ctr"/>
+          <a:lstStyle/>
+          <a:p>
+            <a:pPr indent="0" marL="0">
+              <a:buNone/>
+            </a:pPr>
+            <a:r>
+              <a:rPr lang="en-US" sz="900" b="1" dirty="0">
+                <a:solidFill>
+                  <a:srgbClr val="4A148C"/>
+                </a:solidFill>
+                <a:latin typeface="Arial" pitchFamily="34" charset="0"/>
+                <a:ea typeface="Arial" pitchFamily="34" charset="-122"/>
+                <a:cs typeface="Arial" pitchFamily="34" charset="-120"/>
+              </a:rPr>
+              <a:t>BC02-CP3 — Conteneuriser l'application</a:t>
+            </a:r>
+            <a:endParaRPr lang="en-US" sz="900" dirty="0"/>
+          </a:p>
+        </p:txBody>
+      </p:sp>
+      <p:sp>
+        <p:nvSpPr>
+          <p:cNvPr id="60" name="Shape 58"/>
+          <p:cNvSpPr/>
+          <p:nvPr/>
+        </p:nvSpPr>
+        <p:spPr>
+          <a:xfrm>
+            <a:off x="7557516" y="4732020"/>
+            <a:ext cx="4388206" cy="445313"/>
+          </a:xfrm>
+          <a:prstGeom prst="rect">
+            <a:avLst/>
+          </a:prstGeom>
+          <a:solidFill>
+            <a:srgbClr val="FFFFFF"/>
+          </a:solidFill>
+          <a:ln w="12700">
+            <a:solidFill>
+              <a:srgbClr val="DDDDDD"/>
+            </a:solidFill>
+            <a:prstDash val="solid"/>
+          </a:ln>
+        </p:spPr>
+      </p:sp>
+      <p:sp>
+        <p:nvSpPr>
+          <p:cNvPr id="61" name="Text 59"/>
+          <p:cNvSpPr/>
+          <p:nvPr/>
+        </p:nvSpPr>
+        <p:spPr>
+          <a:xfrm>
+            <a:off x="7618781" y="4732020"/>
+            <a:ext cx="4266590" cy="445313"/>
+          </a:xfrm>
+          <a:prstGeom prst="rect">
+            <a:avLst/>
+          </a:prstGeom>
+          <a:noFill/>
+          <a:ln/>
+        </p:spPr>
+        <p:txBody>
+          <a:bodyPr wrap="square" rtlCol="0" anchor="ctr"/>
+          <a:lstStyle/>
+          <a:p>
+            <a:pPr indent="0" marL="0">
+              <a:buNone/>
+            </a:pPr>
+            <a:r>
+              <a:rPr lang="en-US" sz="900" dirty="0">
+                <a:solidFill>
+                  <a:srgbClr val="333333"/>
+                </a:solidFill>
+                <a:latin typeface="Arial" pitchFamily="34" charset="0"/>
+                <a:ea typeface="Arial" pitchFamily="34" charset="-122"/>
+                <a:cs typeface="Arial" pitchFamily="34" charset="-120"/>
+              </a:rPr>
+              <a:t>pilot-loicrich/iac-nginx:latest sur Docker Hub</a:t>
+            </a:r>
+            <a:endParaRPr lang="en-US" sz="900" dirty="0"/>
+          </a:p>
+        </p:txBody>
+      </p:sp>
+      <p:sp>
+        <p:nvSpPr>
+          <p:cNvPr id="62" name="Shape 60"/>
+          <p:cNvSpPr/>
+          <p:nvPr/>
+        </p:nvSpPr>
+        <p:spPr>
+          <a:xfrm>
+            <a:off x="244145" y="5212080"/>
+            <a:ext cx="146304" cy="445313"/>
+          </a:xfrm>
+          <a:prstGeom prst="rect">
+            <a:avLst/>
+          </a:prstGeom>
+          <a:solidFill>
+            <a:srgbClr val="4A148C"/>
+          </a:solidFill>
+          <a:ln w="12700">
+            <a:solidFill>
+              <a:srgbClr val="4A148C"/>
+            </a:solidFill>
+            <a:prstDash val="solid"/>
+          </a:ln>
+        </p:spPr>
+      </p:sp>
+      <p:sp>
+        <p:nvSpPr>
+          <p:cNvPr id="63" name="Shape 61"/>
+          <p:cNvSpPr/>
+          <p:nvPr/>
+        </p:nvSpPr>
+        <p:spPr>
+          <a:xfrm>
+            <a:off x="390449" y="5212080"/>
+            <a:ext cx="2778862" cy="445313"/>
+          </a:xfrm>
+          <a:prstGeom prst="rect">
+            <a:avLst/>
+          </a:prstGeom>
+          <a:solidFill>
+            <a:srgbClr val="F0F4FF"/>
+          </a:solidFill>
+          <a:ln w="12700">
+            <a:solidFill>
+              <a:srgbClr val="DDDDDD"/>
+            </a:solidFill>
+            <a:prstDash val="solid"/>
+          </a:ln>
+        </p:spPr>
+      </p:sp>
+      <p:sp>
+        <p:nvSpPr>
+          <p:cNvPr id="64" name="Text 62"/>
+          <p:cNvSpPr/>
+          <p:nvPr/>
+        </p:nvSpPr>
+        <p:spPr>
+          <a:xfrm>
+            <a:off x="427025" y="5212080"/>
+            <a:ext cx="2681021" cy="445313"/>
+          </a:xfrm>
+          <a:prstGeom prst="rect">
+            <a:avLst/>
+          </a:prstGeom>
+          <a:noFill/>
+          <a:ln/>
+        </p:spPr>
+        <p:txBody>
+          <a:bodyPr wrap="square" rtlCol="0" anchor="ctr"/>
+          <a:lstStyle/>
+          <a:p>
+            <a:pPr indent="0" marL="0">
+              <a:buNone/>
+            </a:pPr>
+            <a:r>
+              <a:rPr lang="en-US" sz="900" b="1" dirty="0">
+                <a:solidFill>
+                  <a:srgbClr val="222222"/>
+                </a:solidFill>
+                <a:latin typeface="Arial" pitchFamily="34" charset="0"/>
+                <a:ea typeface="Arial" pitchFamily="34" charset="-122"/>
+                <a:cs typeface="Arial" pitchFamily="34" charset="-120"/>
+              </a:rPr>
+              <a:t>GitHub Actions (lint→build→validate)</a:t>
+            </a:r>
+            <a:endParaRPr lang="en-US" sz="900" dirty="0"/>
+          </a:p>
+        </p:txBody>
+      </p:sp>
+      <p:sp>
+        <p:nvSpPr>
+          <p:cNvPr id="65" name="Shape 63"/>
+          <p:cNvSpPr/>
+          <p:nvPr/>
+        </p:nvSpPr>
+        <p:spPr>
+          <a:xfrm>
+            <a:off x="3290926" y="5212080"/>
+            <a:ext cx="4144061" cy="445313"/>
+          </a:xfrm>
+          <a:prstGeom prst="rect">
+            <a:avLst/>
+          </a:prstGeom>
+          <a:solidFill>
+            <a:srgbClr val="F0F4FF"/>
+          </a:solidFill>
+          <a:ln w="12700">
+            <a:solidFill>
+              <a:srgbClr val="DDDDDD"/>
+            </a:solidFill>
+            <a:prstDash val="solid"/>
+          </a:ln>
+        </p:spPr>
+      </p:sp>
+      <p:sp>
+        <p:nvSpPr>
+          <p:cNvPr id="66" name="Text 64"/>
+          <p:cNvSpPr/>
+          <p:nvPr/>
+        </p:nvSpPr>
+        <p:spPr>
+          <a:xfrm>
+            <a:off x="3352190" y="5212080"/>
+            <a:ext cx="4022446" cy="445313"/>
+          </a:xfrm>
+          <a:prstGeom prst="rect">
+            <a:avLst/>
+          </a:prstGeom>
+          <a:noFill/>
+          <a:ln/>
+        </p:spPr>
+        <p:txBody>
+          <a:bodyPr wrap="square" rtlCol="0" anchor="ctr"/>
+          <a:lstStyle/>
+          <a:p>
+            <a:pPr indent="0" marL="0">
+              <a:buNone/>
+            </a:pPr>
+            <a:r>
+              <a:rPr lang="en-US" sz="900" b="1" dirty="0">
+                <a:solidFill>
+                  <a:srgbClr val="4A148C"/>
+                </a:solidFill>
+                <a:latin typeface="Arial" pitchFamily="34" charset="0"/>
+                <a:ea typeface="Arial" pitchFamily="34" charset="-122"/>
+                <a:cs typeface="Arial" pitchFamily="34" charset="-120"/>
+              </a:rPr>
+              <a:t>BC02-CP4 — Pipeline CI/CD</a:t>
+            </a:r>
+            <a:endParaRPr lang="en-US" sz="900" dirty="0"/>
+          </a:p>
+        </p:txBody>
+      </p:sp>
+      <p:sp>
+        <p:nvSpPr>
+          <p:cNvPr id="67" name="Shape 65"/>
+          <p:cNvSpPr/>
+          <p:nvPr/>
+        </p:nvSpPr>
+        <p:spPr>
+          <a:xfrm>
+            <a:off x="7557516" y="5212080"/>
+            <a:ext cx="4388206" cy="445313"/>
+          </a:xfrm>
+          <a:prstGeom prst="rect">
+            <a:avLst/>
+          </a:prstGeom>
+          <a:solidFill>
+            <a:srgbClr val="F0F4FF"/>
+          </a:solidFill>
+          <a:ln w="12700">
+            <a:solidFill>
+              <a:srgbClr val="DDDDDD"/>
+            </a:solidFill>
+            <a:prstDash val="solid"/>
+          </a:ln>
+        </p:spPr>
+      </p:sp>
+      <p:sp>
+        <p:nvSpPr>
+          <p:cNvPr id="68" name="Text 66"/>
+          <p:cNvSpPr/>
+          <p:nvPr/>
+        </p:nvSpPr>
+        <p:spPr>
+          <a:xfrm>
+            <a:off x="7618781" y="5212080"/>
+            <a:ext cx="4266590" cy="445313"/>
+          </a:xfrm>
+          <a:prstGeom prst="rect">
+            <a:avLst/>
+          </a:prstGeom>
+          <a:noFill/>
+          <a:ln/>
+        </p:spPr>
+        <p:txBody>
+          <a:bodyPr wrap="square" rtlCol="0" anchor="ctr"/>
+          <a:lstStyle/>
+          <a:p>
+            <a:pPr indent="0" marL="0">
+              <a:buNone/>
+            </a:pPr>
+            <a:r>
+              <a:rPr lang="en-US" sz="900" dirty="0">
+                <a:solidFill>
+                  <a:srgbClr val="333333"/>
+                </a:solidFill>
+                <a:latin typeface="Arial" pitchFamily="34" charset="0"/>
+                <a:ea typeface="Arial" pitchFamily="34" charset="-122"/>
+                <a:cs typeface="Arial" pitchFamily="34" charset="-120"/>
+              </a:rPr>
+              <a:t>3 jobs séquentiels · déclenché à chaque push</a:t>
+            </a:r>
+            <a:endParaRPr lang="en-US" sz="900" dirty="0"/>
+          </a:p>
+        </p:txBody>
+      </p:sp>
+      <p:sp>
+        <p:nvSpPr>
+          <p:cNvPr id="69" name="Shape 67"/>
+          <p:cNvSpPr/>
+          <p:nvPr/>
+        </p:nvSpPr>
+        <p:spPr>
+          <a:xfrm>
+            <a:off x="244145" y="5692140"/>
+            <a:ext cx="146304" cy="445313"/>
           </a:xfrm>
           <a:prstGeom prst="rect">
             <a:avLst/>
@@ -3437,63 +4836,24 @@
       </p:sp>
       <p:sp>
         <p:nvSpPr>
-          <p:cNvPr id="26" name="Text 24"/>
-          <p:cNvSpPr/>
-          <p:nvPr/>
-        </p:nvSpPr>
-        <p:spPr>
-          <a:xfrm>
-            <a:off x="6217006" y="3909060"/>
-            <a:ext cx="5728716" cy="685800"/>
-          </a:xfrm>
-          <a:prstGeom prst="rect">
-            <a:avLst/>
-          </a:prstGeom>
-          <a:noFill/>
-          <a:ln/>
-        </p:spPr>
-        <p:txBody>
-          <a:bodyPr wrap="square" rtlCol="0" anchor="ctr"/>
-          <a:lstStyle/>
-          <a:p>
-            <a:pPr algn="ctr" indent="0" marL="0">
-              <a:buNone/>
-            </a:pPr>
-            <a:r>
-              <a:rPr lang="en-US" sz="1300" b="1" dirty="0">
-                <a:solidFill>
-                  <a:srgbClr val="FFFFFF"/>
-                </a:solidFill>
-                <a:latin typeface="Arial" pitchFamily="34" charset="0"/>
-                <a:ea typeface="Arial" pitchFamily="34" charset="-122"/>
-                <a:cs typeface="Arial" pitchFamily="34" charset="-120"/>
-              </a:rPr>
-              <a:t>4. Monitoring + Discord ✅</a:t>
-            </a:r>
-            <a:endParaRPr lang="en-US" sz="1300" dirty="0"/>
-          </a:p>
-        </p:txBody>
-      </p:sp>
-      <p:sp>
-        <p:nvSpPr>
-          <p:cNvPr id="27" name="Shape 25"/>
-          <p:cNvSpPr/>
-          <p:nvPr/>
-        </p:nvSpPr>
-        <p:spPr>
-          <a:xfrm>
-            <a:off x="6217006" y="4594860"/>
-            <a:ext cx="5728716" cy="1577340"/>
-          </a:xfrm>
-          <a:prstGeom prst="rect">
-            <a:avLst/>
-          </a:prstGeom>
-          <a:solidFill>
-            <a:srgbClr val="1E2A3A"/>
+          <p:cNvPr id="70" name="Shape 68"/>
+          <p:cNvSpPr/>
+          <p:nvPr/>
+        </p:nvSpPr>
+        <p:spPr>
+          <a:xfrm>
+            <a:off x="390449" y="5692140"/>
+            <a:ext cx="2778862" cy="445313"/>
+          </a:xfrm>
+          <a:prstGeom prst="rect">
+            <a:avLst/>
+          </a:prstGeom>
+          <a:solidFill>
+            <a:srgbClr val="FFFFFF"/>
           </a:solidFill>
           <a:ln w="12700">
             <a:solidFill>
-              <a:srgbClr val="1E2A3A"/>
+              <a:srgbClr val="DDDDDD"/>
             </a:solidFill>
             <a:prstDash val="solid"/>
           </a:ln>
@@ -3501,14 +4861,14 @@
       </p:sp>
       <p:sp>
         <p:nvSpPr>
-          <p:cNvPr id="28" name="Text 26"/>
-          <p:cNvSpPr/>
-          <p:nvPr/>
-        </p:nvSpPr>
-        <p:spPr>
-          <a:xfrm>
-            <a:off x="6338621" y="4732020"/>
-            <a:ext cx="5484571" cy="411480"/>
+          <p:cNvPr id="71" name="Text 69"/>
+          <p:cNvSpPr/>
+          <p:nvPr/>
+        </p:nvSpPr>
+        <p:spPr>
+          <a:xfrm>
+            <a:off x="427025" y="5692140"/>
+            <a:ext cx="2681021" cy="445313"/>
           </a:xfrm>
           <a:prstGeom prst="rect">
             <a:avLst/>
@@ -3524,118 +4884,40 @@
               <a:buNone/>
             </a:pPr>
             <a:r>
-              <a:rPr lang="en-US" sz="1000" dirty="0">
-                <a:solidFill>
-                  <a:srgbClr val="98D982"/>
-                </a:solidFill>
-                <a:latin typeface="Courier New" pitchFamily="34" charset="0"/>
-                <a:ea typeface="Courier New" pitchFamily="34" charset="-122"/>
-                <a:cs typeface="Courier New" pitchFamily="34" charset="-120"/>
-              </a:rPr>
-              <a:t>$ # Grafana : http://192.168.56.10:3000</a:t>
-            </a:r>
-            <a:endParaRPr lang="en-US" sz="1000" dirty="0"/>
-          </a:p>
-        </p:txBody>
-      </p:sp>
-      <p:sp>
-        <p:nvSpPr>
-          <p:cNvPr id="29" name="Text 27"/>
-          <p:cNvSpPr/>
-          <p:nvPr/>
-        </p:nvSpPr>
-        <p:spPr>
-          <a:xfrm>
-            <a:off x="6338621" y="5212080"/>
-            <a:ext cx="5484571" cy="411480"/>
-          </a:xfrm>
-          <a:prstGeom prst="rect">
-            <a:avLst/>
-          </a:prstGeom>
-          <a:noFill/>
-          <a:ln/>
-        </p:spPr>
-        <p:txBody>
-          <a:bodyPr wrap="square" rtlCol="0" anchor="ctr"/>
-          <a:lstStyle/>
-          <a:p>
-            <a:pPr indent="0" marL="0">
-              <a:buNone/>
-            </a:pPr>
-            <a:r>
-              <a:rPr lang="en-US" sz="1000" dirty="0">
-                <a:solidFill>
-                  <a:srgbClr val="98D982"/>
-                </a:solidFill>
-                <a:latin typeface="Courier New" pitchFamily="34" charset="0"/>
-                <a:ea typeface="Courier New" pitchFamily="34" charset="-122"/>
-                <a:cs typeface="Courier New" pitchFamily="34" charset="-120"/>
-              </a:rPr>
-              <a:t>$ docker compose stop node-exporter</a:t>
-            </a:r>
-            <a:endParaRPr lang="en-US" sz="1000" dirty="0"/>
-          </a:p>
-        </p:txBody>
-      </p:sp>
-      <p:sp>
-        <p:nvSpPr>
-          <p:cNvPr id="30" name="Text 28"/>
-          <p:cNvSpPr/>
-          <p:nvPr/>
-        </p:nvSpPr>
-        <p:spPr>
-          <a:xfrm>
-            <a:off x="6338621" y="5692140"/>
-            <a:ext cx="5484571" cy="411480"/>
-          </a:xfrm>
-          <a:prstGeom prst="rect">
-            <a:avLst/>
-          </a:prstGeom>
-          <a:noFill/>
-          <a:ln/>
-        </p:spPr>
-        <p:txBody>
-          <a:bodyPr wrap="square" rtlCol="0" anchor="ctr"/>
-          <a:lstStyle/>
-          <a:p>
-            <a:pPr indent="0" marL="0">
-              <a:buNone/>
-            </a:pPr>
-            <a:r>
-              <a:rPr lang="en-US" sz="1000" dirty="0">
-                <a:solidFill>
-                  <a:srgbClr val="98D982"/>
-                </a:solidFill>
-                <a:latin typeface="Courier New" pitchFamily="34" charset="0"/>
-                <a:ea typeface="Courier New" pitchFamily="34" charset="-122"/>
-                <a:cs typeface="Courier New" pitchFamily="34" charset="-120"/>
-              </a:rPr>
-              <a:t>$ # → Discord : alerte reçue (HTTP 204) 🔔</a:t>
-            </a:r>
-            <a:endParaRPr lang="en-US" sz="1000" dirty="0"/>
-          </a:p>
-        </p:txBody>
-      </p:sp>
-      <p:sp>
-        <p:nvSpPr>
-          <p:cNvPr id="31" name="Shape 29"/>
-          <p:cNvSpPr/>
-          <p:nvPr/>
-        </p:nvSpPr>
-        <p:spPr>
-          <a:xfrm>
-            <a:off x="244145" y="6446520"/>
-            <a:ext cx="11701577" cy="342900"/>
-          </a:xfrm>
-          <a:prstGeom prst="rect">
-            <a:avLst/>
-          </a:prstGeom>
-          <a:solidFill>
-            <a:srgbClr val="1E1E1E"/>
+              <a:rPr lang="en-US" sz="900" b="1" dirty="0">
+                <a:solidFill>
+                  <a:srgbClr val="222222"/>
+                </a:solidFill>
+                <a:latin typeface="Arial" pitchFamily="34" charset="0"/>
+                <a:ea typeface="Arial" pitchFamily="34" charset="-122"/>
+                <a:cs typeface="Arial" pitchFamily="34" charset="-120"/>
+              </a:rPr>
+              <a:t>Prometheus + alerts.yml (3 alertes)</a:t>
+            </a:r>
+            <a:endParaRPr lang="en-US" sz="900" dirty="0"/>
+          </a:p>
+        </p:txBody>
+      </p:sp>
+      <p:sp>
+        <p:nvSpPr>
+          <p:cNvPr id="72" name="Shape 70"/>
+          <p:cNvSpPr/>
+          <p:nvPr/>
+        </p:nvSpPr>
+        <p:spPr>
+          <a:xfrm>
+            <a:off x="3290926" y="5692140"/>
+            <a:ext cx="4144061" cy="445313"/>
+          </a:xfrm>
+          <a:prstGeom prst="rect">
+            <a:avLst/>
+          </a:prstGeom>
+          <a:solidFill>
+            <a:srgbClr val="FFFFFF"/>
           </a:solidFill>
           <a:ln w="12700">
             <a:solidFill>
-              <a:srgbClr val="1E1E1E"/>
+              <a:srgbClr val="DDDDDD"/>
             </a:solidFill>
             <a:prstDash val="solid"/>
           </a:ln>
@@ -3643,14 +4925,14 @@
       </p:sp>
       <p:sp>
         <p:nvSpPr>
-          <p:cNvPr id="32" name="Text 30"/>
-          <p:cNvSpPr/>
-          <p:nvPr/>
-        </p:nvSpPr>
-        <p:spPr>
-          <a:xfrm>
-            <a:off x="365760" y="6446520"/>
-            <a:ext cx="11457432" cy="342900"/>
+          <p:cNvPr id="73" name="Text 71"/>
+          <p:cNvSpPr/>
+          <p:nvPr/>
+        </p:nvSpPr>
+        <p:spPr>
+          <a:xfrm>
+            <a:off x="3352190" y="5692140"/>
+            <a:ext cx="4022446" cy="445313"/>
           </a:xfrm>
           <a:prstGeom prst="rect">
             <a:avLst/>
@@ -3662,19 +4944,498 @@
           <a:bodyPr wrap="square" rtlCol="0" anchor="ctr"/>
           <a:lstStyle/>
           <a:p>
+            <a:pPr indent="0" marL="0">
+              <a:buNone/>
+            </a:pPr>
+            <a:r>
+              <a:rPr lang="en-US" sz="900" b="1" dirty="0">
+                <a:solidFill>
+                  <a:srgbClr val="E65100"/>
+                </a:solidFill>
+                <a:latin typeface="Arial" pitchFamily="34" charset="0"/>
+                <a:ea typeface="Arial" pitchFamily="34" charset="-122"/>
+                <a:cs typeface="Arial" pitchFamily="34" charset="-120"/>
+              </a:rPr>
+              <a:t>BC03-CP1 — Définir les KPIs / alertes</a:t>
+            </a:r>
+            <a:endParaRPr lang="en-US" sz="900" dirty="0"/>
+          </a:p>
+        </p:txBody>
+      </p:sp>
+      <p:sp>
+        <p:nvSpPr>
+          <p:cNvPr id="74" name="Shape 72"/>
+          <p:cNvSpPr/>
+          <p:nvPr/>
+        </p:nvSpPr>
+        <p:spPr>
+          <a:xfrm>
+            <a:off x="7557516" y="5692140"/>
+            <a:ext cx="4388206" cy="445313"/>
+          </a:xfrm>
+          <a:prstGeom prst="rect">
+            <a:avLst/>
+          </a:prstGeom>
+          <a:solidFill>
+            <a:srgbClr val="FFFFFF"/>
+          </a:solidFill>
+          <a:ln w="12700">
+            <a:solidFill>
+              <a:srgbClr val="DDDDDD"/>
+            </a:solidFill>
+            <a:prstDash val="solid"/>
+          </a:ln>
+        </p:spPr>
+      </p:sp>
+      <p:sp>
+        <p:nvSpPr>
+          <p:cNvPr id="75" name="Text 73"/>
+          <p:cNvSpPr/>
+          <p:nvPr/>
+        </p:nvSpPr>
+        <p:spPr>
+          <a:xfrm>
+            <a:off x="7618781" y="5692140"/>
+            <a:ext cx="4266590" cy="445313"/>
+          </a:xfrm>
+          <a:prstGeom prst="rect">
+            <a:avLst/>
+          </a:prstGeom>
+          <a:noFill/>
+          <a:ln/>
+        </p:spPr>
+        <p:txBody>
+          <a:bodyPr wrap="square" rtlCol="0" anchor="ctr"/>
+          <a:lstStyle/>
+          <a:p>
+            <a:pPr indent="0" marL="0">
+              <a:buNone/>
+            </a:pPr>
+            <a:r>
+              <a:rPr lang="en-US" sz="900" dirty="0">
+                <a:solidFill>
+                  <a:srgbClr val="333333"/>
+                </a:solidFill>
+                <a:latin typeface="Arial" pitchFamily="34" charset="0"/>
+                <a:ea typeface="Arial" pitchFamily="34" charset="-122"/>
+                <a:cs typeface="Arial" pitchFamily="34" charset="-120"/>
+              </a:rPr>
+              <a:t>HighCPU · HighMemory · NginxDown en PromQL</a:t>
+            </a:r>
+            <a:endParaRPr lang="en-US" sz="900" dirty="0"/>
+          </a:p>
+        </p:txBody>
+      </p:sp>
+      <p:sp>
+        <p:nvSpPr>
+          <p:cNvPr id="76" name="Shape 74"/>
+          <p:cNvSpPr/>
+          <p:nvPr/>
+        </p:nvSpPr>
+        <p:spPr>
+          <a:xfrm>
+            <a:off x="244145" y="6172200"/>
+            <a:ext cx="146304" cy="445313"/>
+          </a:xfrm>
+          <a:prstGeom prst="rect">
+            <a:avLst/>
+          </a:prstGeom>
+          <a:solidFill>
+            <a:srgbClr val="E65100"/>
+          </a:solidFill>
+          <a:ln w="12700">
+            <a:solidFill>
+              <a:srgbClr val="E65100"/>
+            </a:solidFill>
+            <a:prstDash val="solid"/>
+          </a:ln>
+        </p:spPr>
+      </p:sp>
+      <p:sp>
+        <p:nvSpPr>
+          <p:cNvPr id="77" name="Shape 75"/>
+          <p:cNvSpPr/>
+          <p:nvPr/>
+        </p:nvSpPr>
+        <p:spPr>
+          <a:xfrm>
+            <a:off x="390449" y="6172200"/>
+            <a:ext cx="2778862" cy="445313"/>
+          </a:xfrm>
+          <a:prstGeom prst="rect">
+            <a:avLst/>
+          </a:prstGeom>
+          <a:solidFill>
+            <a:srgbClr val="F0F4FF"/>
+          </a:solidFill>
+          <a:ln w="12700">
+            <a:solidFill>
+              <a:srgbClr val="DDDDDD"/>
+            </a:solidFill>
+            <a:prstDash val="solid"/>
+          </a:ln>
+        </p:spPr>
+      </p:sp>
+      <p:sp>
+        <p:nvSpPr>
+          <p:cNvPr id="78" name="Text 76"/>
+          <p:cNvSpPr/>
+          <p:nvPr/>
+        </p:nvSpPr>
+        <p:spPr>
+          <a:xfrm>
+            <a:off x="427025" y="6172200"/>
+            <a:ext cx="2681021" cy="445313"/>
+          </a:xfrm>
+          <a:prstGeom prst="rect">
+            <a:avLst/>
+          </a:prstGeom>
+          <a:noFill/>
+          <a:ln/>
+        </p:spPr>
+        <p:txBody>
+          <a:bodyPr wrap="square" rtlCol="0" anchor="ctr"/>
+          <a:lstStyle/>
+          <a:p>
+            <a:pPr indent="0" marL="0">
+              <a:buNone/>
+            </a:pPr>
+            <a:r>
+              <a:rPr lang="en-US" sz="900" b="1" dirty="0">
+                <a:solidFill>
+                  <a:srgbClr val="222222"/>
+                </a:solidFill>
+                <a:latin typeface="Arial" pitchFamily="34" charset="0"/>
+                <a:ea typeface="Arial" pitchFamily="34" charset="-122"/>
+                <a:cs typeface="Arial" pitchFamily="34" charset="-120"/>
+              </a:rPr>
+              <a:t>Grafana + Alertmanager + discord_relay</a:t>
+            </a:r>
+            <a:endParaRPr lang="en-US" sz="900" dirty="0"/>
+          </a:p>
+        </p:txBody>
+      </p:sp>
+      <p:sp>
+        <p:nvSpPr>
+          <p:cNvPr id="79" name="Shape 77"/>
+          <p:cNvSpPr/>
+          <p:nvPr/>
+        </p:nvSpPr>
+        <p:spPr>
+          <a:xfrm>
+            <a:off x="3290926" y="6172200"/>
+            <a:ext cx="4144061" cy="445313"/>
+          </a:xfrm>
+          <a:prstGeom prst="rect">
+            <a:avLst/>
+          </a:prstGeom>
+          <a:solidFill>
+            <a:srgbClr val="F0F4FF"/>
+          </a:solidFill>
+          <a:ln w="12700">
+            <a:solidFill>
+              <a:srgbClr val="DDDDDD"/>
+            </a:solidFill>
+            <a:prstDash val="solid"/>
+          </a:ln>
+        </p:spPr>
+      </p:sp>
+      <p:sp>
+        <p:nvSpPr>
+          <p:cNvPr id="80" name="Text 78"/>
+          <p:cNvSpPr/>
+          <p:nvPr/>
+        </p:nvSpPr>
+        <p:spPr>
+          <a:xfrm>
+            <a:off x="3352190" y="6172200"/>
+            <a:ext cx="4022446" cy="445313"/>
+          </a:xfrm>
+          <a:prstGeom prst="rect">
+            <a:avLst/>
+          </a:prstGeom>
+          <a:noFill/>
+          <a:ln/>
+        </p:spPr>
+        <p:txBody>
+          <a:bodyPr wrap="square" rtlCol="0" anchor="ctr"/>
+          <a:lstStyle/>
+          <a:p>
+            <a:pPr indent="0" marL="0">
+              <a:buNone/>
+            </a:pPr>
+            <a:r>
+              <a:rPr lang="en-US" sz="900" b="1" dirty="0">
+                <a:solidFill>
+                  <a:srgbClr val="E65100"/>
+                </a:solidFill>
+                <a:latin typeface="Arial" pitchFamily="34" charset="0"/>
+                <a:ea typeface="Arial" pitchFamily="34" charset="-122"/>
+                <a:cs typeface="Arial" pitchFamily="34" charset="-120"/>
+              </a:rPr>
+              <a:t>BC03-CP2 — Superviser les services</a:t>
+            </a:r>
+            <a:endParaRPr lang="en-US" sz="900" dirty="0"/>
+          </a:p>
+        </p:txBody>
+      </p:sp>
+      <p:sp>
+        <p:nvSpPr>
+          <p:cNvPr id="81" name="Shape 79"/>
+          <p:cNvSpPr/>
+          <p:nvPr/>
+        </p:nvSpPr>
+        <p:spPr>
+          <a:xfrm>
+            <a:off x="7557516" y="6172200"/>
+            <a:ext cx="4388206" cy="445313"/>
+          </a:xfrm>
+          <a:prstGeom prst="rect">
+            <a:avLst/>
+          </a:prstGeom>
+          <a:solidFill>
+            <a:srgbClr val="F0F4FF"/>
+          </a:solidFill>
+          <a:ln w="12700">
+            <a:solidFill>
+              <a:srgbClr val="DDDDDD"/>
+            </a:solidFill>
+            <a:prstDash val="solid"/>
+          </a:ln>
+        </p:spPr>
+      </p:sp>
+      <p:sp>
+        <p:nvSpPr>
+          <p:cNvPr id="82" name="Text 80"/>
+          <p:cNvSpPr/>
+          <p:nvPr/>
+        </p:nvSpPr>
+        <p:spPr>
+          <a:xfrm>
+            <a:off x="7618781" y="6172200"/>
+            <a:ext cx="4266590" cy="445313"/>
+          </a:xfrm>
+          <a:prstGeom prst="rect">
+            <a:avLst/>
+          </a:prstGeom>
+          <a:noFill/>
+          <a:ln/>
+        </p:spPr>
+        <p:txBody>
+          <a:bodyPr wrap="square" rtlCol="0" anchor="ctr"/>
+          <a:lstStyle/>
+          <a:p>
+            <a:pPr indent="0" marL="0">
+              <a:buNone/>
+            </a:pPr>
+            <a:r>
+              <a:rPr lang="en-US" sz="900" dirty="0">
+                <a:solidFill>
+                  <a:srgbClr val="333333"/>
+                </a:solidFill>
+                <a:latin typeface="Arial" pitchFamily="34" charset="0"/>
+                <a:ea typeface="Arial" pitchFamily="34" charset="-122"/>
+                <a:cs typeface="Arial" pitchFamily="34" charset="-120"/>
+              </a:rPr>
+              <a:t>Dashboard auto · Discord HTTP 204 confirmé</a:t>
+            </a:r>
+            <a:endParaRPr lang="en-US" sz="900" dirty="0"/>
+          </a:p>
+        </p:txBody>
+      </p:sp>
+      <p:sp>
+        <p:nvSpPr>
+          <p:cNvPr id="83" name="Shape 81"/>
+          <p:cNvSpPr/>
+          <p:nvPr/>
+        </p:nvSpPr>
+        <p:spPr>
+          <a:xfrm>
+            <a:off x="244145" y="6583680"/>
+            <a:ext cx="3656686" cy="274320"/>
+          </a:xfrm>
+          <a:prstGeom prst="roundRect">
+            <a:avLst>
+              <a:gd name="adj" fmla="val 16667"/>
+            </a:avLst>
+          </a:prstGeom>
+          <a:solidFill>
+            <a:srgbClr val="00695C"/>
+          </a:solidFill>
+          <a:ln w="12700">
+            <a:solidFill>
+              <a:srgbClr val="00695C"/>
+            </a:solidFill>
+            <a:prstDash val="solid"/>
+          </a:ln>
+        </p:spPr>
+      </p:sp>
+      <p:sp>
+        <p:nvSpPr>
+          <p:cNvPr id="84" name="Text 82"/>
+          <p:cNvSpPr/>
+          <p:nvPr/>
+        </p:nvSpPr>
+        <p:spPr>
+          <a:xfrm>
+            <a:off x="244145" y="6583680"/>
+            <a:ext cx="3656686" cy="274320"/>
+          </a:xfrm>
+          <a:prstGeom prst="rect">
+            <a:avLst/>
+          </a:prstGeom>
+          <a:noFill/>
+          <a:ln/>
+        </p:spPr>
+        <p:txBody>
+          <a:bodyPr wrap="square" rtlCol="0" anchor="ctr"/>
+          <a:lstStyle/>
+          <a:p>
             <a:pPr algn="ctr" indent="0" marL="0">
               <a:buNone/>
             </a:pPr>
             <a:r>
-              <a:rPr lang="en-US" sz="1000" dirty="0">
-                <a:solidFill>
-                  <a:srgbClr val="98D982"/>
-                </a:solidFill>
-                <a:latin typeface="Courier New" pitchFamily="34" charset="0"/>
-                <a:ea typeface="Courier New" pitchFamily="34" charset="-122"/>
-                <a:cs typeface="Courier New" pitchFamily="34" charset="-120"/>
-              </a:rPr>
-              <a:t>$ docker compose exec db psql -U admin -d iac_db -c 'SELECT * FROM utilisateurs;'   →  2 lignes ✅</a:t>
+              <a:rPr lang="en-US" sz="1000" b="1" dirty="0">
+                <a:solidFill>
+                  <a:srgbClr val="FFFFFF"/>
+                </a:solidFill>
+                <a:latin typeface="Arial" pitchFamily="34" charset="0"/>
+                <a:ea typeface="Arial" pitchFamily="34" charset="-122"/>
+                <a:cs typeface="Arial" pitchFamily="34" charset="-120"/>
+              </a:rPr>
+              <a:t>BC01 — IaC &amp; Infra</a:t>
+            </a:r>
+            <a:endParaRPr lang="en-US" sz="1000" dirty="0"/>
+          </a:p>
+        </p:txBody>
+      </p:sp>
+      <p:sp>
+        <p:nvSpPr>
+          <p:cNvPr id="85" name="Shape 83"/>
+          <p:cNvSpPr/>
+          <p:nvPr/>
+        </p:nvSpPr>
+        <p:spPr>
+          <a:xfrm>
+            <a:off x="4144975" y="6583680"/>
+            <a:ext cx="3656686" cy="274320"/>
+          </a:xfrm>
+          <a:prstGeom prst="roundRect">
+            <a:avLst>
+              <a:gd name="adj" fmla="val 16667"/>
+            </a:avLst>
+          </a:prstGeom>
+          <a:solidFill>
+            <a:srgbClr val="4A148C"/>
+          </a:solidFill>
+          <a:ln w="12700">
+            <a:solidFill>
+              <a:srgbClr val="4A148C"/>
+            </a:solidFill>
+            <a:prstDash val="solid"/>
+          </a:ln>
+        </p:spPr>
+      </p:sp>
+      <p:sp>
+        <p:nvSpPr>
+          <p:cNvPr id="86" name="Text 84"/>
+          <p:cNvSpPr/>
+          <p:nvPr/>
+        </p:nvSpPr>
+        <p:spPr>
+          <a:xfrm>
+            <a:off x="4144975" y="6583680"/>
+            <a:ext cx="3656686" cy="274320"/>
+          </a:xfrm>
+          <a:prstGeom prst="rect">
+            <a:avLst/>
+          </a:prstGeom>
+          <a:noFill/>
+          <a:ln/>
+        </p:spPr>
+        <p:txBody>
+          <a:bodyPr wrap="square" rtlCol="0" anchor="ctr"/>
+          <a:lstStyle/>
+          <a:p>
+            <a:pPr algn="ctr" indent="0" marL="0">
+              <a:buNone/>
+            </a:pPr>
+            <a:r>
+              <a:rPr lang="en-US" sz="1000" b="1" dirty="0">
+                <a:solidFill>
+                  <a:srgbClr val="FFFFFF"/>
+                </a:solidFill>
+                <a:latin typeface="Arial" pitchFamily="34" charset="0"/>
+                <a:ea typeface="Arial" pitchFamily="34" charset="-122"/>
+                <a:cs typeface="Arial" pitchFamily="34" charset="-120"/>
+              </a:rPr>
+              <a:t>BC02 — Conteneurs &amp; CI/CD</a:t>
+            </a:r>
+            <a:endParaRPr lang="en-US" sz="1000" dirty="0"/>
+          </a:p>
+        </p:txBody>
+      </p:sp>
+      <p:sp>
+        <p:nvSpPr>
+          <p:cNvPr id="87" name="Shape 85"/>
+          <p:cNvSpPr/>
+          <p:nvPr/>
+        </p:nvSpPr>
+        <p:spPr>
+          <a:xfrm>
+            <a:off x="8045806" y="6583680"/>
+            <a:ext cx="3656686" cy="274320"/>
+          </a:xfrm>
+          <a:prstGeom prst="roundRect">
+            <a:avLst>
+              <a:gd name="adj" fmla="val 16667"/>
+            </a:avLst>
+          </a:prstGeom>
+          <a:solidFill>
+            <a:srgbClr val="E65100"/>
+          </a:solidFill>
+          <a:ln w="12700">
+            <a:solidFill>
+              <a:srgbClr val="E65100"/>
+            </a:solidFill>
+            <a:prstDash val="solid"/>
+          </a:ln>
+        </p:spPr>
+      </p:sp>
+      <p:sp>
+        <p:nvSpPr>
+          <p:cNvPr id="88" name="Text 86"/>
+          <p:cNvSpPr/>
+          <p:nvPr/>
+        </p:nvSpPr>
+        <p:spPr>
+          <a:xfrm>
+            <a:off x="8045806" y="6583680"/>
+            <a:ext cx="3656686" cy="274320"/>
+          </a:xfrm>
+          <a:prstGeom prst="rect">
+            <a:avLst/>
+          </a:prstGeom>
+          <a:noFill/>
+          <a:ln/>
+        </p:spPr>
+        <p:txBody>
+          <a:bodyPr wrap="square" rtlCol="0" anchor="ctr"/>
+          <a:lstStyle/>
+          <a:p>
+            <a:pPr algn="ctr" indent="0" marL="0">
+              <a:buNone/>
+            </a:pPr>
+            <a:r>
+              <a:rPr lang="en-US" sz="1000" b="1" dirty="0">
+                <a:solidFill>
+                  <a:srgbClr val="FFFFFF"/>
+                </a:solidFill>
+                <a:latin typeface="Arial" pitchFamily="34" charset="0"/>
+                <a:ea typeface="Arial" pitchFamily="34" charset="-122"/>
+                <a:cs typeface="Arial" pitchFamily="34" charset="-120"/>
+              </a:rPr>
+              <a:t>BC03 — Supervision</a:t>
             </a:r>
             <a:endParaRPr lang="en-US" sz="1000" dirty="0"/>
           </a:p>
@@ -3691,6 +5452,1072 @@
 <file path=ppt/slides/slide11.xml><?xml version="1.0" encoding="utf-8"?>
 <p:sld xmlns:a="http://schemas.openxmlformats.org/drawingml/2006/main" xmlns:r="http://schemas.openxmlformats.org/officeDocument/2006/relationships" xmlns:p="http://schemas.openxmlformats.org/presentationml/2006/main">
   <p:cSld name="Slide 11">
+    <p:spTree>
+      <p:nvGrpSpPr>
+        <p:cNvPr id="1" name=""/>
+        <p:cNvGrpSpPr/>
+        <p:nvPr/>
+      </p:nvGrpSpPr>
+      <p:grpSpPr>
+        <a:xfrm>
+          <a:off x="0" y="0"/>
+          <a:ext cx="0" cy="0"/>
+          <a:chOff x="0" y="0"/>
+          <a:chExt cx="0" cy="0"/>
+        </a:xfrm>
+      </p:grpSpPr>
+      <p:sp>
+        <p:nvSpPr>
+          <p:cNvPr id="2" name="Shape 0"/>
+          <p:cNvSpPr/>
+          <p:nvPr/>
+        </p:nvSpPr>
+        <p:spPr>
+          <a:xfrm>
+            <a:off x="0" y="0"/>
+            <a:ext cx="12192000" cy="6858000"/>
+          </a:xfrm>
+          <a:prstGeom prst="rect">
+            <a:avLst/>
+          </a:prstGeom>
+          <a:solidFill>
+            <a:srgbClr val="0D1B2A"/>
+          </a:solidFill>
+          <a:ln w="12700">
+            <a:solidFill>
+              <a:srgbClr val="0D1B2A"/>
+            </a:solidFill>
+            <a:prstDash val="solid"/>
+          </a:ln>
+        </p:spPr>
+      </p:sp>
+      <p:sp>
+        <p:nvSpPr>
+          <p:cNvPr id="3" name="Shape 1"/>
+          <p:cNvSpPr/>
+          <p:nvPr/>
+        </p:nvSpPr>
+        <p:spPr>
+          <a:xfrm>
+            <a:off x="0" y="0"/>
+            <a:ext cx="12192000" cy="1234440"/>
+          </a:xfrm>
+          <a:prstGeom prst="rect">
+            <a:avLst/>
+          </a:prstGeom>
+          <a:solidFill>
+            <a:srgbClr val="1A237E"/>
+          </a:solidFill>
+          <a:ln w="12700">
+            <a:solidFill>
+              <a:srgbClr val="1A237E"/>
+            </a:solidFill>
+            <a:prstDash val="solid"/>
+          </a:ln>
+        </p:spPr>
+      </p:sp>
+      <p:sp>
+        <p:nvSpPr>
+          <p:cNvPr id="4" name="Shape 2"/>
+          <p:cNvSpPr/>
+          <p:nvPr/>
+        </p:nvSpPr>
+        <p:spPr>
+          <a:xfrm>
+            <a:off x="0" y="1234440"/>
+            <a:ext cx="12192000" cy="103327"/>
+          </a:xfrm>
+          <a:prstGeom prst="rect">
+            <a:avLst/>
+          </a:prstGeom>
+          <a:solidFill>
+            <a:srgbClr val="00695C"/>
+          </a:solidFill>
+          <a:ln w="12700">
+            <a:solidFill>
+              <a:srgbClr val="00695C"/>
+            </a:solidFill>
+            <a:prstDash val="solid"/>
+          </a:ln>
+        </p:spPr>
+      </p:sp>
+      <p:sp>
+        <p:nvSpPr>
+          <p:cNvPr id="5" name="Text 3"/>
+          <p:cNvSpPr/>
+          <p:nvPr/>
+        </p:nvSpPr>
+        <p:spPr>
+          <a:xfrm>
+            <a:off x="244145" y="137160"/>
+            <a:ext cx="9751162" cy="822960"/>
+          </a:xfrm>
+          <a:prstGeom prst="rect">
+            <a:avLst/>
+          </a:prstGeom>
+          <a:noFill/>
+          <a:ln/>
+        </p:spPr>
+        <p:txBody>
+          <a:bodyPr wrap="square" rtlCol="0" anchor="ctr"/>
+          <a:lstStyle/>
+          <a:p>
+            <a:pPr indent="0" marL="0">
+              <a:buNone/>
+            </a:pPr>
+            <a:r>
+              <a:rPr lang="en-US" sz="2600" b="1" dirty="0">
+                <a:solidFill>
+                  <a:srgbClr val="FFFFFF"/>
+                </a:solidFill>
+                <a:latin typeface="Arial" pitchFamily="34" charset="0"/>
+                <a:ea typeface="Arial" pitchFamily="34" charset="-122"/>
+                <a:cs typeface="Arial" pitchFamily="34" charset="-120"/>
+              </a:rPr>
+              <a:t>Démonstration Live</a:t>
+            </a:r>
+            <a:endParaRPr lang="en-US" sz="2600" dirty="0"/>
+          </a:p>
+        </p:txBody>
+      </p:sp>
+      <p:sp>
+        <p:nvSpPr>
+          <p:cNvPr id="6" name="Text 4"/>
+          <p:cNvSpPr/>
+          <p:nvPr/>
+        </p:nvSpPr>
+        <p:spPr>
+          <a:xfrm>
+            <a:off x="244145" y="685800"/>
+            <a:ext cx="9751162" cy="548640"/>
+          </a:xfrm>
+          <a:prstGeom prst="rect">
+            <a:avLst/>
+          </a:prstGeom>
+          <a:noFill/>
+          <a:ln/>
+        </p:spPr>
+        <p:txBody>
+          <a:bodyPr wrap="square" rtlCol="0" anchor="ctr"/>
+          <a:lstStyle/>
+          <a:p>
+            <a:pPr indent="0" marL="0">
+              <a:buNone/>
+            </a:pPr>
+            <a:r>
+              <a:rPr lang="en-US" sz="1300" i="1" dirty="0">
+                <a:solidFill>
+                  <a:srgbClr val="AACCFF"/>
+                </a:solidFill>
+                <a:latin typeface="Arial" pitchFamily="34" charset="0"/>
+                <a:ea typeface="Arial" pitchFamily="34" charset="-122"/>
+                <a:cs typeface="Arial" pitchFamily="34" charset="-120"/>
+              </a:rPr>
+              <a:t>Séquence de commandes — prêt à l'emploi</a:t>
+            </a:r>
+            <a:endParaRPr lang="en-US" sz="1300" dirty="0"/>
+          </a:p>
+        </p:txBody>
+      </p:sp>
+      <p:sp>
+        <p:nvSpPr>
+          <p:cNvPr id="7" name="Shape 5"/>
+          <p:cNvSpPr/>
+          <p:nvPr/>
+        </p:nvSpPr>
+        <p:spPr>
+          <a:xfrm>
+            <a:off x="244145" y="1508760"/>
+            <a:ext cx="5728716" cy="685800"/>
+          </a:xfrm>
+          <a:prstGeom prst="rect">
+            <a:avLst/>
+          </a:prstGeom>
+          <a:solidFill>
+            <a:srgbClr val="00695C"/>
+          </a:solidFill>
+          <a:ln w="12700">
+            <a:solidFill>
+              <a:srgbClr val="00695C"/>
+            </a:solidFill>
+            <a:prstDash val="solid"/>
+          </a:ln>
+        </p:spPr>
+      </p:sp>
+      <p:sp>
+        <p:nvSpPr>
+          <p:cNvPr id="8" name="Text 6"/>
+          <p:cNvSpPr/>
+          <p:nvPr/>
+        </p:nvSpPr>
+        <p:spPr>
+          <a:xfrm>
+            <a:off x="244145" y="1508760"/>
+            <a:ext cx="5728716" cy="685800"/>
+          </a:xfrm>
+          <a:prstGeom prst="rect">
+            <a:avLst/>
+          </a:prstGeom>
+          <a:noFill/>
+          <a:ln/>
+        </p:spPr>
+        <p:txBody>
+          <a:bodyPr wrap="square" rtlCol="0" anchor="ctr"/>
+          <a:lstStyle/>
+          <a:p>
+            <a:pPr algn="ctr" indent="0" marL="0">
+              <a:buNone/>
+            </a:pPr>
+            <a:r>
+              <a:rPr lang="en-US" sz="1300" b="1" dirty="0">
+                <a:solidFill>
+                  <a:srgbClr val="FFFFFF"/>
+                </a:solidFill>
+                <a:latin typeface="Arial" pitchFamily="34" charset="0"/>
+                <a:ea typeface="Arial" pitchFamily="34" charset="-122"/>
+                <a:cs typeface="Arial" pitchFamily="34" charset="-120"/>
+              </a:rPr>
+              <a:t>1. VM + Ansible</a:t>
+            </a:r>
+            <a:endParaRPr lang="en-US" sz="1300" dirty="0"/>
+          </a:p>
+        </p:txBody>
+      </p:sp>
+      <p:sp>
+        <p:nvSpPr>
+          <p:cNvPr id="9" name="Shape 7"/>
+          <p:cNvSpPr/>
+          <p:nvPr/>
+        </p:nvSpPr>
+        <p:spPr>
+          <a:xfrm>
+            <a:off x="244145" y="2194560"/>
+            <a:ext cx="5728716" cy="1577340"/>
+          </a:xfrm>
+          <a:prstGeom prst="rect">
+            <a:avLst/>
+          </a:prstGeom>
+          <a:solidFill>
+            <a:srgbClr val="1E2A3A"/>
+          </a:solidFill>
+          <a:ln w="12700">
+            <a:solidFill>
+              <a:srgbClr val="1E2A3A"/>
+            </a:solidFill>
+            <a:prstDash val="solid"/>
+          </a:ln>
+        </p:spPr>
+      </p:sp>
+      <p:sp>
+        <p:nvSpPr>
+          <p:cNvPr id="10" name="Text 8"/>
+          <p:cNvSpPr/>
+          <p:nvPr/>
+        </p:nvSpPr>
+        <p:spPr>
+          <a:xfrm>
+            <a:off x="365760" y="2331720"/>
+            <a:ext cx="5484571" cy="411480"/>
+          </a:xfrm>
+          <a:prstGeom prst="rect">
+            <a:avLst/>
+          </a:prstGeom>
+          <a:noFill/>
+          <a:ln/>
+        </p:spPr>
+        <p:txBody>
+          <a:bodyPr wrap="square" rtlCol="0" anchor="ctr"/>
+          <a:lstStyle/>
+          <a:p>
+            <a:pPr indent="0" marL="0">
+              <a:buNone/>
+            </a:pPr>
+            <a:r>
+              <a:rPr lang="en-US" sz="1000" dirty="0">
+                <a:solidFill>
+                  <a:srgbClr val="98D982"/>
+                </a:solidFill>
+                <a:latin typeface="Courier New" pitchFamily="34" charset="0"/>
+                <a:ea typeface="Courier New" pitchFamily="34" charset="-122"/>
+                <a:cs typeface="Courier New" pitchFamily="34" charset="-120"/>
+              </a:rPr>
+              <a:t>$ vagrant up</a:t>
+            </a:r>
+            <a:endParaRPr lang="en-US" sz="1000" dirty="0"/>
+          </a:p>
+        </p:txBody>
+      </p:sp>
+      <p:sp>
+        <p:nvSpPr>
+          <p:cNvPr id="11" name="Text 9"/>
+          <p:cNvSpPr/>
+          <p:nvPr/>
+        </p:nvSpPr>
+        <p:spPr>
+          <a:xfrm>
+            <a:off x="365760" y="2811780"/>
+            <a:ext cx="5484571" cy="411480"/>
+          </a:xfrm>
+          <a:prstGeom prst="rect">
+            <a:avLst/>
+          </a:prstGeom>
+          <a:noFill/>
+          <a:ln/>
+        </p:spPr>
+        <p:txBody>
+          <a:bodyPr wrap="square" rtlCol="0" anchor="ctr"/>
+          <a:lstStyle/>
+          <a:p>
+            <a:pPr indent="0" marL="0">
+              <a:buNone/>
+            </a:pPr>
+            <a:r>
+              <a:rPr lang="en-US" sz="1000" dirty="0">
+                <a:solidFill>
+                  <a:srgbClr val="98D982"/>
+                </a:solidFill>
+                <a:latin typeface="Courier New" pitchFamily="34" charset="0"/>
+                <a:ea typeface="Courier New" pitchFamily="34" charset="-122"/>
+                <a:cs typeface="Courier New" pitchFamily="34" charset="-120"/>
+              </a:rPr>
+              <a:t>$ ansible-playbook ansible/playbook.yml</a:t>
+            </a:r>
+            <a:endParaRPr lang="en-US" sz="1000" dirty="0"/>
+          </a:p>
+        </p:txBody>
+      </p:sp>
+      <p:sp>
+        <p:nvSpPr>
+          <p:cNvPr id="12" name="Text 10"/>
+          <p:cNvSpPr/>
+          <p:nvPr/>
+        </p:nvSpPr>
+        <p:spPr>
+          <a:xfrm>
+            <a:off x="365760" y="3291840"/>
+            <a:ext cx="5484571" cy="411480"/>
+          </a:xfrm>
+          <a:prstGeom prst="rect">
+            <a:avLst/>
+          </a:prstGeom>
+          <a:noFill/>
+          <a:ln/>
+        </p:spPr>
+        <p:txBody>
+          <a:bodyPr wrap="square" rtlCol="0" anchor="ctr"/>
+          <a:lstStyle/>
+          <a:p>
+            <a:pPr indent="0" marL="0">
+              <a:buNone/>
+            </a:pPr>
+            <a:r>
+              <a:rPr lang="en-US" sz="1000" dirty="0">
+                <a:solidFill>
+                  <a:srgbClr val="98D982"/>
+                </a:solidFill>
+                <a:latin typeface="Courier New" pitchFamily="34" charset="0"/>
+                <a:ea typeface="Courier New" pitchFamily="34" charset="-122"/>
+                <a:cs typeface="Courier New" pitchFamily="34" charset="-120"/>
+              </a:rPr>
+              <a:t>$ curl http://192.168.56.10</a:t>
+            </a:r>
+            <a:endParaRPr lang="en-US" sz="1000" dirty="0"/>
+          </a:p>
+        </p:txBody>
+      </p:sp>
+      <p:sp>
+        <p:nvSpPr>
+          <p:cNvPr id="13" name="Shape 11"/>
+          <p:cNvSpPr/>
+          <p:nvPr/>
+        </p:nvSpPr>
+        <p:spPr>
+          <a:xfrm>
+            <a:off x="6217006" y="1508760"/>
+            <a:ext cx="5728716" cy="685800"/>
+          </a:xfrm>
+          <a:prstGeom prst="rect">
+            <a:avLst/>
+          </a:prstGeom>
+          <a:solidFill>
+            <a:srgbClr val="1565C0"/>
+          </a:solidFill>
+          <a:ln w="12700">
+            <a:solidFill>
+              <a:srgbClr val="1565C0"/>
+            </a:solidFill>
+            <a:prstDash val="solid"/>
+          </a:ln>
+        </p:spPr>
+      </p:sp>
+      <p:sp>
+        <p:nvSpPr>
+          <p:cNvPr id="14" name="Text 12"/>
+          <p:cNvSpPr/>
+          <p:nvPr/>
+        </p:nvSpPr>
+        <p:spPr>
+          <a:xfrm>
+            <a:off x="6217006" y="1508760"/>
+            <a:ext cx="5728716" cy="685800"/>
+          </a:xfrm>
+          <a:prstGeom prst="rect">
+            <a:avLst/>
+          </a:prstGeom>
+          <a:noFill/>
+          <a:ln/>
+        </p:spPr>
+        <p:txBody>
+          <a:bodyPr wrap="square" rtlCol="0" anchor="ctr"/>
+          <a:lstStyle/>
+          <a:p>
+            <a:pPr algn="ctr" indent="0" marL="0">
+              <a:buNone/>
+            </a:pPr>
+            <a:r>
+              <a:rPr lang="en-US" sz="1300" b="1" dirty="0">
+                <a:solidFill>
+                  <a:srgbClr val="FFFFFF"/>
+                </a:solidFill>
+                <a:latin typeface="Arial" pitchFamily="34" charset="0"/>
+                <a:ea typeface="Arial" pitchFamily="34" charset="-122"/>
+                <a:cs typeface="Arial" pitchFamily="34" charset="-120"/>
+              </a:rPr>
+              <a:t>2. Docker Compose</a:t>
+            </a:r>
+            <a:endParaRPr lang="en-US" sz="1300" dirty="0"/>
+          </a:p>
+        </p:txBody>
+      </p:sp>
+      <p:sp>
+        <p:nvSpPr>
+          <p:cNvPr id="15" name="Shape 13"/>
+          <p:cNvSpPr/>
+          <p:nvPr/>
+        </p:nvSpPr>
+        <p:spPr>
+          <a:xfrm>
+            <a:off x="6217006" y="2194560"/>
+            <a:ext cx="5728716" cy="1577340"/>
+          </a:xfrm>
+          <a:prstGeom prst="rect">
+            <a:avLst/>
+          </a:prstGeom>
+          <a:solidFill>
+            <a:srgbClr val="1E2A3A"/>
+          </a:solidFill>
+          <a:ln w="12700">
+            <a:solidFill>
+              <a:srgbClr val="1E2A3A"/>
+            </a:solidFill>
+            <a:prstDash val="solid"/>
+          </a:ln>
+        </p:spPr>
+      </p:sp>
+      <p:sp>
+        <p:nvSpPr>
+          <p:cNvPr id="16" name="Text 14"/>
+          <p:cNvSpPr/>
+          <p:nvPr/>
+        </p:nvSpPr>
+        <p:spPr>
+          <a:xfrm>
+            <a:off x="6338621" y="2331720"/>
+            <a:ext cx="5484571" cy="411480"/>
+          </a:xfrm>
+          <a:prstGeom prst="rect">
+            <a:avLst/>
+          </a:prstGeom>
+          <a:noFill/>
+          <a:ln/>
+        </p:spPr>
+        <p:txBody>
+          <a:bodyPr wrap="square" rtlCol="0" anchor="ctr"/>
+          <a:lstStyle/>
+          <a:p>
+            <a:pPr indent="0" marL="0">
+              <a:buNone/>
+            </a:pPr>
+            <a:r>
+              <a:rPr lang="en-US" sz="1000" dirty="0">
+                <a:solidFill>
+                  <a:srgbClr val="98D982"/>
+                </a:solidFill>
+                <a:latin typeface="Courier New" pitchFamily="34" charset="0"/>
+                <a:ea typeface="Courier New" pitchFamily="34" charset="-122"/>
+                <a:cs typeface="Courier New" pitchFamily="34" charset="-120"/>
+              </a:rPr>
+              <a:t>$ docker compose up -d</a:t>
+            </a:r>
+            <a:endParaRPr lang="en-US" sz="1000" dirty="0"/>
+          </a:p>
+        </p:txBody>
+      </p:sp>
+      <p:sp>
+        <p:nvSpPr>
+          <p:cNvPr id="17" name="Text 15"/>
+          <p:cNvSpPr/>
+          <p:nvPr/>
+        </p:nvSpPr>
+        <p:spPr>
+          <a:xfrm>
+            <a:off x="6338621" y="2811780"/>
+            <a:ext cx="5484571" cy="411480"/>
+          </a:xfrm>
+          <a:prstGeom prst="rect">
+            <a:avLst/>
+          </a:prstGeom>
+          <a:noFill/>
+          <a:ln/>
+        </p:spPr>
+        <p:txBody>
+          <a:bodyPr wrap="square" rtlCol="0" anchor="ctr"/>
+          <a:lstStyle/>
+          <a:p>
+            <a:pPr indent="0" marL="0">
+              <a:buNone/>
+            </a:pPr>
+            <a:r>
+              <a:rPr lang="en-US" sz="1000" dirty="0">
+                <a:solidFill>
+                  <a:srgbClr val="98D982"/>
+                </a:solidFill>
+                <a:latin typeface="Courier New" pitchFamily="34" charset="0"/>
+                <a:ea typeface="Courier New" pitchFamily="34" charset="-122"/>
+                <a:cs typeface="Courier New" pitchFamily="34" charset="-120"/>
+              </a:rPr>
+              <a:t>$ docker compose ps</a:t>
+            </a:r>
+            <a:endParaRPr lang="en-US" sz="1000" dirty="0"/>
+          </a:p>
+        </p:txBody>
+      </p:sp>
+      <p:sp>
+        <p:nvSpPr>
+          <p:cNvPr id="18" name="Text 16"/>
+          <p:cNvSpPr/>
+          <p:nvPr/>
+        </p:nvSpPr>
+        <p:spPr>
+          <a:xfrm>
+            <a:off x="6338621" y="3291840"/>
+            <a:ext cx="5484571" cy="411480"/>
+          </a:xfrm>
+          <a:prstGeom prst="rect">
+            <a:avLst/>
+          </a:prstGeom>
+          <a:noFill/>
+          <a:ln/>
+        </p:spPr>
+        <p:txBody>
+          <a:bodyPr wrap="square" rtlCol="0" anchor="ctr"/>
+          <a:lstStyle/>
+          <a:p>
+            <a:pPr indent="0" marL="0">
+              <a:buNone/>
+            </a:pPr>
+            <a:r>
+              <a:rPr lang="en-US" sz="1000" dirty="0">
+                <a:solidFill>
+                  <a:srgbClr val="98D982"/>
+                </a:solidFill>
+                <a:latin typeface="Courier New" pitchFamily="34" charset="0"/>
+                <a:ea typeface="Courier New" pitchFamily="34" charset="-122"/>
+                <a:cs typeface="Courier New" pitchFamily="34" charset="-120"/>
+              </a:rPr>
+              <a:t>$ curl http://localhost:80</a:t>
+            </a:r>
+            <a:endParaRPr lang="en-US" sz="1000" dirty="0"/>
+          </a:p>
+        </p:txBody>
+      </p:sp>
+      <p:sp>
+        <p:nvSpPr>
+          <p:cNvPr id="19" name="Shape 17"/>
+          <p:cNvSpPr/>
+          <p:nvPr/>
+        </p:nvSpPr>
+        <p:spPr>
+          <a:xfrm>
+            <a:off x="244145" y="3909060"/>
+            <a:ext cx="5728716" cy="685800"/>
+          </a:xfrm>
+          <a:prstGeom prst="rect">
+            <a:avLst/>
+          </a:prstGeom>
+          <a:solidFill>
+            <a:srgbClr val="4A148C"/>
+          </a:solidFill>
+          <a:ln w="12700">
+            <a:solidFill>
+              <a:srgbClr val="4A148C"/>
+            </a:solidFill>
+            <a:prstDash val="solid"/>
+          </a:ln>
+        </p:spPr>
+      </p:sp>
+      <p:sp>
+        <p:nvSpPr>
+          <p:cNvPr id="20" name="Text 18"/>
+          <p:cNvSpPr/>
+          <p:nvPr/>
+        </p:nvSpPr>
+        <p:spPr>
+          <a:xfrm>
+            <a:off x="244145" y="3909060"/>
+            <a:ext cx="5728716" cy="685800"/>
+          </a:xfrm>
+          <a:prstGeom prst="rect">
+            <a:avLst/>
+          </a:prstGeom>
+          <a:noFill/>
+          <a:ln/>
+        </p:spPr>
+        <p:txBody>
+          <a:bodyPr wrap="square" rtlCol="0" anchor="ctr"/>
+          <a:lstStyle/>
+          <a:p>
+            <a:pPr algn="ctr" indent="0" marL="0">
+              <a:buNone/>
+            </a:pPr>
+            <a:r>
+              <a:rPr lang="en-US" sz="1300" b="1" dirty="0">
+                <a:solidFill>
+                  <a:srgbClr val="FFFFFF"/>
+                </a:solidFill>
+                <a:latin typeface="Arial" pitchFamily="34" charset="0"/>
+                <a:ea typeface="Arial" pitchFamily="34" charset="-122"/>
+                <a:cs typeface="Arial" pitchFamily="34" charset="-120"/>
+              </a:rPr>
+              <a:t>3. Kubernetes</a:t>
+            </a:r>
+            <a:endParaRPr lang="en-US" sz="1300" dirty="0"/>
+          </a:p>
+        </p:txBody>
+      </p:sp>
+      <p:sp>
+        <p:nvSpPr>
+          <p:cNvPr id="21" name="Shape 19"/>
+          <p:cNvSpPr/>
+          <p:nvPr/>
+        </p:nvSpPr>
+        <p:spPr>
+          <a:xfrm>
+            <a:off x="244145" y="4594860"/>
+            <a:ext cx="5728716" cy="1577340"/>
+          </a:xfrm>
+          <a:prstGeom prst="rect">
+            <a:avLst/>
+          </a:prstGeom>
+          <a:solidFill>
+            <a:srgbClr val="1E2A3A"/>
+          </a:solidFill>
+          <a:ln w="12700">
+            <a:solidFill>
+              <a:srgbClr val="1E2A3A"/>
+            </a:solidFill>
+            <a:prstDash val="solid"/>
+          </a:ln>
+        </p:spPr>
+      </p:sp>
+      <p:sp>
+        <p:nvSpPr>
+          <p:cNvPr id="22" name="Text 20"/>
+          <p:cNvSpPr/>
+          <p:nvPr/>
+        </p:nvSpPr>
+        <p:spPr>
+          <a:xfrm>
+            <a:off x="365760" y="4732020"/>
+            <a:ext cx="5484571" cy="411480"/>
+          </a:xfrm>
+          <a:prstGeom prst="rect">
+            <a:avLst/>
+          </a:prstGeom>
+          <a:noFill/>
+          <a:ln/>
+        </p:spPr>
+        <p:txBody>
+          <a:bodyPr wrap="square" rtlCol="0" anchor="ctr"/>
+          <a:lstStyle/>
+          <a:p>
+            <a:pPr indent="0" marL="0">
+              <a:buNone/>
+            </a:pPr>
+            <a:r>
+              <a:rPr lang="en-US" sz="1000" dirty="0">
+                <a:solidFill>
+                  <a:srgbClr val="98D982"/>
+                </a:solidFill>
+                <a:latin typeface="Courier New" pitchFamily="34" charset="0"/>
+                <a:ea typeface="Courier New" pitchFamily="34" charset="-122"/>
+                <a:cs typeface="Courier New" pitchFamily="34" charset="-120"/>
+              </a:rPr>
+              <a:t>$ kubectl apply -f k8s/</a:t>
+            </a:r>
+            <a:endParaRPr lang="en-US" sz="1000" dirty="0"/>
+          </a:p>
+        </p:txBody>
+      </p:sp>
+      <p:sp>
+        <p:nvSpPr>
+          <p:cNvPr id="23" name="Text 21"/>
+          <p:cNvSpPr/>
+          <p:nvPr/>
+        </p:nvSpPr>
+        <p:spPr>
+          <a:xfrm>
+            <a:off x="365760" y="5212080"/>
+            <a:ext cx="5484571" cy="411480"/>
+          </a:xfrm>
+          <a:prstGeom prst="rect">
+            <a:avLst/>
+          </a:prstGeom>
+          <a:noFill/>
+          <a:ln/>
+        </p:spPr>
+        <p:txBody>
+          <a:bodyPr wrap="square" rtlCol="0" anchor="ctr"/>
+          <a:lstStyle/>
+          <a:p>
+            <a:pPr indent="0" marL="0">
+              <a:buNone/>
+            </a:pPr>
+            <a:r>
+              <a:rPr lang="en-US" sz="1000" dirty="0">
+                <a:solidFill>
+                  <a:srgbClr val="98D982"/>
+                </a:solidFill>
+                <a:latin typeface="Courier New" pitchFamily="34" charset="0"/>
+                <a:ea typeface="Courier New" pitchFamily="34" charset="-122"/>
+                <a:cs typeface="Courier New" pitchFamily="34" charset="-120"/>
+              </a:rPr>
+              <a:t>$ kubectl get pods,svc,hpa</a:t>
+            </a:r>
+            <a:endParaRPr lang="en-US" sz="1000" dirty="0"/>
+          </a:p>
+        </p:txBody>
+      </p:sp>
+      <p:sp>
+        <p:nvSpPr>
+          <p:cNvPr id="24" name="Text 22"/>
+          <p:cNvSpPr/>
+          <p:nvPr/>
+        </p:nvSpPr>
+        <p:spPr>
+          <a:xfrm>
+            <a:off x="365760" y="5692140"/>
+            <a:ext cx="5484571" cy="411480"/>
+          </a:xfrm>
+          <a:prstGeom prst="rect">
+            <a:avLst/>
+          </a:prstGeom>
+          <a:noFill/>
+          <a:ln/>
+        </p:spPr>
+        <p:txBody>
+          <a:bodyPr wrap="square" rtlCol="0" anchor="ctr"/>
+          <a:lstStyle/>
+          <a:p>
+            <a:pPr indent="0" marL="0">
+              <a:buNone/>
+            </a:pPr>
+            <a:r>
+              <a:rPr lang="en-US" sz="1000" dirty="0">
+                <a:solidFill>
+                  <a:srgbClr val="98D982"/>
+                </a:solidFill>
+                <a:latin typeface="Courier New" pitchFamily="34" charset="0"/>
+                <a:ea typeface="Courier New" pitchFamily="34" charset="-122"/>
+                <a:cs typeface="Courier New" pitchFamily="34" charset="-120"/>
+              </a:rPr>
+              <a:t>$ kubectl get pvc</a:t>
+            </a:r>
+            <a:endParaRPr lang="en-US" sz="1000" dirty="0"/>
+          </a:p>
+        </p:txBody>
+      </p:sp>
+      <p:sp>
+        <p:nvSpPr>
+          <p:cNvPr id="25" name="Shape 23"/>
+          <p:cNvSpPr/>
+          <p:nvPr/>
+        </p:nvSpPr>
+        <p:spPr>
+          <a:xfrm>
+            <a:off x="6217006" y="3909060"/>
+            <a:ext cx="5728716" cy="685800"/>
+          </a:xfrm>
+          <a:prstGeom prst="rect">
+            <a:avLst/>
+          </a:prstGeom>
+          <a:solidFill>
+            <a:srgbClr val="E65100"/>
+          </a:solidFill>
+          <a:ln w="12700">
+            <a:solidFill>
+              <a:srgbClr val="E65100"/>
+            </a:solidFill>
+            <a:prstDash val="solid"/>
+          </a:ln>
+        </p:spPr>
+      </p:sp>
+      <p:sp>
+        <p:nvSpPr>
+          <p:cNvPr id="26" name="Text 24"/>
+          <p:cNvSpPr/>
+          <p:nvPr/>
+        </p:nvSpPr>
+        <p:spPr>
+          <a:xfrm>
+            <a:off x="6217006" y="3909060"/>
+            <a:ext cx="5728716" cy="685800"/>
+          </a:xfrm>
+          <a:prstGeom prst="rect">
+            <a:avLst/>
+          </a:prstGeom>
+          <a:noFill/>
+          <a:ln/>
+        </p:spPr>
+        <p:txBody>
+          <a:bodyPr wrap="square" rtlCol="0" anchor="ctr"/>
+          <a:lstStyle/>
+          <a:p>
+            <a:pPr algn="ctr" indent="0" marL="0">
+              <a:buNone/>
+            </a:pPr>
+            <a:r>
+              <a:rPr lang="en-US" sz="1300" b="1" dirty="0">
+                <a:solidFill>
+                  <a:srgbClr val="FFFFFF"/>
+                </a:solidFill>
+                <a:latin typeface="Arial" pitchFamily="34" charset="0"/>
+                <a:ea typeface="Arial" pitchFamily="34" charset="-122"/>
+                <a:cs typeface="Arial" pitchFamily="34" charset="-120"/>
+              </a:rPr>
+              <a:t>4. Monitoring + Discord ✅</a:t>
+            </a:r>
+            <a:endParaRPr lang="en-US" sz="1300" dirty="0"/>
+          </a:p>
+        </p:txBody>
+      </p:sp>
+      <p:sp>
+        <p:nvSpPr>
+          <p:cNvPr id="27" name="Shape 25"/>
+          <p:cNvSpPr/>
+          <p:nvPr/>
+        </p:nvSpPr>
+        <p:spPr>
+          <a:xfrm>
+            <a:off x="6217006" y="4594860"/>
+            <a:ext cx="5728716" cy="1577340"/>
+          </a:xfrm>
+          <a:prstGeom prst="rect">
+            <a:avLst/>
+          </a:prstGeom>
+          <a:solidFill>
+            <a:srgbClr val="1E2A3A"/>
+          </a:solidFill>
+          <a:ln w="12700">
+            <a:solidFill>
+              <a:srgbClr val="1E2A3A"/>
+            </a:solidFill>
+            <a:prstDash val="solid"/>
+          </a:ln>
+        </p:spPr>
+      </p:sp>
+      <p:sp>
+        <p:nvSpPr>
+          <p:cNvPr id="28" name="Text 26"/>
+          <p:cNvSpPr/>
+          <p:nvPr/>
+        </p:nvSpPr>
+        <p:spPr>
+          <a:xfrm>
+            <a:off x="6338621" y="4732020"/>
+            <a:ext cx="5484571" cy="411480"/>
+          </a:xfrm>
+          <a:prstGeom prst="rect">
+            <a:avLst/>
+          </a:prstGeom>
+          <a:noFill/>
+          <a:ln/>
+        </p:spPr>
+        <p:txBody>
+          <a:bodyPr wrap="square" rtlCol="0" anchor="ctr"/>
+          <a:lstStyle/>
+          <a:p>
+            <a:pPr indent="0" marL="0">
+              <a:buNone/>
+            </a:pPr>
+            <a:r>
+              <a:rPr lang="en-US" sz="1000" dirty="0">
+                <a:solidFill>
+                  <a:srgbClr val="98D982"/>
+                </a:solidFill>
+                <a:latin typeface="Courier New" pitchFamily="34" charset="0"/>
+                <a:ea typeface="Courier New" pitchFamily="34" charset="-122"/>
+                <a:cs typeface="Courier New" pitchFamily="34" charset="-120"/>
+              </a:rPr>
+              <a:t>$ # Grafana : http://192.168.56.10:3000</a:t>
+            </a:r>
+            <a:endParaRPr lang="en-US" sz="1000" dirty="0"/>
+          </a:p>
+        </p:txBody>
+      </p:sp>
+      <p:sp>
+        <p:nvSpPr>
+          <p:cNvPr id="29" name="Text 27"/>
+          <p:cNvSpPr/>
+          <p:nvPr/>
+        </p:nvSpPr>
+        <p:spPr>
+          <a:xfrm>
+            <a:off x="6338621" y="5212080"/>
+            <a:ext cx="5484571" cy="411480"/>
+          </a:xfrm>
+          <a:prstGeom prst="rect">
+            <a:avLst/>
+          </a:prstGeom>
+          <a:noFill/>
+          <a:ln/>
+        </p:spPr>
+        <p:txBody>
+          <a:bodyPr wrap="square" rtlCol="0" anchor="ctr"/>
+          <a:lstStyle/>
+          <a:p>
+            <a:pPr indent="0" marL="0">
+              <a:buNone/>
+            </a:pPr>
+            <a:r>
+              <a:rPr lang="en-US" sz="1000" dirty="0">
+                <a:solidFill>
+                  <a:srgbClr val="98D982"/>
+                </a:solidFill>
+                <a:latin typeface="Courier New" pitchFamily="34" charset="0"/>
+                <a:ea typeface="Courier New" pitchFamily="34" charset="-122"/>
+                <a:cs typeface="Courier New" pitchFamily="34" charset="-120"/>
+              </a:rPr>
+              <a:t>$ docker compose stop node-exporter</a:t>
+            </a:r>
+            <a:endParaRPr lang="en-US" sz="1000" dirty="0"/>
+          </a:p>
+        </p:txBody>
+      </p:sp>
+      <p:sp>
+        <p:nvSpPr>
+          <p:cNvPr id="30" name="Text 28"/>
+          <p:cNvSpPr/>
+          <p:nvPr/>
+        </p:nvSpPr>
+        <p:spPr>
+          <a:xfrm>
+            <a:off x="6338621" y="5692140"/>
+            <a:ext cx="5484571" cy="411480"/>
+          </a:xfrm>
+          <a:prstGeom prst="rect">
+            <a:avLst/>
+          </a:prstGeom>
+          <a:noFill/>
+          <a:ln/>
+        </p:spPr>
+        <p:txBody>
+          <a:bodyPr wrap="square" rtlCol="0" anchor="ctr"/>
+          <a:lstStyle/>
+          <a:p>
+            <a:pPr indent="0" marL="0">
+              <a:buNone/>
+            </a:pPr>
+            <a:r>
+              <a:rPr lang="en-US" sz="1000" dirty="0">
+                <a:solidFill>
+                  <a:srgbClr val="98D982"/>
+                </a:solidFill>
+                <a:latin typeface="Courier New" pitchFamily="34" charset="0"/>
+                <a:ea typeface="Courier New" pitchFamily="34" charset="-122"/>
+                <a:cs typeface="Courier New" pitchFamily="34" charset="-120"/>
+              </a:rPr>
+              <a:t>$ # → Discord : alerte reçue (HTTP 204) 🔔</a:t>
+            </a:r>
+            <a:endParaRPr lang="en-US" sz="1000" dirty="0"/>
+          </a:p>
+        </p:txBody>
+      </p:sp>
+      <p:sp>
+        <p:nvSpPr>
+          <p:cNvPr id="31" name="Shape 29"/>
+          <p:cNvSpPr/>
+          <p:nvPr/>
+        </p:nvSpPr>
+        <p:spPr>
+          <a:xfrm>
+            <a:off x="244145" y="6446520"/>
+            <a:ext cx="11701577" cy="342900"/>
+          </a:xfrm>
+          <a:prstGeom prst="rect">
+            <a:avLst/>
+          </a:prstGeom>
+          <a:solidFill>
+            <a:srgbClr val="1E1E1E"/>
+          </a:solidFill>
+          <a:ln w="12700">
+            <a:solidFill>
+              <a:srgbClr val="1E1E1E"/>
+            </a:solidFill>
+            <a:prstDash val="solid"/>
+          </a:ln>
+        </p:spPr>
+      </p:sp>
+      <p:sp>
+        <p:nvSpPr>
+          <p:cNvPr id="32" name="Text 30"/>
+          <p:cNvSpPr/>
+          <p:nvPr/>
+        </p:nvSpPr>
+        <p:spPr>
+          <a:xfrm>
+            <a:off x="365760" y="6446520"/>
+            <a:ext cx="11457432" cy="342900"/>
+          </a:xfrm>
+          <a:prstGeom prst="rect">
+            <a:avLst/>
+          </a:prstGeom>
+          <a:noFill/>
+          <a:ln/>
+        </p:spPr>
+        <p:txBody>
+          <a:bodyPr wrap="square" rtlCol="0" anchor="ctr"/>
+          <a:lstStyle/>
+          <a:p>
+            <a:pPr algn="ctr" indent="0" marL="0">
+              <a:buNone/>
+            </a:pPr>
+            <a:r>
+              <a:rPr lang="en-US" sz="1000" dirty="0">
+                <a:solidFill>
+                  <a:srgbClr val="98D982"/>
+                </a:solidFill>
+                <a:latin typeface="Courier New" pitchFamily="34" charset="0"/>
+                <a:ea typeface="Courier New" pitchFamily="34" charset="-122"/>
+                <a:cs typeface="Courier New" pitchFamily="34" charset="-120"/>
+              </a:rPr>
+              <a:t>$ docker compose exec db psql -U admin -d iac_db -c 'SELECT * FROM utilisateurs;'   →  2 lignes ✅</a:t>
+            </a:r>
+            <a:endParaRPr lang="en-US" sz="1000" dirty="0"/>
+          </a:p>
+        </p:txBody>
+      </p:sp>
+    </p:spTree>
+  </p:cSld>
+  <p:clrMapOvr>
+    <a:masterClrMapping/>
+  </p:clrMapOvr>
+</p:sld>
+</file>
+
+<file path=ppt/slides/slide12.xml><?xml version="1.0" encoding="utf-8"?>
+<p:sld xmlns:a="http://schemas.openxmlformats.org/drawingml/2006/main" xmlns:r="http://schemas.openxmlformats.org/officeDocument/2006/relationships" xmlns:p="http://schemas.openxmlformats.org/presentationml/2006/main">
+  <p:cSld name="Slide 12">
     <p:spTree>
       <p:nvGrpSpPr>
         <p:cNvPr id="1" name=""/>

</xml_diff>

<commit_message>
fix(docs): correct PromQL, alert names and demo commands in presentation
- slide 7: real CPU PromQL expr + actual 3 alert names (HighCPUUsage, HighMemoryUsage, NginxDown)
- slide 11: localhost:8080, kubernetes/, localhost Grafana, testdb
- slides 9/10: k8s/ to kubernetes/
</commit_message>
<xml_diff>
--- a/documentation/Presentation_iac-infra_ASD.pptx
+++ b/documentation/Presentation_iac-infra_ASD.pptx
@@ -3935,7 +3935,7 @@
                 <a:ea typeface="Arial" pitchFamily="34" charset="-122"/>
                 <a:cs typeface="Arial" pitchFamily="34" charset="-120"/>
               </a:rPr>
-              <a:t>Vagrantfile versionné + kubectl apply -f k8s/</a:t>
+              <a:t>Vagrantfile versionné + kubectl apply -f kubernetes/</a:t>
             </a:r>
             <a:endParaRPr lang="en-US" sz="900" dirty="0"/>
           </a:p>
@@ -6025,7 +6025,7 @@
                 <a:ea typeface="Courier New" pitchFamily="34" charset="-122"/>
                 <a:cs typeface="Courier New" pitchFamily="34" charset="-120"/>
               </a:rPr>
-              <a:t>$ curl http://localhost:80</a:t>
+              <a:t>$ curl http://localhost:8080</a:t>
             </a:r>
             <a:endParaRPr lang="en-US" sz="1000" dirty="0"/>
           </a:p>
@@ -6153,7 +6153,7 @@
                 <a:ea typeface="Courier New" pitchFamily="34" charset="-122"/>
                 <a:cs typeface="Courier New" pitchFamily="34" charset="-120"/>
               </a:rPr>
-              <a:t>$ kubectl apply -f k8s/</a:t>
+              <a:t>$ kubectl apply -f kubernetes/</a:t>
             </a:r>
             <a:endParaRPr lang="en-US" sz="1000" dirty="0"/>
           </a:p>
@@ -6359,7 +6359,7 @@
                 <a:ea typeface="Courier New" pitchFamily="34" charset="-122"/>
                 <a:cs typeface="Courier New" pitchFamily="34" charset="-120"/>
               </a:rPr>
-              <a:t>$ # Grafana : http://192.168.56.10:3000</a:t>
+              <a:t>$ # Grafana : http://localhost:3000</a:t>
             </a:r>
             <a:endParaRPr lang="en-US" sz="1000" dirty="0"/>
           </a:p>
@@ -6501,7 +6501,7 @@
                 <a:ea typeface="Courier New" pitchFamily="34" charset="-122"/>
                 <a:cs typeface="Courier New" pitchFamily="34" charset="-120"/>
               </a:rPr>
-              <a:t>$ docker compose exec db psql -U admin -d iac_db -c 'SELECT * FROM utilisateurs;'   →  2 lignes ✅</a:t>
+              <a:t>$ docker compose exec db psql -U admin -d testdb -c 'SELECT * FROM utilisateurs;'   →  2 lignes ✅</a:t>
             </a:r>
             <a:endParaRPr lang="en-US" sz="1000" dirty="0"/>
           </a:p>
@@ -15240,7 +15240,7 @@
                 <a:ea typeface="Arial" pitchFamily="34" charset="-122"/>
                 <a:cs typeface="Arial" pitchFamily="34" charset="-120"/>
               </a:rPr>
-              <a:t>Règles alertes : InstanceDown · HighMemory · NginxDown · DiskSpaceLow</a:t>
+              <a:t>3 règles d'alertes : HighCPUUsage · HighMemoryUsage · NginxDown</a:t>
             </a:r>
             <a:endParaRPr lang="en-US" sz="1100" dirty="0"/>
           </a:p>
@@ -15304,7 +15304,7 @@
                 <a:ea typeface="Arial" pitchFamily="34" charset="-122"/>
                 <a:cs typeface="Arial" pitchFamily="34" charset="-120"/>
               </a:rPr>
-              <a:t>PromQL : avg(rate(node_cpu_seconds_total[5m])) * 100</a:t>
+              <a:t>PromQL CPU : 100 - (avg by(instance)(rate(node_cpu_seconds_total{mode="idle"}[2m])) * 100) &gt; 80</a:t>
             </a:r>
             <a:endParaRPr lang="en-US" sz="1100" dirty="0"/>
           </a:p>
@@ -19926,7 +19926,7 @@
                           <a:ea typeface="Arial" pitchFamily="34" charset="-122"/>
                           <a:cs typeface="Arial" pitchFamily="34" charset="-120"/>
                         </a:rPr>
-                        <a:t>kubectl apply -f k8s/</a:t>
+                        <a:t>kubectl apply -f kubernetes/</a:t>
                       </a:r>
                       <a:endParaRPr lang="en-US" sz="1000" dirty="0">
                         <a:latin typeface="Arial" charset="0"/>

</xml_diff>

<commit_message>
docs(pptx): update presentation for WordPress + MariaDB deployment
</commit_message>
<xml_diff>
--- a/documentation/Presentation_iac-infra_ASD.pptx
+++ b/documentation/Presentation_iac-infra_ASD.pptx
@@ -4241,7 +4241,7 @@
                 <a:ea typeface="Arial" pitchFamily="34" charset="-122"/>
                 <a:cs typeface="Arial" pitchFamily="34" charset="-120"/>
               </a:rPr>
-              <a:t>PVC PostgreSQL + init_db/schema.sql</a:t>
+              <a:t>PVC MariaDB + PVC wp-content</a:t>
             </a:r>
             <a:endParaRPr lang="en-US" sz="900" dirty="0"/>
           </a:p>
@@ -4586,7 +4586,7 @@
                 <a:ea typeface="Arial" pitchFamily="34" charset="-122"/>
                 <a:cs typeface="Arial" pitchFamily="34" charset="-120"/>
               </a:rPr>
-              <a:t>pilot-loicrich/iac-nginx:latest sur Docker Hub</a:t>
+              <a:t>lnanzotonlieu/iac-wordpress:latest sur Docker Hub</a:t>
             </a:r>
             <a:endParaRPr lang="en-US" sz="900" dirty="0"/>
           </a:p>
@@ -6501,7 +6501,7 @@
                 <a:ea typeface="Courier New" pitchFamily="34" charset="-122"/>
                 <a:cs typeface="Courier New" pitchFamily="34" charset="-120"/>
               </a:rPr>
-              <a:t>$ docker compose exec db psql -U admin -d testdb -c 'SELECT * FROM utilisateurs;'   →  2 lignes ✅</a:t>
+              <a:t>$ docker compose exec db sh -c 'mysql -uroot -p... -e "SHOW TABLES" wordpress'   →  tables WordPress ✅</a:t>
             </a:r>
             <a:endParaRPr lang="en-US" sz="1000" dirty="0"/>
           </a:p>
@@ -9858,7 +9858,7 @@
                 <a:ea typeface="Arial" pitchFamily="34" charset="-122"/>
                 <a:cs typeface="Arial" pitchFamily="34" charset="-120"/>
               </a:rPr>
-              <a:t>Nginx :80</a:t>
+              <a:t>WordPress :80</a:t>
             </a:r>
             <a:endParaRPr lang="en-US" sz="1000" dirty="0"/>
           </a:p>
@@ -10224,7 +10224,7 @@
                 <a:ea typeface="Arial" pitchFamily="34" charset="-122"/>
                 <a:cs typeface="Arial" pitchFamily="34" charset="-120"/>
               </a:rPr>
-              <a:t>Nginx</a:t>
+              <a:t>WordPress</a:t>
             </a:r>
             <a:endParaRPr lang="en-US" sz="1000" dirty="0"/>
           </a:p>
@@ -10311,7 +10311,7 @@
                 <a:ea typeface="Arial" pitchFamily="34" charset="-122"/>
                 <a:cs typeface="Arial" pitchFamily="34" charset="-120"/>
               </a:rPr>
-              <a:t>PostgreSQL</a:t>
+              <a:t>MariaDB</a:t>
             </a:r>
             <a:endParaRPr lang="en-US" sz="1000" dirty="0"/>
           </a:p>
@@ -11513,7 +11513,7 @@
                 <a:ea typeface="Arial" pitchFamily="34" charset="-122"/>
                 <a:cs typeface="Arial" pitchFamily="34" charset="-120"/>
               </a:rPr>
-              <a:t>⚙️  Ansible — 3 rôles</a:t>
+              <a:t>⚙️  Ansible — 4 rôles</a:t>
             </a:r>
             <a:endParaRPr lang="en-US" sz="1300" dirty="0"/>
           </a:p>
@@ -11602,7 +11602,7 @@
                 <a:ea typeface="Arial" pitchFamily="34" charset="-122"/>
                 <a:cs typeface="Arial" pitchFamily="34" charset="-120"/>
               </a:rPr>
-              <a:t>common → Nginx installé + démarré</a:t>
+              <a:t>common → paquets de base</a:t>
             </a:r>
             <a:endParaRPr lang="en-US" sz="1100" dirty="0"/>
           </a:p>
@@ -11730,7 +11730,7 @@
                 <a:ea typeface="Arial" pitchFamily="34" charset="-122"/>
                 <a:cs typeface="Arial" pitchFamily="34" charset="-120"/>
               </a:rPr>
-              <a:t>monitoring → Docker + systemd</a:t>
+              <a:t>monitoring → Docker + stack</a:t>
             </a:r>
             <a:endParaRPr lang="en-US" sz="1100" dirty="0"/>
           </a:p>
@@ -11794,7 +11794,7 @@
                 <a:ea typeface="Arial" pitchFamily="34" charset="-122"/>
                 <a:cs typeface="Arial" pitchFamily="34" charset="-120"/>
               </a:rPr>
-              <a:t>Idempotent (rejouable ∞)</a:t>
+              <a:t>webapp → WordPress + MariaDB</a:t>
             </a:r>
             <a:endParaRPr lang="en-US" sz="1100" dirty="0"/>
           </a:p>
@@ -12573,7 +12573,7 @@
                 <a:ea typeface="Arial" pitchFamily="34" charset="-122"/>
                 <a:cs typeface="Arial" pitchFamily="34" charset="-120"/>
               </a:rPr>
-              <a:t>🐳  Docker Compose — 6 services</a:t>
+              <a:t>🐳  Docker Compose — WordPress + monitoring</a:t>
             </a:r>
             <a:endParaRPr lang="en-US" sz="1300" dirty="0"/>
           </a:p>
@@ -12656,7 +12656,7 @@
                 <a:ea typeface="Arial" pitchFamily="34" charset="-122"/>
                 <a:cs typeface="Arial" pitchFamily="34" charset="-120"/>
               </a:rPr>
-              <a:t>Nginx (Dockerfile custom)</a:t>
+              <a:t>WordPress (image custom)</a:t>
             </a:r>
             <a:endParaRPr lang="en-US" sz="900" dirty="0"/>
           </a:p>
@@ -12739,7 +12739,7 @@
                 <a:ea typeface="Arial" pitchFamily="34" charset="-122"/>
                 <a:cs typeface="Arial" pitchFamily="34" charset="-120"/>
               </a:rPr>
-              <a:t>PostgreSQL 15 + init_db/</a:t>
+              <a:t>MariaDB 11 (base wordpress)</a:t>
             </a:r>
             <a:endParaRPr lang="en-US" sz="900" dirty="0"/>
           </a:p>
@@ -13460,7 +13460,7 @@
                           <a:ea typeface="Arial" pitchFamily="34" charset="-122"/>
                           <a:cs typeface="Arial" pitchFamily="34" charset="-120"/>
                         </a:rPr>
-                        <a:t>Nginx</a:t>
+                        <a:t>WordPress</a:t>
                       </a:r>
                       <a:endParaRPr lang="en-US" sz="1000" dirty="0">
                         <a:latin typeface="Arial" charset="0"/>
@@ -13872,7 +13872,7 @@
                           <a:ea typeface="Arial" pitchFamily="34" charset="-122"/>
                           <a:cs typeface="Arial" pitchFamily="34" charset="-120"/>
                         </a:rPr>
-                        <a:t>PostgreSQL</a:t>
+                        <a:t>MariaDB</a:t>
                       </a:r>
                       <a:endParaRPr lang="en-US" sz="1000" dirty="0">
                         <a:latin typeface="Arial" charset="0"/>
@@ -14078,7 +14078,7 @@
                           <a:ea typeface="Arial" pitchFamily="34" charset="-122"/>
                           <a:cs typeface="Arial" pitchFamily="34" charset="-120"/>
                         </a:rPr>
-                        <a:t>Nginx</a:t>
+                        <a:t>WordPress</a:t>
                       </a:r>
                       <a:endParaRPr lang="en-US" sz="1000" dirty="0">
                         <a:latin typeface="Arial" charset="0"/>
@@ -14689,7 +14689,7 @@
                 <a:ea typeface="Arial" pitchFamily="34" charset="-122"/>
                 <a:cs typeface="Arial" pitchFamily="34" charset="-120"/>
               </a:rPr>
-              <a:t>pilot-loicrich/iac-nginx</a:t>
+              <a:t>lnanzotonlieu/iac-wordpress</a:t>
             </a:r>
             <a:endParaRPr lang="en-US" sz="900" dirty="0"/>
           </a:p>
@@ -15176,7 +15176,7 @@
                 <a:ea typeface="Arial" pitchFamily="34" charset="-122"/>
                 <a:cs typeface="Arial" pitchFamily="34" charset="-120"/>
               </a:rPr>
-              <a:t>4 scrape targets : prometheus · node-exporter · Nginx · alertmanager</a:t>
+              <a:t>4 scrape targets : prometheus · node-exporter · mysqld-exporter · alertmanager</a:t>
             </a:r>
             <a:endParaRPr lang="en-US" sz="1100" dirty="0"/>
           </a:p>
@@ -16192,7 +16192,7 @@
                 <a:ea typeface="Arial" pitchFamily="34" charset="-122"/>
                 <a:cs typeface="Arial" pitchFamily="34" charset="-120"/>
               </a:rPr>
-              <a:t>🐘  PostgreSQL 15 — init automatique : init_db/schema.sql monté dans /docker-entrypoint-initdb.d:ro</a:t>
+              <a:t>🐬  MariaDB 11 — base WordPress, identifiants via secret, exporter mysqld pour les métriques</a:t>
             </a:r>
             <a:endParaRPr lang="en-US" sz="1200" dirty="0"/>
           </a:p>
@@ -16256,7 +16256,7 @@
                 <a:ea typeface="Courier New" pitchFamily="34" charset="-122"/>
                 <a:cs typeface="Courier New" pitchFamily="34" charset="-120"/>
               </a:rPr>
-              <a:t>CREATE TABLE IF NOT EXISTS public.utilisateurs ( id SERIAL PRIMARY KEY, nom VARCHAR(50), email VARCHAR(100) UNIQUE NOT NULL );</a:t>
+              <a:t>-- Base 'wordpress' creee automatiquement par MariaDB (variables MARIADB_*)</a:t>
             </a:r>
             <a:endParaRPr lang="en-US" sz="900" dirty="0"/>
           </a:p>
@@ -16273,7 +16273,7 @@
                 <a:ea typeface="Courier New" pitchFamily="34" charset="-122"/>
                 <a:cs typeface="Courier New" pitchFamily="34" charset="-120"/>
               </a:rPr>
-              <a:t>INSERT INTO public.utilisateurs (nom, email) VALUES ('Loic','loic@test.com'),('Admin','admin@test.com')  ON CONFLICT (email) DO NOTHING;</a:t>
+              <a:t>-- WordPress genere son propre schema a l'installation : wp_users, wp_posts, wp_options...</a:t>
             </a:r>
             <a:endParaRPr lang="en-US" sz="900" dirty="0"/>
           </a:p>
@@ -17437,7 +17437,7 @@
                 <a:ea typeface="Arial" pitchFamily="34" charset="-122"/>
                 <a:cs typeface="Arial" pitchFamily="34" charset="-120"/>
               </a:rPr>
-              <a:t>Initialisation PostgreSQL</a:t>
+              <a:t>Application réelle déployée</a:t>
             </a:r>
             <a:endParaRPr lang="en-US" sz="1400" dirty="0"/>
           </a:p>
@@ -17540,7 +17540,7 @@
                 <a:ea typeface="Arial" pitchFamily="34" charset="-122"/>
                 <a:cs typeface="Arial" pitchFamily="34" charset="-120"/>
               </a:rPr>
-              <a:t>Répertoire init_db/ inexistant</a:t>
+              <a:t>Page Nginx vide (pas d'app réelle)</a:t>
             </a:r>
             <a:endParaRPr lang="en-US" sz="900" dirty="0"/>
           </a:p>
@@ -17557,7 +17557,7 @@
                 <a:ea typeface="Arial" pitchFamily="34" charset="-122"/>
                 <a:cs typeface="Arial" pitchFamily="34" charset="-120"/>
               </a:rPr>
-              <a:t>Aucun script SQL d'initialisation</a:t>
+              <a:t>Base PostgreSQL de test uniquement</a:t>
             </a:r>
             <a:endParaRPr lang="en-US" sz="900" dirty="0"/>
           </a:p>
@@ -17574,7 +17574,7 @@
                 <a:ea typeface="Arial" pitchFamily="34" charset="-122"/>
                 <a:cs typeface="Arial" pitchFamily="34" charset="-120"/>
               </a:rPr>
-              <a:t>Volume non monté</a:t>
+              <a:t>« boîte vide » (retour formateur)</a:t>
             </a:r>
             <a:endParaRPr lang="en-US" sz="900" dirty="0"/>
           </a:p>
@@ -17716,7 +17716,7 @@
                 <a:ea typeface="Arial" pitchFamily="34" charset="-122"/>
                 <a:cs typeface="Arial" pitchFamily="34" charset="-120"/>
               </a:rPr>
-              <a:t>init_db/schema.sql créé</a:t>
+              <a:t>WordPress déployé (Docker + K8s)</a:t>
             </a:r>
             <a:endParaRPr lang="en-US" sz="900" dirty="0"/>
           </a:p>
@@ -17733,7 +17733,7 @@
                 <a:ea typeface="Arial" pitchFamily="34" charset="-122"/>
                 <a:cs typeface="Arial" pitchFamily="34" charset="-120"/>
               </a:rPr>
-              <a:t>INSERT ON CONFLICT DO NOTHING</a:t>
+              <a:t>MariaDB + image WordPress durcie</a:t>
             </a:r>
             <a:endParaRPr lang="en-US" sz="900" dirty="0"/>
           </a:p>
@@ -17750,7 +17750,7 @@
                 <a:ea typeface="Arial" pitchFamily="34" charset="-122"/>
                 <a:cs typeface="Arial" pitchFamily="34" charset="-120"/>
               </a:rPr>
-              <a:t>Mount docker-compose ajouté</a:t>
+              <a:t>Haute dispo : 2 réplicas + HPA + PVC</a:t>
             </a:r>
             <a:endParaRPr lang="en-US" sz="900" dirty="0"/>
           </a:p>
@@ -17767,7 +17767,7 @@
                 <a:ea typeface="Arial" pitchFamily="34" charset="-122"/>
                 <a:cs typeface="Arial" pitchFamily="34" charset="-120"/>
               </a:rPr>
-              <a:t>Documentation README mise à jour</a:t>
+              <a:t>Supervision via mysqld-exporter</a:t>
             </a:r>
             <a:endParaRPr lang="en-US" sz="900" dirty="0"/>
           </a:p>
@@ -20886,7 +20886,7 @@
                           <a:ea typeface="Arial" pitchFamily="34" charset="-122"/>
                           <a:cs typeface="Arial" pitchFamily="34" charset="-120"/>
                         </a:rPr>
-                        <a:t>PostgreSQL init auto + PVC persistant</a:t>
+                        <a:t>MariaDB + PVC persistant (WordPress)</a:t>
                       </a:r>
                       <a:endParaRPr lang="en-US" sz="1000" dirty="0">
                         <a:latin typeface="Arial" charset="0"/>
@@ -21022,7 +21022,7 @@
                           <a:ea typeface="Arial" pitchFamily="34" charset="-122"/>
                           <a:cs typeface="Arial" pitchFamily="34" charset="-120"/>
                         </a:rPr>
-                        <a:t>init_db/schema.sql monté</a:t>
+                        <a:t>base wordpress auto-initialisée</a:t>
                       </a:r>
                       <a:endParaRPr lang="en-US" sz="1000" dirty="0">
                         <a:latin typeface="Arial" charset="0"/>

</xml_diff>

<commit_message>
docs: rename NginxDown -> InstanceDown in pptx and DP (consistency with code)
</commit_message>
<xml_diff>
--- a/documentation/Presentation_iac-infra_ASD.pptx
+++ b/documentation/Presentation_iac-infra_ASD.pptx
@@ -15240,7 +15240,7 @@
                 <a:ea typeface="Arial" pitchFamily="34" charset="-122"/>
                 <a:cs typeface="Arial" pitchFamily="34" charset="-120"/>
               </a:rPr>
-              <a:t>3 règles d'alertes : HighCPUUsage · HighMemoryUsage · NginxDown</a:t>
+              <a:t>3 règles d'alertes : HighCPUUsage · HighMemoryUsage · InstanceDown</a:t>
             </a:r>
             <a:endParaRPr lang="en-US" sz="1100" dirty="0"/>
           </a:p>
@@ -15579,7 +15579,7 @@
                 <a:ea typeface="Arial" pitchFamily="34" charset="-122"/>
                 <a:cs typeface="Arial" pitchFamily="34" charset="-120"/>
               </a:rPr>
-              <a:t>(ex: NginxDown)</a:t>
+              <a:t>(ex: InstanceDown)</a:t>
             </a:r>
             <a:endParaRPr lang="en-US" sz="900" dirty="0"/>
           </a:p>

</xml_diff>

<commit_message>
docs(pptx): add 4 depth slides (methodology, security, challenges, watch) -> 16 slides
Co-Authored-By: Claude Opus 4.8 <noreply@anthropic.com>
</commit_message>
<xml_diff>
--- a/documentation/Presentation_iac-infra_ASD.pptx
+++ b/documentation/Presentation_iac-infra_ASD.pptx
@@ -8,14 +8,18 @@
     <p:sldId id="256" r:id="rId2"/>
     <p:sldId id="257" r:id="rId3"/>
     <p:sldId id="258" r:id="rId4"/>
+    <p:sldId id="268" r:id="rId19"/>
     <p:sldId id="259" r:id="rId5"/>
     <p:sldId id="260" r:id="rId6"/>
     <p:sldId id="261" r:id="rId7"/>
     <p:sldId id="262" r:id="rId8"/>
+    <p:sldId id="269" r:id="rId20"/>
     <p:sldId id="263" r:id="rId9"/>
+    <p:sldId id="270" r:id="rId21"/>
     <p:sldId id="264" r:id="rId10"/>
     <p:sldId id="265" r:id="rId11"/>
     <p:sldId id="266" r:id="rId12"/>
+    <p:sldId id="271" r:id="rId22"/>
     <p:sldId id="267" r:id="rId13"/>
   </p:sldIdLst>
   <p:notesMasterIdLst>
@@ -7084,6 +7088,3326 @@
               <a:t>Questions ?</a:t>
             </a:r>
             <a:endParaRPr lang="en-US" sz="2800" dirty="0"/>
+          </a:p>
+        </p:txBody>
+      </p:sp>
+    </p:spTree>
+  </p:cSld>
+  <p:clrMapOvr>
+    <a:masterClrMapping/>
+  </p:clrMapOvr>
+</p:sld>
+</file>
+
+<file path=ppt/slides/slide13.xml><?xml version="1.0" encoding="utf-8"?>
+<p:sld xmlns:a="http://schemas.openxmlformats.org/drawingml/2006/main" xmlns:r="http://schemas.openxmlformats.org/officeDocument/2006/relationships" xmlns:p="http://schemas.openxmlformats.org/presentationml/2006/main">
+  <p:cSld>
+    <p:spTree>
+      <p:nvGrpSpPr>
+        <p:cNvPr id="1" name=""/>
+        <p:cNvGrpSpPr/>
+        <p:nvPr/>
+      </p:nvGrpSpPr>
+      <p:grpSpPr>
+        <a:xfrm>
+          <a:off x="0" y="0"/>
+          <a:ext cx="0" cy="0"/>
+          <a:chOff x="0" y="0"/>
+          <a:chExt cx="0" cy="0"/>
+        </a:xfrm>
+      </p:grpSpPr>
+      <p:sp>
+        <p:nvSpPr>
+          <p:cNvPr id="2" name="S2"/>
+          <p:cNvSpPr/>
+          <p:nvPr/>
+        </p:nvSpPr>
+        <p:spPr>
+          <a:xfrm>
+            <a:off x="0" y="0"/>
+            <a:ext cx="12192000" cy="6858000"/>
+          </a:xfrm>
+          <a:prstGeom prst="rect">
+            <a:avLst/>
+          </a:prstGeom>
+          <a:solidFill>
+            <a:srgbClr val="F5F5F5"/>
+          </a:solidFill>
+          <a:ln w="12700">
+            <a:solidFill>
+              <a:srgbClr val="F5F5F5"/>
+            </a:solidFill>
+            <a:prstDash val="solid"/>
+          </a:ln>
+        </p:spPr>
+      </p:sp>
+      <p:sp>
+        <p:nvSpPr>
+          <p:cNvPr id="3" name="S3"/>
+          <p:cNvSpPr/>
+          <p:nvPr/>
+        </p:nvSpPr>
+        <p:spPr>
+          <a:xfrm>
+            <a:off x="0" y="0"/>
+            <a:ext cx="12192000" cy="1234440"/>
+          </a:xfrm>
+          <a:prstGeom prst="rect">
+            <a:avLst/>
+          </a:prstGeom>
+          <a:solidFill>
+            <a:srgbClr val="1A237E"/>
+          </a:solidFill>
+          <a:ln w="12700">
+            <a:solidFill>
+              <a:srgbClr val="1A237E"/>
+            </a:solidFill>
+            <a:prstDash val="solid"/>
+          </a:ln>
+        </p:spPr>
+      </p:sp>
+      <p:sp>
+        <p:nvSpPr>
+          <p:cNvPr id="4" name="S4"/>
+          <p:cNvSpPr/>
+          <p:nvPr/>
+        </p:nvSpPr>
+        <p:spPr>
+          <a:xfrm>
+            <a:off x="0" y="1234440"/>
+            <a:ext cx="12192000" cy="102870"/>
+          </a:xfrm>
+          <a:prstGeom prst="rect">
+            <a:avLst/>
+          </a:prstGeom>
+          <a:solidFill>
+            <a:srgbClr val="1565C0"/>
+          </a:solidFill>
+          <a:ln w="12700">
+            <a:solidFill>
+              <a:srgbClr val="1565C0"/>
+            </a:solidFill>
+            <a:prstDash val="solid"/>
+          </a:ln>
+        </p:spPr>
+      </p:sp>
+      <p:sp>
+        <p:nvSpPr>
+          <p:cNvPr id="5" name="T5"/>
+          <p:cNvSpPr/>
+          <p:nvPr/>
+        </p:nvSpPr>
+        <p:spPr>
+          <a:xfrm>
+            <a:off x="243840" y="137160"/>
+            <a:ext cx="9753600" cy="822960"/>
+          </a:xfrm>
+          <a:prstGeom prst="rect">
+            <a:avLst/>
+          </a:prstGeom>
+          <a:noFill/>
+          <a:ln/>
+        </p:spPr>
+        <p:txBody>
+          <a:bodyPr wrap="square" rtlCol="0" anchor="ctr"/>
+          <a:lstStyle/>
+          <a:p>
+            <a:pPr indent="0" marL="0">
+              <a:buNone/>
+            </a:pPr>
+            <a:r>
+              <a:rPr lang="fr-FR" sz="2600" b="1" dirty="0">
+                <a:solidFill>
+                  <a:srgbClr val="FFFFFF"/>
+                </a:solidFill>
+                <a:latin typeface="Arial" pitchFamily="34" charset="0"/>
+                <a:ea typeface="Arial" pitchFamily="34" charset="-122"/>
+                <a:cs typeface="Arial" pitchFamily="34" charset="-120"/>
+              </a:rPr>
+              <a:t>Démarche &amp; méthodologie</a:t>
+            </a:r>
+          </a:p>
+        </p:txBody>
+      </p:sp>
+      <p:sp>
+        <p:nvSpPr>
+          <p:cNvPr id="6" name="T6"/>
+          <p:cNvSpPr/>
+          <p:nvPr/>
+        </p:nvSpPr>
+        <p:spPr>
+          <a:xfrm>
+            <a:off x="243840" y="685800"/>
+            <a:ext cx="9753600" cy="548640"/>
+          </a:xfrm>
+          <a:prstGeom prst="rect">
+            <a:avLst/>
+          </a:prstGeom>
+          <a:noFill/>
+          <a:ln/>
+        </p:spPr>
+        <p:txBody>
+          <a:bodyPr wrap="square" rtlCol="0" anchor="ctr"/>
+          <a:lstStyle/>
+          <a:p>
+            <a:pPr indent="0" marL="0">
+              <a:buNone/>
+            </a:pPr>
+            <a:r>
+              <a:rPr lang="fr-FR" sz="1300" i="1" dirty="0">
+                <a:solidFill>
+                  <a:srgbClr val="AACCFF"/>
+                </a:solidFill>
+                <a:latin typeface="Arial" pitchFamily="34" charset="0"/>
+                <a:ea typeface="Arial" pitchFamily="34" charset="-122"/>
+                <a:cs typeface="Arial" pitchFamily="34" charset="-120"/>
+              </a:rPr>
+              <a:t>14 sprints · Git · Conventional Commits · qualité automatisée</a:t>
+            </a:r>
+          </a:p>
+        </p:txBody>
+      </p:sp>
+      <p:sp>
+        <p:nvSpPr>
+          <p:cNvPr id="7" name="S7"/>
+          <p:cNvSpPr/>
+          <p:nvPr/>
+        </p:nvSpPr>
+        <p:spPr>
+          <a:xfrm>
+            <a:off x="243840" y="1508760"/>
+            <a:ext cx="5730240" cy="617220"/>
+          </a:xfrm>
+          <a:prstGeom prst="rect">
+            <a:avLst/>
+          </a:prstGeom>
+          <a:solidFill>
+            <a:srgbClr val="1565C0"/>
+          </a:solidFill>
+          <a:ln w="12700">
+            <a:solidFill>
+              <a:srgbClr val="1565C0"/>
+            </a:solidFill>
+            <a:prstDash val="solid"/>
+          </a:ln>
+        </p:spPr>
+      </p:sp>
+      <p:sp>
+        <p:nvSpPr>
+          <p:cNvPr id="8" name="T8"/>
+          <p:cNvSpPr/>
+          <p:nvPr/>
+        </p:nvSpPr>
+        <p:spPr>
+          <a:xfrm>
+            <a:off x="365760" y="1508760"/>
+            <a:ext cx="5486400" cy="617220"/>
+          </a:xfrm>
+          <a:prstGeom prst="rect">
+            <a:avLst/>
+          </a:prstGeom>
+          <a:noFill/>
+          <a:ln/>
+        </p:spPr>
+        <p:txBody>
+          <a:bodyPr wrap="square" rtlCol="0" anchor="ctr"/>
+          <a:lstStyle/>
+          <a:p>
+            <a:pPr indent="0" marL="0">
+              <a:buNone/>
+            </a:pPr>
+            <a:r>
+              <a:rPr lang="fr-FR" sz="1200" b="1" dirty="0">
+                <a:solidFill>
+                  <a:srgbClr val="FFFFFF"/>
+                </a:solidFill>
+                <a:latin typeface="Arial" pitchFamily="34" charset="0"/>
+                <a:ea typeface="Arial" pitchFamily="34" charset="-122"/>
+                <a:cs typeface="Arial" pitchFamily="34" charset="-120"/>
+              </a:rPr>
+              <a:t>Gestion de version</a:t>
+            </a:r>
+          </a:p>
+        </p:txBody>
+      </p:sp>
+      <p:sp>
+        <p:nvSpPr>
+          <p:cNvPr id="9" name="S9"/>
+          <p:cNvSpPr/>
+          <p:nvPr/>
+        </p:nvSpPr>
+        <p:spPr>
+          <a:xfrm>
+            <a:off x="243840" y="2125980"/>
+            <a:ext cx="5730240" cy="1783080"/>
+          </a:xfrm>
+          <a:prstGeom prst="rect">
+            <a:avLst/>
+          </a:prstGeom>
+          <a:solidFill>
+            <a:srgbClr val="FFFFFF"/>
+          </a:solidFill>
+          <a:ln w="12700">
+            <a:solidFill>
+              <a:srgbClr val="DDDDDD"/>
+            </a:solidFill>
+            <a:prstDash val="solid"/>
+          </a:ln>
+        </p:spPr>
+      </p:sp>
+      <p:sp>
+        <p:nvSpPr>
+          <p:cNvPr id="10" name="T10"/>
+          <p:cNvSpPr/>
+          <p:nvPr/>
+        </p:nvSpPr>
+        <p:spPr>
+          <a:xfrm>
+            <a:off x="365760" y="2228850"/>
+            <a:ext cx="5486400" cy="1577340"/>
+          </a:xfrm>
+          <a:prstGeom prst="rect">
+            <a:avLst/>
+          </a:prstGeom>
+          <a:noFill/>
+          <a:ln/>
+        </p:spPr>
+        <p:txBody>
+          <a:bodyPr wrap="square" rtlCol="0" anchor="t"/>
+          <a:lstStyle/>
+          <a:p>
+            <a:pPr indent="0" marL="0">
+              <a:buNone/>
+            </a:pPr>
+            <a:r>
+              <a:rPr lang="fr-FR" sz="1000" dirty="0">
+                <a:solidFill>
+                  <a:srgbClr val="222222"/>
+                </a:solidFill>
+                <a:latin typeface="Arial" pitchFamily="34" charset="0"/>
+                <a:ea typeface="Arial" pitchFamily="34" charset="-122"/>
+                <a:cs typeface="Arial" pitchFamily="34" charset="-120"/>
+              </a:rPr>
+              <a:t>• Git + GitHub</a:t>
+            </a:r>
+          </a:p>
+          <a:p>
+            <a:pPr indent="0" marL="0">
+              <a:buNone/>
+            </a:pPr>
+            <a:r>
+              <a:rPr lang="fr-FR" sz="1000" dirty="0">
+                <a:solidFill>
+                  <a:srgbClr val="222222"/>
+                </a:solidFill>
+                <a:latin typeface="Arial" pitchFamily="34" charset="0"/>
+                <a:ea typeface="Arial" pitchFamily="34" charset="-122"/>
+                <a:cs typeface="Arial" pitchFamily="34" charset="-120"/>
+              </a:rPr>
+              <a:t>• Conventional Commits (feat / fix / docs)</a:t>
+            </a:r>
+          </a:p>
+          <a:p>
+            <a:pPr indent="0" marL="0">
+              <a:buNone/>
+            </a:pPr>
+            <a:r>
+              <a:rPr lang="fr-FR" sz="1000" dirty="0">
+                <a:solidFill>
+                  <a:srgbClr val="222222"/>
+                </a:solidFill>
+                <a:latin typeface="Arial" pitchFamily="34" charset="0"/>
+                <a:ea typeface="Arial" pitchFamily="34" charset="-122"/>
+                <a:cs typeface="Arial" pitchFamily="34" charset="-120"/>
+              </a:rPr>
+              <a:t>• Branches + Pull Requests</a:t>
+            </a:r>
+          </a:p>
+        </p:txBody>
+      </p:sp>
+      <p:sp>
+        <p:nvSpPr>
+          <p:cNvPr id="11" name="S11"/>
+          <p:cNvSpPr/>
+          <p:nvPr/>
+        </p:nvSpPr>
+        <p:spPr>
+          <a:xfrm>
+            <a:off x="6217920" y="1508760"/>
+            <a:ext cx="5730240" cy="617220"/>
+          </a:xfrm>
+          <a:prstGeom prst="rect">
+            <a:avLst/>
+          </a:prstGeom>
+          <a:solidFill>
+            <a:srgbClr val="00695C"/>
+          </a:solidFill>
+          <a:ln w="12700">
+            <a:solidFill>
+              <a:srgbClr val="00695C"/>
+            </a:solidFill>
+            <a:prstDash val="solid"/>
+          </a:ln>
+        </p:spPr>
+      </p:sp>
+      <p:sp>
+        <p:nvSpPr>
+          <p:cNvPr id="12" name="T12"/>
+          <p:cNvSpPr/>
+          <p:nvPr/>
+        </p:nvSpPr>
+        <p:spPr>
+          <a:xfrm>
+            <a:off x="6339840" y="1508760"/>
+            <a:ext cx="5486400" cy="617220"/>
+          </a:xfrm>
+          <a:prstGeom prst="rect">
+            <a:avLst/>
+          </a:prstGeom>
+          <a:noFill/>
+          <a:ln/>
+        </p:spPr>
+        <p:txBody>
+          <a:bodyPr wrap="square" rtlCol="0" anchor="ctr"/>
+          <a:lstStyle/>
+          <a:p>
+            <a:pPr indent="0" marL="0">
+              <a:buNone/>
+            </a:pPr>
+            <a:r>
+              <a:rPr lang="fr-FR" sz="1200" b="1" dirty="0">
+                <a:solidFill>
+                  <a:srgbClr val="FFFFFF"/>
+                </a:solidFill>
+                <a:latin typeface="Arial" pitchFamily="34" charset="0"/>
+                <a:ea typeface="Arial" pitchFamily="34" charset="-122"/>
+                <a:cs typeface="Arial" pitchFamily="34" charset="-120"/>
+              </a:rPr>
+              <a:t>Développement itératif</a:t>
+            </a:r>
+          </a:p>
+        </p:txBody>
+      </p:sp>
+      <p:sp>
+        <p:nvSpPr>
+          <p:cNvPr id="13" name="S13"/>
+          <p:cNvSpPr/>
+          <p:nvPr/>
+        </p:nvSpPr>
+        <p:spPr>
+          <a:xfrm>
+            <a:off x="6217920" y="2125980"/>
+            <a:ext cx="5730240" cy="1783080"/>
+          </a:xfrm>
+          <a:prstGeom prst="rect">
+            <a:avLst/>
+          </a:prstGeom>
+          <a:solidFill>
+            <a:srgbClr val="FFFFFF"/>
+          </a:solidFill>
+          <a:ln w="12700">
+            <a:solidFill>
+              <a:srgbClr val="DDDDDD"/>
+            </a:solidFill>
+            <a:prstDash val="solid"/>
+          </a:ln>
+        </p:spPr>
+      </p:sp>
+      <p:sp>
+        <p:nvSpPr>
+          <p:cNvPr id="14" name="T14"/>
+          <p:cNvSpPr/>
+          <p:nvPr/>
+        </p:nvSpPr>
+        <p:spPr>
+          <a:xfrm>
+            <a:off x="6339840" y="2228850"/>
+            <a:ext cx="5486400" cy="1577340"/>
+          </a:xfrm>
+          <a:prstGeom prst="rect">
+            <a:avLst/>
+          </a:prstGeom>
+          <a:noFill/>
+          <a:ln/>
+        </p:spPr>
+        <p:txBody>
+          <a:bodyPr wrap="square" rtlCol="0" anchor="t"/>
+          <a:lstStyle/>
+          <a:p>
+            <a:pPr indent="0" marL="0">
+              <a:buNone/>
+            </a:pPr>
+            <a:r>
+              <a:rPr lang="fr-FR" sz="1000" dirty="0">
+                <a:solidFill>
+                  <a:srgbClr val="222222"/>
+                </a:solidFill>
+                <a:latin typeface="Arial" pitchFamily="34" charset="0"/>
+                <a:ea typeface="Arial" pitchFamily="34" charset="-122"/>
+                <a:cs typeface="Arial" pitchFamily="34" charset="-120"/>
+              </a:rPr>
+              <a:t>• 14 sprints successifs</a:t>
+            </a:r>
+          </a:p>
+          <a:p>
+            <a:pPr indent="0" marL="0">
+              <a:buNone/>
+            </a:pPr>
+            <a:r>
+              <a:rPr lang="fr-FR" sz="1000" dirty="0">
+                <a:solidFill>
+                  <a:srgbClr val="222222"/>
+                </a:solidFill>
+                <a:latin typeface="Arial" pitchFamily="34" charset="0"/>
+                <a:ea typeface="Arial" pitchFamily="34" charset="-122"/>
+                <a:cs typeface="Arial" pitchFamily="34" charset="-120"/>
+              </a:rPr>
+              <a:t>• Bilans hebdomadaires avec le formateur</a:t>
+            </a:r>
+          </a:p>
+          <a:p>
+            <a:pPr indent="0" marL="0">
+              <a:buNone/>
+            </a:pPr>
+            <a:r>
+              <a:rPr lang="fr-FR" sz="1000" dirty="0">
+                <a:solidFill>
+                  <a:srgbClr val="222222"/>
+                </a:solidFill>
+                <a:latin typeface="Arial" pitchFamily="34" charset="0"/>
+                <a:ea typeface="Arial" pitchFamily="34" charset="-122"/>
+                <a:cs typeface="Arial" pitchFamily="34" charset="-120"/>
+              </a:rPr>
+              <a:t>• Corrections intégrées sprint après sprint</a:t>
+            </a:r>
+          </a:p>
+        </p:txBody>
+      </p:sp>
+      <p:sp>
+        <p:nvSpPr>
+          <p:cNvPr id="15" name="S15"/>
+          <p:cNvSpPr/>
+          <p:nvPr/>
+        </p:nvSpPr>
+        <p:spPr>
+          <a:xfrm>
+            <a:off x="243840" y="4114800"/>
+            <a:ext cx="5730240" cy="617220"/>
+          </a:xfrm>
+          <a:prstGeom prst="rect">
+            <a:avLst/>
+          </a:prstGeom>
+          <a:solidFill>
+            <a:srgbClr val="2E7D32"/>
+          </a:solidFill>
+          <a:ln w="12700">
+            <a:solidFill>
+              <a:srgbClr val="2E7D32"/>
+            </a:solidFill>
+            <a:prstDash val="solid"/>
+          </a:ln>
+        </p:spPr>
+      </p:sp>
+      <p:sp>
+        <p:nvSpPr>
+          <p:cNvPr id="16" name="T16"/>
+          <p:cNvSpPr/>
+          <p:nvPr/>
+        </p:nvSpPr>
+        <p:spPr>
+          <a:xfrm>
+            <a:off x="365760" y="4114800"/>
+            <a:ext cx="5486400" cy="617220"/>
+          </a:xfrm>
+          <a:prstGeom prst="rect">
+            <a:avLst/>
+          </a:prstGeom>
+          <a:noFill/>
+          <a:ln/>
+        </p:spPr>
+        <p:txBody>
+          <a:bodyPr wrap="square" rtlCol="0" anchor="ctr"/>
+          <a:lstStyle/>
+          <a:p>
+            <a:pPr indent="0" marL="0">
+              <a:buNone/>
+            </a:pPr>
+            <a:r>
+              <a:rPr lang="fr-FR" sz="1200" b="1" dirty="0">
+                <a:solidFill>
+                  <a:srgbClr val="FFFFFF"/>
+                </a:solidFill>
+                <a:latin typeface="Arial" pitchFamily="34" charset="0"/>
+                <a:ea typeface="Arial" pitchFamily="34" charset="-122"/>
+                <a:cs typeface="Arial" pitchFamily="34" charset="-120"/>
+              </a:rPr>
+              <a:t>Qualité automatisée</a:t>
+            </a:r>
+          </a:p>
+        </p:txBody>
+      </p:sp>
+      <p:sp>
+        <p:nvSpPr>
+          <p:cNvPr id="17" name="S17"/>
+          <p:cNvSpPr/>
+          <p:nvPr/>
+        </p:nvSpPr>
+        <p:spPr>
+          <a:xfrm>
+            <a:off x="243840" y="4732020"/>
+            <a:ext cx="5730240" cy="1783080"/>
+          </a:xfrm>
+          <a:prstGeom prst="rect">
+            <a:avLst/>
+          </a:prstGeom>
+          <a:solidFill>
+            <a:srgbClr val="FFFFFF"/>
+          </a:solidFill>
+          <a:ln w="12700">
+            <a:solidFill>
+              <a:srgbClr val="DDDDDD"/>
+            </a:solidFill>
+            <a:prstDash val="solid"/>
+          </a:ln>
+        </p:spPr>
+      </p:sp>
+      <p:sp>
+        <p:nvSpPr>
+          <p:cNvPr id="18" name="T18"/>
+          <p:cNvSpPr/>
+          <p:nvPr/>
+        </p:nvSpPr>
+        <p:spPr>
+          <a:xfrm>
+            <a:off x="365760" y="4834890"/>
+            <a:ext cx="5486400" cy="1577340"/>
+          </a:xfrm>
+          <a:prstGeom prst="rect">
+            <a:avLst/>
+          </a:prstGeom>
+          <a:noFill/>
+          <a:ln/>
+        </p:spPr>
+        <p:txBody>
+          <a:bodyPr wrap="square" rtlCol="0" anchor="t"/>
+          <a:lstStyle/>
+          <a:p>
+            <a:pPr indent="0" marL="0">
+              <a:buNone/>
+            </a:pPr>
+            <a:r>
+              <a:rPr lang="fr-FR" sz="1000" dirty="0">
+                <a:solidFill>
+                  <a:srgbClr val="222222"/>
+                </a:solidFill>
+                <a:latin typeface="Arial" pitchFamily="34" charset="0"/>
+                <a:ea typeface="Arial" pitchFamily="34" charset="-122"/>
+                <a:cs typeface="Arial" pitchFamily="34" charset="-120"/>
+              </a:rPr>
+              <a:t>• yamllint + terraform validate en CI</a:t>
+            </a:r>
+          </a:p>
+          <a:p>
+            <a:pPr indent="0" marL="0">
+              <a:buNone/>
+            </a:pPr>
+            <a:r>
+              <a:rPr lang="fr-FR" sz="1000" dirty="0">
+                <a:solidFill>
+                  <a:srgbClr val="222222"/>
+                </a:solidFill>
+                <a:latin typeface="Arial" pitchFamily="34" charset="0"/>
+                <a:ea typeface="Arial" pitchFamily="34" charset="-122"/>
+                <a:cs typeface="Arial" pitchFamily="34" charset="-120"/>
+              </a:rPr>
+              <a:t>• Scan de sécurité Trivy</a:t>
+            </a:r>
+          </a:p>
+          <a:p>
+            <a:pPr indent="0" marL="0">
+              <a:buNone/>
+            </a:pPr>
+            <a:r>
+              <a:rPr lang="fr-FR" sz="1000" dirty="0">
+                <a:solidFill>
+                  <a:srgbClr val="222222"/>
+                </a:solidFill>
+                <a:latin typeface="Arial" pitchFamily="34" charset="0"/>
+                <a:ea typeface="Arial" pitchFamily="34" charset="-122"/>
+                <a:cs typeface="Arial" pitchFamily="34" charset="-120"/>
+              </a:rPr>
+              <a:t>• Validation à chaque git push</a:t>
+            </a:r>
+          </a:p>
+        </p:txBody>
+      </p:sp>
+      <p:sp>
+        <p:nvSpPr>
+          <p:cNvPr id="19" name="S19"/>
+          <p:cNvSpPr/>
+          <p:nvPr/>
+        </p:nvSpPr>
+        <p:spPr>
+          <a:xfrm>
+            <a:off x="6217920" y="4114800"/>
+            <a:ext cx="5730240" cy="617220"/>
+          </a:xfrm>
+          <a:prstGeom prst="rect">
+            <a:avLst/>
+          </a:prstGeom>
+          <a:solidFill>
+            <a:srgbClr val="4A148C"/>
+          </a:solidFill>
+          <a:ln w="12700">
+            <a:solidFill>
+              <a:srgbClr val="4A148C"/>
+            </a:solidFill>
+            <a:prstDash val="solid"/>
+          </a:ln>
+        </p:spPr>
+      </p:sp>
+      <p:sp>
+        <p:nvSpPr>
+          <p:cNvPr id="20" name="T20"/>
+          <p:cNvSpPr/>
+          <p:nvPr/>
+        </p:nvSpPr>
+        <p:spPr>
+          <a:xfrm>
+            <a:off x="6339840" y="4114800"/>
+            <a:ext cx="5486400" cy="617220"/>
+          </a:xfrm>
+          <a:prstGeom prst="rect">
+            <a:avLst/>
+          </a:prstGeom>
+          <a:noFill/>
+          <a:ln/>
+        </p:spPr>
+        <p:txBody>
+          <a:bodyPr wrap="square" rtlCol="0" anchor="ctr"/>
+          <a:lstStyle/>
+          <a:p>
+            <a:pPr indent="0" marL="0">
+              <a:buNone/>
+            </a:pPr>
+            <a:r>
+              <a:rPr lang="fr-FR" sz="1200" b="1" dirty="0">
+                <a:solidFill>
+                  <a:srgbClr val="FFFFFF"/>
+                </a:solidFill>
+                <a:latin typeface="Arial" pitchFamily="34" charset="0"/>
+                <a:ea typeface="Arial" pitchFamily="34" charset="-122"/>
+                <a:cs typeface="Arial" pitchFamily="34" charset="-120"/>
+              </a:rPr>
+              <a:t>Documentation continue</a:t>
+            </a:r>
+          </a:p>
+        </p:txBody>
+      </p:sp>
+      <p:sp>
+        <p:nvSpPr>
+          <p:cNvPr id="21" name="S21"/>
+          <p:cNvSpPr/>
+          <p:nvPr/>
+        </p:nvSpPr>
+        <p:spPr>
+          <a:xfrm>
+            <a:off x="6217920" y="4732020"/>
+            <a:ext cx="5730240" cy="1783080"/>
+          </a:xfrm>
+          <a:prstGeom prst="rect">
+            <a:avLst/>
+          </a:prstGeom>
+          <a:solidFill>
+            <a:srgbClr val="FFFFFF"/>
+          </a:solidFill>
+          <a:ln w="12700">
+            <a:solidFill>
+              <a:srgbClr val="DDDDDD"/>
+            </a:solidFill>
+            <a:prstDash val="solid"/>
+          </a:ln>
+        </p:spPr>
+      </p:sp>
+      <p:sp>
+        <p:nvSpPr>
+          <p:cNvPr id="22" name="T22"/>
+          <p:cNvSpPr/>
+          <p:nvPr/>
+        </p:nvSpPr>
+        <p:spPr>
+          <a:xfrm>
+            <a:off x="6339840" y="4834890"/>
+            <a:ext cx="5486400" cy="1577340"/>
+          </a:xfrm>
+          <a:prstGeom prst="rect">
+            <a:avLst/>
+          </a:prstGeom>
+          <a:noFill/>
+          <a:ln/>
+        </p:spPr>
+        <p:txBody>
+          <a:bodyPr wrap="square" rtlCol="0" anchor="t"/>
+          <a:lstStyle/>
+          <a:p>
+            <a:pPr indent="0" marL="0">
+              <a:buNone/>
+            </a:pPr>
+            <a:r>
+              <a:rPr lang="fr-FR" sz="1000" dirty="0">
+                <a:solidFill>
+                  <a:srgbClr val="222222"/>
+                </a:solidFill>
+                <a:latin typeface="Arial" pitchFamily="34" charset="0"/>
+                <a:ea typeface="Arial" pitchFamily="34" charset="-122"/>
+                <a:cs typeface="Arial" pitchFamily="34" charset="-120"/>
+              </a:rPr>
+              <a:t>• README détaillé</a:t>
+            </a:r>
+          </a:p>
+          <a:p>
+            <a:pPr indent="0" marL="0">
+              <a:buNone/>
+            </a:pPr>
+            <a:r>
+              <a:rPr lang="fr-FR" sz="1000" dirty="0">
+                <a:solidFill>
+                  <a:srgbClr val="222222"/>
+                </a:solidFill>
+                <a:latin typeface="Arial" pitchFamily="34" charset="0"/>
+                <a:ea typeface="Arial" pitchFamily="34" charset="-122"/>
+                <a:cs typeface="Arial" pitchFamily="34" charset="-120"/>
+              </a:rPr>
+              <a:t>• Dossier Projet + schéma d architecture</a:t>
+            </a:r>
+          </a:p>
+          <a:p>
+            <a:pPr indent="0" marL="0">
+              <a:buNone/>
+            </a:pPr>
+            <a:r>
+              <a:rPr lang="fr-FR" sz="1000" dirty="0">
+                <a:solidFill>
+                  <a:srgbClr val="222222"/>
+                </a:solidFill>
+                <a:latin typeface="Arial" pitchFamily="34" charset="0"/>
+                <a:ea typeface="Arial" pitchFamily="34" charset="-122"/>
+                <a:cs typeface="Arial" pitchFamily="34" charset="-120"/>
+              </a:rPr>
+              <a:t>• Tout versionné sur GitHub</a:t>
+            </a:r>
+          </a:p>
+        </p:txBody>
+      </p:sp>
+    </p:spTree>
+  </p:cSld>
+  <p:clrMapOvr>
+    <a:masterClrMapping/>
+  </p:clrMapOvr>
+</p:sld>
+</file>
+
+<file path=ppt/slides/slide14.xml><?xml version="1.0" encoding="utf-8"?>
+<p:sld xmlns:a="http://schemas.openxmlformats.org/drawingml/2006/main" xmlns:r="http://schemas.openxmlformats.org/officeDocument/2006/relationships" xmlns:p="http://schemas.openxmlformats.org/presentationml/2006/main">
+  <p:cSld>
+    <p:spTree>
+      <p:nvGrpSpPr>
+        <p:cNvPr id="1" name=""/>
+        <p:cNvGrpSpPr/>
+        <p:nvPr/>
+      </p:nvGrpSpPr>
+      <p:grpSpPr>
+        <a:xfrm>
+          <a:off x="0" y="0"/>
+          <a:ext cx="0" cy="0"/>
+          <a:chOff x="0" y="0"/>
+          <a:chExt cx="0" cy="0"/>
+        </a:xfrm>
+      </p:grpSpPr>
+      <p:sp>
+        <p:nvSpPr>
+          <p:cNvPr id="2" name="S2"/>
+          <p:cNvSpPr/>
+          <p:nvPr/>
+        </p:nvSpPr>
+        <p:spPr>
+          <a:xfrm>
+            <a:off x="0" y="0"/>
+            <a:ext cx="12192000" cy="6858000"/>
+          </a:xfrm>
+          <a:prstGeom prst="rect">
+            <a:avLst/>
+          </a:prstGeom>
+          <a:solidFill>
+            <a:srgbClr val="F5F5F5"/>
+          </a:solidFill>
+          <a:ln w="12700">
+            <a:solidFill>
+              <a:srgbClr val="F5F5F5"/>
+            </a:solidFill>
+            <a:prstDash val="solid"/>
+          </a:ln>
+        </p:spPr>
+      </p:sp>
+      <p:sp>
+        <p:nvSpPr>
+          <p:cNvPr id="3" name="S3"/>
+          <p:cNvSpPr/>
+          <p:nvPr/>
+        </p:nvSpPr>
+        <p:spPr>
+          <a:xfrm>
+            <a:off x="0" y="0"/>
+            <a:ext cx="12192000" cy="1234440"/>
+          </a:xfrm>
+          <a:prstGeom prst="rect">
+            <a:avLst/>
+          </a:prstGeom>
+          <a:solidFill>
+            <a:srgbClr val="1A237E"/>
+          </a:solidFill>
+          <a:ln w="12700">
+            <a:solidFill>
+              <a:srgbClr val="1A237E"/>
+            </a:solidFill>
+            <a:prstDash val="solid"/>
+          </a:ln>
+        </p:spPr>
+      </p:sp>
+      <p:sp>
+        <p:nvSpPr>
+          <p:cNvPr id="4" name="S4"/>
+          <p:cNvSpPr/>
+          <p:nvPr/>
+        </p:nvSpPr>
+        <p:spPr>
+          <a:xfrm>
+            <a:off x="0" y="1234440"/>
+            <a:ext cx="12192000" cy="102870"/>
+          </a:xfrm>
+          <a:prstGeom prst="rect">
+            <a:avLst/>
+          </a:prstGeom>
+          <a:solidFill>
+            <a:srgbClr val="B71C1C"/>
+          </a:solidFill>
+          <a:ln w="12700">
+            <a:solidFill>
+              <a:srgbClr val="B71C1C"/>
+            </a:solidFill>
+            <a:prstDash val="solid"/>
+          </a:ln>
+        </p:spPr>
+      </p:sp>
+      <p:sp>
+        <p:nvSpPr>
+          <p:cNvPr id="5" name="T5"/>
+          <p:cNvSpPr/>
+          <p:nvPr/>
+        </p:nvSpPr>
+        <p:spPr>
+          <a:xfrm>
+            <a:off x="243840" y="137160"/>
+            <a:ext cx="9753600" cy="822960"/>
+          </a:xfrm>
+          <a:prstGeom prst="rect">
+            <a:avLst/>
+          </a:prstGeom>
+          <a:noFill/>
+          <a:ln/>
+        </p:spPr>
+        <p:txBody>
+          <a:bodyPr wrap="square" rtlCol="0" anchor="ctr"/>
+          <a:lstStyle/>
+          <a:p>
+            <a:pPr indent="0" marL="0">
+              <a:buNone/>
+            </a:pPr>
+            <a:r>
+              <a:rPr lang="fr-FR" sz="2600" b="1" dirty="0">
+                <a:solidFill>
+                  <a:srgbClr val="FFFFFF"/>
+                </a:solidFill>
+                <a:latin typeface="Arial" pitchFamily="34" charset="0"/>
+                <a:ea typeface="Arial" pitchFamily="34" charset="-122"/>
+                <a:cs typeface="Arial" pitchFamily="34" charset="-120"/>
+              </a:rPr>
+              <a:t>Sécurité — défense en profondeur</a:t>
+            </a:r>
+          </a:p>
+        </p:txBody>
+      </p:sp>
+      <p:sp>
+        <p:nvSpPr>
+          <p:cNvPr id="6" name="T6"/>
+          <p:cNvSpPr/>
+          <p:nvPr/>
+        </p:nvSpPr>
+        <p:spPr>
+          <a:xfrm>
+            <a:off x="243840" y="685800"/>
+            <a:ext cx="9753600" cy="548640"/>
+          </a:xfrm>
+          <a:prstGeom prst="rect">
+            <a:avLst/>
+          </a:prstGeom>
+          <a:noFill/>
+          <a:ln/>
+        </p:spPr>
+        <p:txBody>
+          <a:bodyPr wrap="square" rtlCol="0" anchor="ctr"/>
+          <a:lstStyle/>
+          <a:p>
+            <a:pPr indent="0" marL="0">
+              <a:buNone/>
+            </a:pPr>
+            <a:r>
+              <a:rPr lang="fr-FR" sz="1300" i="1" dirty="0">
+                <a:solidFill>
+                  <a:srgbClr val="AACCFF"/>
+                </a:solidFill>
+                <a:latin typeface="Arial" pitchFamily="34" charset="0"/>
+                <a:ea typeface="Arial" pitchFamily="34" charset="-122"/>
+                <a:cs typeface="Arial" pitchFamily="34" charset="-120"/>
+              </a:rPr>
+              <a:t>Du système aux secrets, à chaque couche</a:t>
+            </a:r>
+          </a:p>
+        </p:txBody>
+      </p:sp>
+      <p:sp>
+        <p:nvSpPr>
+          <p:cNvPr id="7" name="S7"/>
+          <p:cNvSpPr/>
+          <p:nvPr/>
+        </p:nvSpPr>
+        <p:spPr>
+          <a:xfrm>
+            <a:off x="243840" y="1508760"/>
+            <a:ext cx="5730240" cy="617220"/>
+          </a:xfrm>
+          <a:prstGeom prst="rect">
+            <a:avLst/>
+          </a:prstGeom>
+          <a:solidFill>
+            <a:srgbClr val="B71C1C"/>
+          </a:solidFill>
+          <a:ln w="12700">
+            <a:solidFill>
+              <a:srgbClr val="B71C1C"/>
+            </a:solidFill>
+            <a:prstDash val="solid"/>
+          </a:ln>
+        </p:spPr>
+      </p:sp>
+      <p:sp>
+        <p:nvSpPr>
+          <p:cNvPr id="8" name="T8"/>
+          <p:cNvSpPr/>
+          <p:nvPr/>
+        </p:nvSpPr>
+        <p:spPr>
+          <a:xfrm>
+            <a:off x="365760" y="1508760"/>
+            <a:ext cx="5486400" cy="617220"/>
+          </a:xfrm>
+          <a:prstGeom prst="rect">
+            <a:avLst/>
+          </a:prstGeom>
+          <a:noFill/>
+          <a:ln/>
+        </p:spPr>
+        <p:txBody>
+          <a:bodyPr wrap="square" rtlCol="0" anchor="ctr"/>
+          <a:lstStyle/>
+          <a:p>
+            <a:pPr indent="0" marL="0">
+              <a:buNone/>
+            </a:pPr>
+            <a:r>
+              <a:rPr lang="fr-FR" sz="1200" b="1" dirty="0">
+                <a:solidFill>
+                  <a:srgbClr val="FFFFFF"/>
+                </a:solidFill>
+                <a:latin typeface="Arial" pitchFamily="34" charset="0"/>
+                <a:ea typeface="Arial" pitchFamily="34" charset="-122"/>
+                <a:cs typeface="Arial" pitchFamily="34" charset="-120"/>
+              </a:rPr>
+              <a:t>Réseau &amp; système</a:t>
+            </a:r>
+          </a:p>
+        </p:txBody>
+      </p:sp>
+      <p:sp>
+        <p:nvSpPr>
+          <p:cNvPr id="9" name="S9"/>
+          <p:cNvSpPr/>
+          <p:nvPr/>
+        </p:nvSpPr>
+        <p:spPr>
+          <a:xfrm>
+            <a:off x="243840" y="2125980"/>
+            <a:ext cx="5730240" cy="1783080"/>
+          </a:xfrm>
+          <a:prstGeom prst="rect">
+            <a:avLst/>
+          </a:prstGeom>
+          <a:solidFill>
+            <a:srgbClr val="FFFFFF"/>
+          </a:solidFill>
+          <a:ln w="12700">
+            <a:solidFill>
+              <a:srgbClr val="DDDDDD"/>
+            </a:solidFill>
+            <a:prstDash val="solid"/>
+          </a:ln>
+        </p:spPr>
+      </p:sp>
+      <p:sp>
+        <p:nvSpPr>
+          <p:cNvPr id="10" name="T10"/>
+          <p:cNvSpPr/>
+          <p:nvPr/>
+        </p:nvSpPr>
+        <p:spPr>
+          <a:xfrm>
+            <a:off x="365760" y="2228850"/>
+            <a:ext cx="5486400" cy="1577340"/>
+          </a:xfrm>
+          <a:prstGeom prst="rect">
+            <a:avLst/>
+          </a:prstGeom>
+          <a:noFill/>
+          <a:ln/>
+        </p:spPr>
+        <p:txBody>
+          <a:bodyPr wrap="square" rtlCol="0" anchor="t"/>
+          <a:lstStyle/>
+          <a:p>
+            <a:pPr indent="0" marL="0">
+              <a:buNone/>
+            </a:pPr>
+            <a:r>
+              <a:rPr lang="fr-FR" sz="1000" dirty="0">
+                <a:solidFill>
+                  <a:srgbClr val="222222"/>
+                </a:solidFill>
+                <a:latin typeface="Arial" pitchFamily="34" charset="0"/>
+                <a:ea typeface="Arial" pitchFamily="34" charset="-122"/>
+                <a:cs typeface="Arial" pitchFamily="34" charset="-120"/>
+              </a:rPr>
+              <a:t>• UFW : politique deny par défaut</a:t>
+            </a:r>
+          </a:p>
+          <a:p>
+            <a:pPr indent="0" marL="0">
+              <a:buNone/>
+            </a:pPr>
+            <a:r>
+              <a:rPr lang="fr-FR" sz="1000" dirty="0">
+                <a:solidFill>
+                  <a:srgbClr val="222222"/>
+                </a:solidFill>
+                <a:latin typeface="Arial" pitchFamily="34" charset="0"/>
+                <a:ea typeface="Arial" pitchFamily="34" charset="-122"/>
+                <a:cs typeface="Arial" pitchFamily="34" charset="-120"/>
+              </a:rPr>
+              <a:t>• Ports ouverts : 22 / 80 / 443</a:t>
+            </a:r>
+          </a:p>
+          <a:p>
+            <a:pPr indent="0" marL="0">
+              <a:buNone/>
+            </a:pPr>
+            <a:r>
+              <a:rPr lang="fr-FR" sz="1000" dirty="0">
+                <a:solidFill>
+                  <a:srgbClr val="222222"/>
+                </a:solidFill>
+                <a:latin typeface="Arial" pitchFamily="34" charset="0"/>
+                <a:ea typeface="Arial" pitchFamily="34" charset="-122"/>
+                <a:cs typeface="Arial" pitchFamily="34" charset="-120"/>
+              </a:rPr>
+              <a:t>• SSH hardening : PermitRootLogin no, PasswordAuth no</a:t>
+            </a:r>
+          </a:p>
+        </p:txBody>
+      </p:sp>
+      <p:sp>
+        <p:nvSpPr>
+          <p:cNvPr id="11" name="S11"/>
+          <p:cNvSpPr/>
+          <p:nvPr/>
+        </p:nvSpPr>
+        <p:spPr>
+          <a:xfrm>
+            <a:off x="6217920" y="1508760"/>
+            <a:ext cx="5730240" cy="617220"/>
+          </a:xfrm>
+          <a:prstGeom prst="rect">
+            <a:avLst/>
+          </a:prstGeom>
+          <a:solidFill>
+            <a:srgbClr val="E65100"/>
+          </a:solidFill>
+          <a:ln w="12700">
+            <a:solidFill>
+              <a:srgbClr val="E65100"/>
+            </a:solidFill>
+            <a:prstDash val="solid"/>
+          </a:ln>
+        </p:spPr>
+      </p:sp>
+      <p:sp>
+        <p:nvSpPr>
+          <p:cNvPr id="12" name="T12"/>
+          <p:cNvSpPr/>
+          <p:nvPr/>
+        </p:nvSpPr>
+        <p:spPr>
+          <a:xfrm>
+            <a:off x="6339840" y="1508760"/>
+            <a:ext cx="5486400" cy="617220"/>
+          </a:xfrm>
+          <a:prstGeom prst="rect">
+            <a:avLst/>
+          </a:prstGeom>
+          <a:noFill/>
+          <a:ln/>
+        </p:spPr>
+        <p:txBody>
+          <a:bodyPr wrap="square" rtlCol="0" anchor="ctr"/>
+          <a:lstStyle/>
+          <a:p>
+            <a:pPr indent="0" marL="0">
+              <a:buNone/>
+            </a:pPr>
+            <a:r>
+              <a:rPr lang="fr-FR" sz="1200" b="1" dirty="0">
+                <a:solidFill>
+                  <a:srgbClr val="FFFFFF"/>
+                </a:solidFill>
+                <a:latin typeface="Arial" pitchFamily="34" charset="0"/>
+                <a:ea typeface="Arial" pitchFamily="34" charset="-122"/>
+                <a:cs typeface="Arial" pitchFamily="34" charset="-120"/>
+              </a:rPr>
+              <a:t>Gestion des secrets</a:t>
+            </a:r>
+          </a:p>
+        </p:txBody>
+      </p:sp>
+      <p:sp>
+        <p:nvSpPr>
+          <p:cNvPr id="13" name="S13"/>
+          <p:cNvSpPr/>
+          <p:nvPr/>
+        </p:nvSpPr>
+        <p:spPr>
+          <a:xfrm>
+            <a:off x="6217920" y="2125980"/>
+            <a:ext cx="5730240" cy="1783080"/>
+          </a:xfrm>
+          <a:prstGeom prst="rect">
+            <a:avLst/>
+          </a:prstGeom>
+          <a:solidFill>
+            <a:srgbClr val="FFFFFF"/>
+          </a:solidFill>
+          <a:ln w="12700">
+            <a:solidFill>
+              <a:srgbClr val="DDDDDD"/>
+            </a:solidFill>
+            <a:prstDash val="solid"/>
+          </a:ln>
+        </p:spPr>
+      </p:sp>
+      <p:sp>
+        <p:nvSpPr>
+          <p:cNvPr id="14" name="T14"/>
+          <p:cNvSpPr/>
+          <p:nvPr/>
+        </p:nvSpPr>
+        <p:spPr>
+          <a:xfrm>
+            <a:off x="6339840" y="2228850"/>
+            <a:ext cx="5486400" cy="1577340"/>
+          </a:xfrm>
+          <a:prstGeom prst="rect">
+            <a:avLst/>
+          </a:prstGeom>
+          <a:noFill/>
+          <a:ln/>
+        </p:spPr>
+        <p:txBody>
+          <a:bodyPr wrap="square" rtlCol="0" anchor="t"/>
+          <a:lstStyle/>
+          <a:p>
+            <a:pPr indent="0" marL="0">
+              <a:buNone/>
+            </a:pPr>
+            <a:r>
+              <a:rPr lang="fr-FR" sz="1000" dirty="0">
+                <a:solidFill>
+                  <a:srgbClr val="222222"/>
+                </a:solidFill>
+                <a:latin typeface="Arial" pitchFamily="34" charset="0"/>
+                <a:ea typeface="Arial" pitchFamily="34" charset="-122"/>
+                <a:cs typeface="Arial" pitchFamily="34" charset="-120"/>
+              </a:rPr>
+              <a:t>• .env gitignoré (jamais commité)</a:t>
+            </a:r>
+          </a:p>
+          <a:p>
+            <a:pPr indent="0" marL="0">
+              <a:buNone/>
+            </a:pPr>
+            <a:r>
+              <a:rPr lang="fr-FR" sz="1000" dirty="0">
+                <a:solidFill>
+                  <a:srgbClr val="222222"/>
+                </a:solidFill>
+                <a:latin typeface="Arial" pitchFamily="34" charset="0"/>
+                <a:ea typeface="Arial" pitchFamily="34" charset="-122"/>
+                <a:cs typeface="Arial" pitchFamily="34" charset="-120"/>
+              </a:rPr>
+              <a:t>• Ansible Vault / Secret K8s injecté hors dépôt</a:t>
+            </a:r>
+          </a:p>
+          <a:p>
+            <a:pPr indent="0" marL="0">
+              <a:buNone/>
+            </a:pPr>
+            <a:r>
+              <a:rPr lang="fr-FR" sz="1000" dirty="0">
+                <a:solidFill>
+                  <a:srgbClr val="222222"/>
+                </a:solidFill>
+                <a:latin typeface="Arial" pitchFamily="34" charset="0"/>
+                <a:ea typeface="Arial" pitchFamily="34" charset="-122"/>
+                <a:cs typeface="Arial" pitchFamily="34" charset="-120"/>
+              </a:rPr>
+              <a:t>• Webhook Discord révoqué après fuite</a:t>
+            </a:r>
+          </a:p>
+        </p:txBody>
+      </p:sp>
+      <p:sp>
+        <p:nvSpPr>
+          <p:cNvPr id="15" name="S15"/>
+          <p:cNvSpPr/>
+          <p:nvPr/>
+        </p:nvSpPr>
+        <p:spPr>
+          <a:xfrm>
+            <a:off x="243840" y="4114800"/>
+            <a:ext cx="5730240" cy="617220"/>
+          </a:xfrm>
+          <a:prstGeom prst="rect">
+            <a:avLst/>
+          </a:prstGeom>
+          <a:solidFill>
+            <a:srgbClr val="4A148C"/>
+          </a:solidFill>
+          <a:ln w="12700">
+            <a:solidFill>
+              <a:srgbClr val="4A148C"/>
+            </a:solidFill>
+            <a:prstDash val="solid"/>
+          </a:ln>
+        </p:spPr>
+      </p:sp>
+      <p:sp>
+        <p:nvSpPr>
+          <p:cNvPr id="16" name="T16"/>
+          <p:cNvSpPr/>
+          <p:nvPr/>
+        </p:nvSpPr>
+        <p:spPr>
+          <a:xfrm>
+            <a:off x="365760" y="4114800"/>
+            <a:ext cx="5486400" cy="617220"/>
+          </a:xfrm>
+          <a:prstGeom prst="rect">
+            <a:avLst/>
+          </a:prstGeom>
+          <a:noFill/>
+          <a:ln/>
+        </p:spPr>
+        <p:txBody>
+          <a:bodyPr wrap="square" rtlCol="0" anchor="ctr"/>
+          <a:lstStyle/>
+          <a:p>
+            <a:pPr indent="0" marL="0">
+              <a:buNone/>
+            </a:pPr>
+            <a:r>
+              <a:rPr lang="fr-FR" sz="1200" b="1" dirty="0">
+                <a:solidFill>
+                  <a:srgbClr val="FFFFFF"/>
+                </a:solidFill>
+                <a:latin typeface="Arial" pitchFamily="34" charset="0"/>
+                <a:ea typeface="Arial" pitchFamily="34" charset="-122"/>
+                <a:cs typeface="Arial" pitchFamily="34" charset="-120"/>
+              </a:rPr>
+              <a:t>Image durcie</a:t>
+            </a:r>
+          </a:p>
+        </p:txBody>
+      </p:sp>
+      <p:sp>
+        <p:nvSpPr>
+          <p:cNvPr id="17" name="S17"/>
+          <p:cNvSpPr/>
+          <p:nvPr/>
+        </p:nvSpPr>
+        <p:spPr>
+          <a:xfrm>
+            <a:off x="243840" y="4732020"/>
+            <a:ext cx="5730240" cy="1783080"/>
+          </a:xfrm>
+          <a:prstGeom prst="rect">
+            <a:avLst/>
+          </a:prstGeom>
+          <a:solidFill>
+            <a:srgbClr val="FFFFFF"/>
+          </a:solidFill>
+          <a:ln w="12700">
+            <a:solidFill>
+              <a:srgbClr val="DDDDDD"/>
+            </a:solidFill>
+            <a:prstDash val="solid"/>
+          </a:ln>
+        </p:spPr>
+      </p:sp>
+      <p:sp>
+        <p:nvSpPr>
+          <p:cNvPr id="18" name="T18"/>
+          <p:cNvSpPr/>
+          <p:nvPr/>
+        </p:nvSpPr>
+        <p:spPr>
+          <a:xfrm>
+            <a:off x="365760" y="4834890"/>
+            <a:ext cx="5486400" cy="1577340"/>
+          </a:xfrm>
+          <a:prstGeom prst="rect">
+            <a:avLst/>
+          </a:prstGeom>
+          <a:noFill/>
+          <a:ln/>
+        </p:spPr>
+        <p:txBody>
+          <a:bodyPr wrap="square" rtlCol="0" anchor="t"/>
+          <a:lstStyle/>
+          <a:p>
+            <a:pPr indent="0" marL="0">
+              <a:buNone/>
+            </a:pPr>
+            <a:r>
+              <a:rPr lang="fr-FR" sz="1000" dirty="0">
+                <a:solidFill>
+                  <a:srgbClr val="222222"/>
+                </a:solidFill>
+                <a:latin typeface="Arial" pitchFamily="34" charset="0"/>
+                <a:ea typeface="Arial" pitchFamily="34" charset="-122"/>
+                <a:cs typeface="Arial" pitchFamily="34" charset="-120"/>
+              </a:rPr>
+              <a:t>• Image WordPress custom</a:t>
+            </a:r>
+          </a:p>
+          <a:p>
+            <a:pPr indent="0" marL="0">
+              <a:buNone/>
+            </a:pPr>
+            <a:r>
+              <a:rPr lang="fr-FR" sz="1000" dirty="0">
+                <a:solidFill>
+                  <a:srgbClr val="222222"/>
+                </a:solidFill>
+                <a:latin typeface="Arial" pitchFamily="34" charset="0"/>
+                <a:ea typeface="Arial" pitchFamily="34" charset="-122"/>
+                <a:cs typeface="Arial" pitchFamily="34" charset="-120"/>
+              </a:rPr>
+              <a:t>• DISALLOW_FILE_EDIT activé</a:t>
+            </a:r>
+          </a:p>
+          <a:p>
+            <a:pPr indent="0" marL="0">
+              <a:buNone/>
+            </a:pPr>
+            <a:r>
+              <a:rPr lang="fr-FR" sz="1000" dirty="0">
+                <a:solidFill>
+                  <a:srgbClr val="222222"/>
+                </a:solidFill>
+                <a:latin typeface="Arial" pitchFamily="34" charset="0"/>
+                <a:ea typeface="Arial" pitchFamily="34" charset="-122"/>
+                <a:cs typeface="Arial" pitchFamily="34" charset="-120"/>
+              </a:rPr>
+              <a:t>• Utilisateur non-root (cf. dropshop)</a:t>
+            </a:r>
+          </a:p>
+        </p:txBody>
+      </p:sp>
+      <p:sp>
+        <p:nvSpPr>
+          <p:cNvPr id="19" name="S19"/>
+          <p:cNvSpPr/>
+          <p:nvPr/>
+        </p:nvSpPr>
+        <p:spPr>
+          <a:xfrm>
+            <a:off x="6217920" y="4114800"/>
+            <a:ext cx="5730240" cy="617220"/>
+          </a:xfrm>
+          <a:prstGeom prst="rect">
+            <a:avLst/>
+          </a:prstGeom>
+          <a:solidFill>
+            <a:srgbClr val="00695C"/>
+          </a:solidFill>
+          <a:ln w="12700">
+            <a:solidFill>
+              <a:srgbClr val="00695C"/>
+            </a:solidFill>
+            <a:prstDash val="solid"/>
+          </a:ln>
+        </p:spPr>
+      </p:sp>
+      <p:sp>
+        <p:nvSpPr>
+          <p:cNvPr id="20" name="T20"/>
+          <p:cNvSpPr/>
+          <p:nvPr/>
+        </p:nvSpPr>
+        <p:spPr>
+          <a:xfrm>
+            <a:off x="6339840" y="4114800"/>
+            <a:ext cx="5486400" cy="617220"/>
+          </a:xfrm>
+          <a:prstGeom prst="rect">
+            <a:avLst/>
+          </a:prstGeom>
+          <a:noFill/>
+          <a:ln/>
+        </p:spPr>
+        <p:txBody>
+          <a:bodyPr wrap="square" rtlCol="0" anchor="ctr"/>
+          <a:lstStyle/>
+          <a:p>
+            <a:pPr indent="0" marL="0">
+              <a:buNone/>
+            </a:pPr>
+            <a:r>
+              <a:rPr lang="fr-FR" sz="1200" b="1" dirty="0">
+                <a:solidFill>
+                  <a:srgbClr val="FFFFFF"/>
+                </a:solidFill>
+                <a:latin typeface="Arial" pitchFamily="34" charset="0"/>
+                <a:ea typeface="Arial" pitchFamily="34" charset="-122"/>
+                <a:cs typeface="Arial" pitchFamily="34" charset="-120"/>
+              </a:rPr>
+              <a:t>Sécurité dans la CI</a:t>
+            </a:r>
+          </a:p>
+        </p:txBody>
+      </p:sp>
+      <p:sp>
+        <p:nvSpPr>
+          <p:cNvPr id="21" name="S21"/>
+          <p:cNvSpPr/>
+          <p:nvPr/>
+        </p:nvSpPr>
+        <p:spPr>
+          <a:xfrm>
+            <a:off x="6217920" y="4732020"/>
+            <a:ext cx="5730240" cy="1783080"/>
+          </a:xfrm>
+          <a:prstGeom prst="rect">
+            <a:avLst/>
+          </a:prstGeom>
+          <a:solidFill>
+            <a:srgbClr val="FFFFFF"/>
+          </a:solidFill>
+          <a:ln w="12700">
+            <a:solidFill>
+              <a:srgbClr val="DDDDDD"/>
+            </a:solidFill>
+            <a:prstDash val="solid"/>
+          </a:ln>
+        </p:spPr>
+      </p:sp>
+      <p:sp>
+        <p:nvSpPr>
+          <p:cNvPr id="22" name="T22"/>
+          <p:cNvSpPr/>
+          <p:nvPr/>
+        </p:nvSpPr>
+        <p:spPr>
+          <a:xfrm>
+            <a:off x="6339840" y="4834890"/>
+            <a:ext cx="5486400" cy="1577340"/>
+          </a:xfrm>
+          <a:prstGeom prst="rect">
+            <a:avLst/>
+          </a:prstGeom>
+          <a:noFill/>
+          <a:ln/>
+        </p:spPr>
+        <p:txBody>
+          <a:bodyPr wrap="square" rtlCol="0" anchor="t"/>
+          <a:lstStyle/>
+          <a:p>
+            <a:pPr indent="0" marL="0">
+              <a:buNone/>
+            </a:pPr>
+            <a:r>
+              <a:rPr lang="fr-FR" sz="1000" dirty="0">
+                <a:solidFill>
+                  <a:srgbClr val="222222"/>
+                </a:solidFill>
+                <a:latin typeface="Arial" pitchFamily="34" charset="0"/>
+                <a:ea typeface="Arial" pitchFamily="34" charset="-122"/>
+                <a:cs typeface="Arial" pitchFamily="34" charset="-120"/>
+              </a:rPr>
+              <a:t>• Scan Trivy (manifests + Dockerfile)</a:t>
+            </a:r>
+          </a:p>
+          <a:p>
+            <a:pPr indent="0" marL="0">
+              <a:buNone/>
+            </a:pPr>
+            <a:r>
+              <a:rPr lang="fr-FR" sz="1000" dirty="0">
+                <a:solidFill>
+                  <a:srgbClr val="222222"/>
+                </a:solidFill>
+                <a:latin typeface="Arial" pitchFamily="34" charset="0"/>
+                <a:ea typeface="Arial" pitchFamily="34" charset="-122"/>
+                <a:cs typeface="Arial" pitchFamily="34" charset="-120"/>
+              </a:rPr>
+              <a:t>• Aucun secret dans le code versionné</a:t>
+            </a:r>
+          </a:p>
+          <a:p>
+            <a:pPr indent="0" marL="0">
+              <a:buNone/>
+            </a:pPr>
+            <a:r>
+              <a:rPr lang="fr-FR" sz="1000" dirty="0">
+                <a:solidFill>
+                  <a:srgbClr val="222222"/>
+                </a:solidFill>
+                <a:latin typeface="Arial" pitchFamily="34" charset="0"/>
+                <a:ea typeface="Arial" pitchFamily="34" charset="-122"/>
+                <a:cs typeface="Arial" pitchFamily="34" charset="-120"/>
+              </a:rPr>
+              <a:t>• .env.example sans valeur réelle</a:t>
+            </a:r>
+          </a:p>
+        </p:txBody>
+      </p:sp>
+    </p:spTree>
+  </p:cSld>
+  <p:clrMapOvr>
+    <a:masterClrMapping/>
+  </p:clrMapOvr>
+</p:sld>
+</file>
+
+<file path=ppt/slides/slide15.xml><?xml version="1.0" encoding="utf-8"?>
+<p:sld xmlns:a="http://schemas.openxmlformats.org/drawingml/2006/main" xmlns:r="http://schemas.openxmlformats.org/officeDocument/2006/relationships" xmlns:p="http://schemas.openxmlformats.org/presentationml/2006/main">
+  <p:cSld>
+    <p:spTree>
+      <p:nvGrpSpPr>
+        <p:cNvPr id="1" name=""/>
+        <p:cNvGrpSpPr/>
+        <p:nvPr/>
+      </p:nvGrpSpPr>
+      <p:grpSpPr>
+        <a:xfrm>
+          <a:off x="0" y="0"/>
+          <a:ext cx="0" cy="0"/>
+          <a:chOff x="0" y="0"/>
+          <a:chExt cx="0" cy="0"/>
+        </a:xfrm>
+      </p:grpSpPr>
+      <p:sp>
+        <p:nvSpPr>
+          <p:cNvPr id="2" name="S2"/>
+          <p:cNvSpPr/>
+          <p:nvPr/>
+        </p:nvSpPr>
+        <p:spPr>
+          <a:xfrm>
+            <a:off x="0" y="0"/>
+            <a:ext cx="12192000" cy="6858000"/>
+          </a:xfrm>
+          <a:prstGeom prst="rect">
+            <a:avLst/>
+          </a:prstGeom>
+          <a:solidFill>
+            <a:srgbClr val="F5F5F5"/>
+          </a:solidFill>
+          <a:ln w="12700">
+            <a:solidFill>
+              <a:srgbClr val="F5F5F5"/>
+            </a:solidFill>
+            <a:prstDash val="solid"/>
+          </a:ln>
+        </p:spPr>
+      </p:sp>
+      <p:sp>
+        <p:nvSpPr>
+          <p:cNvPr id="3" name="S3"/>
+          <p:cNvSpPr/>
+          <p:nvPr/>
+        </p:nvSpPr>
+        <p:spPr>
+          <a:xfrm>
+            <a:off x="0" y="0"/>
+            <a:ext cx="12192000" cy="1234440"/>
+          </a:xfrm>
+          <a:prstGeom prst="rect">
+            <a:avLst/>
+          </a:prstGeom>
+          <a:solidFill>
+            <a:srgbClr val="1A237E"/>
+          </a:solidFill>
+          <a:ln w="12700">
+            <a:solidFill>
+              <a:srgbClr val="1A237E"/>
+            </a:solidFill>
+            <a:prstDash val="solid"/>
+          </a:ln>
+        </p:spPr>
+      </p:sp>
+      <p:sp>
+        <p:nvSpPr>
+          <p:cNvPr id="4" name="S4"/>
+          <p:cNvSpPr/>
+          <p:nvPr/>
+        </p:nvSpPr>
+        <p:spPr>
+          <a:xfrm>
+            <a:off x="0" y="1234440"/>
+            <a:ext cx="12192000" cy="102870"/>
+          </a:xfrm>
+          <a:prstGeom prst="rect">
+            <a:avLst/>
+          </a:prstGeom>
+          <a:solidFill>
+            <a:srgbClr val="E65100"/>
+          </a:solidFill>
+          <a:ln w="12700">
+            <a:solidFill>
+              <a:srgbClr val="E65100"/>
+            </a:solidFill>
+            <a:prstDash val="solid"/>
+          </a:ln>
+        </p:spPr>
+      </p:sp>
+      <p:sp>
+        <p:nvSpPr>
+          <p:cNvPr id="5" name="T5"/>
+          <p:cNvSpPr/>
+          <p:nvPr/>
+        </p:nvSpPr>
+        <p:spPr>
+          <a:xfrm>
+            <a:off x="243840" y="137160"/>
+            <a:ext cx="9753600" cy="822960"/>
+          </a:xfrm>
+          <a:prstGeom prst="rect">
+            <a:avLst/>
+          </a:prstGeom>
+          <a:noFill/>
+          <a:ln/>
+        </p:spPr>
+        <p:txBody>
+          <a:bodyPr wrap="square" rtlCol="0" anchor="ctr"/>
+          <a:lstStyle/>
+          <a:p>
+            <a:pPr indent="0" marL="0">
+              <a:buNone/>
+            </a:pPr>
+            <a:r>
+              <a:rPr lang="fr-FR" sz="2600" b="1" dirty="0">
+                <a:solidFill>
+                  <a:srgbClr val="FFFFFF"/>
+                </a:solidFill>
+                <a:latin typeface="Arial" pitchFamily="34" charset="0"/>
+                <a:ea typeface="Arial" pitchFamily="34" charset="-122"/>
+                <a:cs typeface="Arial" pitchFamily="34" charset="-120"/>
+              </a:rPr>
+              <a:t>Difficultés techniques résolues</a:t>
+            </a:r>
+          </a:p>
+        </p:txBody>
+      </p:sp>
+      <p:sp>
+        <p:nvSpPr>
+          <p:cNvPr id="6" name="T6"/>
+          <p:cNvSpPr/>
+          <p:nvPr/>
+        </p:nvSpPr>
+        <p:spPr>
+          <a:xfrm>
+            <a:off x="243840" y="685800"/>
+            <a:ext cx="9753600" cy="548640"/>
+          </a:xfrm>
+          <a:prstGeom prst="rect">
+            <a:avLst/>
+          </a:prstGeom>
+          <a:noFill/>
+          <a:ln/>
+        </p:spPr>
+        <p:txBody>
+          <a:bodyPr wrap="square" rtlCol="0" anchor="ctr"/>
+          <a:lstStyle/>
+          <a:p>
+            <a:pPr indent="0" marL="0">
+              <a:buNone/>
+            </a:pPr>
+            <a:r>
+              <a:rPr lang="fr-FR" sz="1300" i="1" dirty="0">
+                <a:solidFill>
+                  <a:srgbClr val="AACCFF"/>
+                </a:solidFill>
+                <a:latin typeface="Arial" pitchFamily="34" charset="0"/>
+                <a:ea typeface="Arial" pitchFamily="34" charset="-122"/>
+                <a:cs typeface="Arial" pitchFamily="34" charset="-120"/>
+              </a:rPr>
+              <a:t>Diagnostiquer, comprendre, corriger</a:t>
+            </a:r>
+          </a:p>
+        </p:txBody>
+      </p:sp>
+      <p:sp>
+        <p:nvSpPr>
+          <p:cNvPr id="7" name="S7"/>
+          <p:cNvSpPr/>
+          <p:nvPr/>
+        </p:nvSpPr>
+        <p:spPr>
+          <a:xfrm>
+            <a:off x="243840" y="1577340"/>
+            <a:ext cx="5486400" cy="1508760"/>
+          </a:xfrm>
+          <a:prstGeom prst="rect">
+            <a:avLst/>
+          </a:prstGeom>
+          <a:solidFill>
+            <a:srgbClr val="FFF3E0"/>
+          </a:solidFill>
+          <a:ln w="12700">
+            <a:solidFill>
+              <a:srgbClr val="FFCCAA"/>
+            </a:solidFill>
+            <a:prstDash val="solid"/>
+          </a:ln>
+        </p:spPr>
+      </p:sp>
+      <p:sp>
+        <p:nvSpPr>
+          <p:cNvPr id="8" name="T8"/>
+          <p:cNvSpPr/>
+          <p:nvPr/>
+        </p:nvSpPr>
+        <p:spPr>
+          <a:xfrm>
+            <a:off x="365760" y="1645920"/>
+            <a:ext cx="5242560" cy="411480"/>
+          </a:xfrm>
+          <a:prstGeom prst="rect">
+            <a:avLst/>
+          </a:prstGeom>
+          <a:noFill/>
+          <a:ln/>
+        </p:spPr>
+        <p:txBody>
+          <a:bodyPr wrap="square" rtlCol="0" anchor="t"/>
+          <a:lstStyle/>
+          <a:p>
+            <a:pPr indent="0" marL="0">
+              <a:buNone/>
+            </a:pPr>
+            <a:r>
+              <a:rPr lang="fr-FR" sz="900" b="1" dirty="0">
+                <a:solidFill>
+                  <a:srgbClr val="E65100"/>
+                </a:solidFill>
+                <a:latin typeface="Arial" pitchFamily="34" charset="0"/>
+                <a:ea typeface="Arial" pitchFamily="34" charset="-122"/>
+                <a:cs typeface="Arial" pitchFamily="34" charset="-120"/>
+              </a:rPr>
+              <a:t>PROBLÈME</a:t>
+            </a:r>
+          </a:p>
+        </p:txBody>
+      </p:sp>
+      <p:sp>
+        <p:nvSpPr>
+          <p:cNvPr id="9" name="T9"/>
+          <p:cNvSpPr/>
+          <p:nvPr/>
+        </p:nvSpPr>
+        <p:spPr>
+          <a:xfrm>
+            <a:off x="365760" y="2057400"/>
+            <a:ext cx="5242560" cy="960120"/>
+          </a:xfrm>
+          <a:prstGeom prst="rect">
+            <a:avLst/>
+          </a:prstGeom>
+          <a:noFill/>
+          <a:ln/>
+        </p:spPr>
+        <p:txBody>
+          <a:bodyPr wrap="square" rtlCol="0" anchor="t"/>
+          <a:lstStyle/>
+          <a:p>
+            <a:pPr indent="0" marL="0">
+              <a:buNone/>
+            </a:pPr>
+            <a:r>
+              <a:rPr lang="fr-FR" sz="1000" dirty="0">
+                <a:solidFill>
+                  <a:srgbClr val="663300"/>
+                </a:solidFill>
+                <a:latin typeface="Arial" pitchFamily="34" charset="0"/>
+                <a:ea typeface="Arial" pitchFamily="34" charset="-122"/>
+                <a:cs typeface="Arial" pitchFamily="34" charset="-120"/>
+              </a:rPr>
+              <a:t>Projet « boîte vide » (retour formateur)</a:t>
+            </a:r>
+          </a:p>
+        </p:txBody>
+      </p:sp>
+      <p:sp>
+        <p:nvSpPr>
+          <p:cNvPr id="10" name="T10"/>
+          <p:cNvSpPr/>
+          <p:nvPr/>
+        </p:nvSpPr>
+        <p:spPr>
+          <a:xfrm>
+            <a:off x="5852160" y="1577340"/>
+            <a:ext cx="487680" cy="1508760"/>
+          </a:xfrm>
+          <a:prstGeom prst="rect">
+            <a:avLst/>
+          </a:prstGeom>
+          <a:noFill/>
+          <a:ln/>
+        </p:spPr>
+        <p:txBody>
+          <a:bodyPr wrap="square" rtlCol="0" anchor="ctr"/>
+          <a:lstStyle/>
+          <a:p>
+            <a:pPr algn="ctr" indent="0" marL="0">
+              <a:buNone/>
+            </a:pPr>
+            <a:r>
+              <a:rPr lang="fr-FR" sz="1800" b="1" dirty="0">
+                <a:solidFill>
+                  <a:srgbClr val="2E7D32"/>
+                </a:solidFill>
+                <a:latin typeface="Arial" pitchFamily="34" charset="0"/>
+                <a:ea typeface="Arial" pitchFamily="34" charset="-122"/>
+                <a:cs typeface="Arial" pitchFamily="34" charset="-120"/>
+              </a:rPr>
+              <a:t>-&gt;</a:t>
+            </a:r>
+          </a:p>
+        </p:txBody>
+      </p:sp>
+      <p:sp>
+        <p:nvSpPr>
+          <p:cNvPr id="11" name="S11"/>
+          <p:cNvSpPr/>
+          <p:nvPr/>
+        </p:nvSpPr>
+        <p:spPr>
+          <a:xfrm>
+            <a:off x="6461760" y="1577340"/>
+            <a:ext cx="5486400" cy="1508760"/>
+          </a:xfrm>
+          <a:prstGeom prst="rect">
+            <a:avLst/>
+          </a:prstGeom>
+          <a:solidFill>
+            <a:srgbClr val="E8F5E9"/>
+          </a:solidFill>
+          <a:ln w="12700">
+            <a:solidFill>
+              <a:srgbClr val="AADDAA"/>
+            </a:solidFill>
+            <a:prstDash val="solid"/>
+          </a:ln>
+        </p:spPr>
+      </p:sp>
+      <p:sp>
+        <p:nvSpPr>
+          <p:cNvPr id="12" name="T12"/>
+          <p:cNvSpPr/>
+          <p:nvPr/>
+        </p:nvSpPr>
+        <p:spPr>
+          <a:xfrm>
+            <a:off x="6583680" y="1645920"/>
+            <a:ext cx="5242560" cy="411480"/>
+          </a:xfrm>
+          <a:prstGeom prst="rect">
+            <a:avLst/>
+          </a:prstGeom>
+          <a:noFill/>
+          <a:ln/>
+        </p:spPr>
+        <p:txBody>
+          <a:bodyPr wrap="square" rtlCol="0" anchor="t"/>
+          <a:lstStyle/>
+          <a:p>
+            <a:pPr indent="0" marL="0">
+              <a:buNone/>
+            </a:pPr>
+            <a:r>
+              <a:rPr lang="fr-FR" sz="900" b="1" dirty="0">
+                <a:solidFill>
+                  <a:srgbClr val="2E7D32"/>
+                </a:solidFill>
+                <a:latin typeface="Arial" pitchFamily="34" charset="0"/>
+                <a:ea typeface="Arial" pitchFamily="34" charset="-122"/>
+                <a:cs typeface="Arial" pitchFamily="34" charset="-120"/>
+              </a:rPr>
+              <a:t>SOLUTION</a:t>
+            </a:r>
+          </a:p>
+        </p:txBody>
+      </p:sp>
+      <p:sp>
+        <p:nvSpPr>
+          <p:cNvPr id="13" name="T13"/>
+          <p:cNvSpPr/>
+          <p:nvPr/>
+        </p:nvSpPr>
+        <p:spPr>
+          <a:xfrm>
+            <a:off x="6583680" y="2057400"/>
+            <a:ext cx="5242560" cy="960120"/>
+          </a:xfrm>
+          <a:prstGeom prst="rect">
+            <a:avLst/>
+          </a:prstGeom>
+          <a:noFill/>
+          <a:ln/>
+        </p:spPr>
+        <p:txBody>
+          <a:bodyPr wrap="square" rtlCol="0" anchor="t"/>
+          <a:lstStyle/>
+          <a:p>
+            <a:pPr indent="0" marL="0">
+              <a:buNone/>
+            </a:pPr>
+            <a:r>
+              <a:rPr lang="fr-FR" sz="1000" dirty="0">
+                <a:solidFill>
+                  <a:srgbClr val="1A3D1A"/>
+                </a:solidFill>
+                <a:latin typeface="Arial" pitchFamily="34" charset="0"/>
+                <a:ea typeface="Arial" pitchFamily="34" charset="-122"/>
+                <a:cs typeface="Arial" pitchFamily="34" charset="-120"/>
+              </a:rPr>
+              <a:t>Déploiement WordPress réel : HA (2 réplicas), image durcie, MariaDB</a:t>
+            </a:r>
+          </a:p>
+        </p:txBody>
+      </p:sp>
+      <p:sp>
+        <p:nvSpPr>
+          <p:cNvPr id="14" name="S14"/>
+          <p:cNvSpPr/>
+          <p:nvPr/>
+        </p:nvSpPr>
+        <p:spPr>
+          <a:xfrm>
+            <a:off x="243840" y="3223260"/>
+            <a:ext cx="5486400" cy="1508760"/>
+          </a:xfrm>
+          <a:prstGeom prst="rect">
+            <a:avLst/>
+          </a:prstGeom>
+          <a:solidFill>
+            <a:srgbClr val="FFF3E0"/>
+          </a:solidFill>
+          <a:ln w="12700">
+            <a:solidFill>
+              <a:srgbClr val="FFCCAA"/>
+            </a:solidFill>
+            <a:prstDash val="solid"/>
+          </a:ln>
+        </p:spPr>
+      </p:sp>
+      <p:sp>
+        <p:nvSpPr>
+          <p:cNvPr id="15" name="T15"/>
+          <p:cNvSpPr/>
+          <p:nvPr/>
+        </p:nvSpPr>
+        <p:spPr>
+          <a:xfrm>
+            <a:off x="365760" y="3291840"/>
+            <a:ext cx="5242560" cy="411480"/>
+          </a:xfrm>
+          <a:prstGeom prst="rect">
+            <a:avLst/>
+          </a:prstGeom>
+          <a:noFill/>
+          <a:ln/>
+        </p:spPr>
+        <p:txBody>
+          <a:bodyPr wrap="square" rtlCol="0" anchor="t"/>
+          <a:lstStyle/>
+          <a:p>
+            <a:pPr indent="0" marL="0">
+              <a:buNone/>
+            </a:pPr>
+            <a:r>
+              <a:rPr lang="fr-FR" sz="900" b="1" dirty="0">
+                <a:solidFill>
+                  <a:srgbClr val="E65100"/>
+                </a:solidFill>
+                <a:latin typeface="Arial" pitchFamily="34" charset="0"/>
+                <a:ea typeface="Arial" pitchFamily="34" charset="-122"/>
+                <a:cs typeface="Arial" pitchFamily="34" charset="-120"/>
+              </a:rPr>
+              <a:t>PROBLÈME</a:t>
+            </a:r>
+          </a:p>
+        </p:txBody>
+      </p:sp>
+      <p:sp>
+        <p:nvSpPr>
+          <p:cNvPr id="16" name="T16"/>
+          <p:cNvSpPr/>
+          <p:nvPr/>
+        </p:nvSpPr>
+        <p:spPr>
+          <a:xfrm>
+            <a:off x="365760" y="3703320"/>
+            <a:ext cx="5242560" cy="960120"/>
+          </a:xfrm>
+          <a:prstGeom prst="rect">
+            <a:avLst/>
+          </a:prstGeom>
+          <a:noFill/>
+          <a:ln/>
+        </p:spPr>
+        <p:txBody>
+          <a:bodyPr wrap="square" rtlCol="0" anchor="t"/>
+          <a:lstStyle/>
+          <a:p>
+            <a:pPr indent="0" marL="0">
+              <a:buNone/>
+            </a:pPr>
+            <a:r>
+              <a:rPr lang="fr-FR" sz="1000" dirty="0">
+                <a:solidFill>
+                  <a:srgbClr val="663300"/>
+                </a:solidFill>
+                <a:latin typeface="Arial" pitchFamily="34" charset="0"/>
+                <a:ea typeface="Arial" pitchFamily="34" charset="-122"/>
+                <a:cs typeface="Arial" pitchFamily="34" charset="-120"/>
+              </a:rPr>
+              <a:t>Alerte Discord muette — HTTP 403</a:t>
+            </a:r>
+          </a:p>
+        </p:txBody>
+      </p:sp>
+      <p:sp>
+        <p:nvSpPr>
+          <p:cNvPr id="17" name="T17"/>
+          <p:cNvSpPr/>
+          <p:nvPr/>
+        </p:nvSpPr>
+        <p:spPr>
+          <a:xfrm>
+            <a:off x="5852160" y="3223260"/>
+            <a:ext cx="487680" cy="1508760"/>
+          </a:xfrm>
+          <a:prstGeom prst="rect">
+            <a:avLst/>
+          </a:prstGeom>
+          <a:noFill/>
+          <a:ln/>
+        </p:spPr>
+        <p:txBody>
+          <a:bodyPr wrap="square" rtlCol="0" anchor="ctr"/>
+          <a:lstStyle/>
+          <a:p>
+            <a:pPr algn="ctr" indent="0" marL="0">
+              <a:buNone/>
+            </a:pPr>
+            <a:r>
+              <a:rPr lang="fr-FR" sz="1800" b="1" dirty="0">
+                <a:solidFill>
+                  <a:srgbClr val="2E7D32"/>
+                </a:solidFill>
+                <a:latin typeface="Arial" pitchFamily="34" charset="0"/>
+                <a:ea typeface="Arial" pitchFamily="34" charset="-122"/>
+                <a:cs typeface="Arial" pitchFamily="34" charset="-120"/>
+              </a:rPr>
+              <a:t>-&gt;</a:t>
+            </a:r>
+          </a:p>
+        </p:txBody>
+      </p:sp>
+      <p:sp>
+        <p:nvSpPr>
+          <p:cNvPr id="18" name="S18"/>
+          <p:cNvSpPr/>
+          <p:nvPr/>
+        </p:nvSpPr>
+        <p:spPr>
+          <a:xfrm>
+            <a:off x="6461760" y="3223260"/>
+            <a:ext cx="5486400" cy="1508760"/>
+          </a:xfrm>
+          <a:prstGeom prst="rect">
+            <a:avLst/>
+          </a:prstGeom>
+          <a:solidFill>
+            <a:srgbClr val="E8F5E9"/>
+          </a:solidFill>
+          <a:ln w="12700">
+            <a:solidFill>
+              <a:srgbClr val="AADDAA"/>
+            </a:solidFill>
+            <a:prstDash val="solid"/>
+          </a:ln>
+        </p:spPr>
+      </p:sp>
+      <p:sp>
+        <p:nvSpPr>
+          <p:cNvPr id="19" name="T19"/>
+          <p:cNvSpPr/>
+          <p:nvPr/>
+        </p:nvSpPr>
+        <p:spPr>
+          <a:xfrm>
+            <a:off x="6583680" y="3291840"/>
+            <a:ext cx="5242560" cy="411480"/>
+          </a:xfrm>
+          <a:prstGeom prst="rect">
+            <a:avLst/>
+          </a:prstGeom>
+          <a:noFill/>
+          <a:ln/>
+        </p:spPr>
+        <p:txBody>
+          <a:bodyPr wrap="square" rtlCol="0" anchor="t"/>
+          <a:lstStyle/>
+          <a:p>
+            <a:pPr indent="0" marL="0">
+              <a:buNone/>
+            </a:pPr>
+            <a:r>
+              <a:rPr lang="fr-FR" sz="900" b="1" dirty="0">
+                <a:solidFill>
+                  <a:srgbClr val="2E7D32"/>
+                </a:solidFill>
+                <a:latin typeface="Arial" pitchFamily="34" charset="0"/>
+                <a:ea typeface="Arial" pitchFamily="34" charset="-122"/>
+                <a:cs typeface="Arial" pitchFamily="34" charset="-120"/>
+              </a:rPr>
+              <a:t>SOLUTION</a:t>
+            </a:r>
+          </a:p>
+        </p:txBody>
+      </p:sp>
+      <p:sp>
+        <p:nvSpPr>
+          <p:cNvPr id="20" name="T20"/>
+          <p:cNvSpPr/>
+          <p:nvPr/>
+        </p:nvSpPr>
+        <p:spPr>
+          <a:xfrm>
+            <a:off x="6583680" y="3703320"/>
+            <a:ext cx="5242560" cy="960120"/>
+          </a:xfrm>
+          <a:prstGeom prst="rect">
+            <a:avLst/>
+          </a:prstGeom>
+          <a:noFill/>
+          <a:ln/>
+        </p:spPr>
+        <p:txBody>
+          <a:bodyPr wrap="square" rtlCol="0" anchor="t"/>
+          <a:lstStyle/>
+          <a:p>
+            <a:pPr indent="0" marL="0">
+              <a:buNone/>
+            </a:pPr>
+            <a:r>
+              <a:rPr lang="fr-FR" sz="1000" dirty="0">
+                <a:solidFill>
+                  <a:srgbClr val="1A3D1A"/>
+                </a:solidFill>
+                <a:latin typeface="Arial" pitchFamily="34" charset="0"/>
+                <a:ea typeface="Arial" pitchFamily="34" charset="-122"/>
+                <a:cs typeface="Arial" pitchFamily="34" charset="-120"/>
+              </a:rPr>
+              <a:t>Diagnostic : User-Agent manquant -&gt; relay Python -&gt; HTTP 204</a:t>
+            </a:r>
+          </a:p>
+        </p:txBody>
+      </p:sp>
+      <p:sp>
+        <p:nvSpPr>
+          <p:cNvPr id="21" name="S21"/>
+          <p:cNvSpPr/>
+          <p:nvPr/>
+        </p:nvSpPr>
+        <p:spPr>
+          <a:xfrm>
+            <a:off x="243840" y="4869180"/>
+            <a:ext cx="5486400" cy="1508760"/>
+          </a:xfrm>
+          <a:prstGeom prst="rect">
+            <a:avLst/>
+          </a:prstGeom>
+          <a:solidFill>
+            <a:srgbClr val="FFF3E0"/>
+          </a:solidFill>
+          <a:ln w="12700">
+            <a:solidFill>
+              <a:srgbClr val="FFCCAA"/>
+            </a:solidFill>
+            <a:prstDash val="solid"/>
+          </a:ln>
+        </p:spPr>
+      </p:sp>
+      <p:sp>
+        <p:nvSpPr>
+          <p:cNvPr id="22" name="T22"/>
+          <p:cNvSpPr/>
+          <p:nvPr/>
+        </p:nvSpPr>
+        <p:spPr>
+          <a:xfrm>
+            <a:off x="365760" y="4937760"/>
+            <a:ext cx="5242560" cy="411480"/>
+          </a:xfrm>
+          <a:prstGeom prst="rect">
+            <a:avLst/>
+          </a:prstGeom>
+          <a:noFill/>
+          <a:ln/>
+        </p:spPr>
+        <p:txBody>
+          <a:bodyPr wrap="square" rtlCol="0" anchor="t"/>
+          <a:lstStyle/>
+          <a:p>
+            <a:pPr indent="0" marL="0">
+              <a:buNone/>
+            </a:pPr>
+            <a:r>
+              <a:rPr lang="fr-FR" sz="900" b="1" dirty="0">
+                <a:solidFill>
+                  <a:srgbClr val="E65100"/>
+                </a:solidFill>
+                <a:latin typeface="Arial" pitchFamily="34" charset="0"/>
+                <a:ea typeface="Arial" pitchFamily="34" charset="-122"/>
+                <a:cs typeface="Arial" pitchFamily="34" charset="-120"/>
+              </a:rPr>
+              <a:t>PROBLÈME</a:t>
+            </a:r>
+          </a:p>
+        </p:txBody>
+      </p:sp>
+      <p:sp>
+        <p:nvSpPr>
+          <p:cNvPr id="23" name="T23"/>
+          <p:cNvSpPr/>
+          <p:nvPr/>
+        </p:nvSpPr>
+        <p:spPr>
+          <a:xfrm>
+            <a:off x="365760" y="5349240"/>
+            <a:ext cx="5242560" cy="960120"/>
+          </a:xfrm>
+          <a:prstGeom prst="rect">
+            <a:avLst/>
+          </a:prstGeom>
+          <a:noFill/>
+          <a:ln/>
+        </p:spPr>
+        <p:txBody>
+          <a:bodyPr wrap="square" rtlCol="0" anchor="t"/>
+          <a:lstStyle/>
+          <a:p>
+            <a:pPr indent="0" marL="0">
+              <a:buNone/>
+            </a:pPr>
+            <a:r>
+              <a:rPr lang="fr-FR" sz="1000" dirty="0">
+                <a:solidFill>
+                  <a:srgbClr val="663300"/>
+                </a:solidFill>
+                <a:latin typeface="Arial" pitchFamily="34" charset="0"/>
+                <a:ea typeface="Arial" pitchFamily="34" charset="-122"/>
+                <a:cs typeface="Arial" pitchFamily="34" charset="-120"/>
+              </a:rPr>
+              <a:t>CI en échec (fichier systemd dans Ansible)</a:t>
+            </a:r>
+          </a:p>
+        </p:txBody>
+      </p:sp>
+      <p:sp>
+        <p:nvSpPr>
+          <p:cNvPr id="24" name="T24"/>
+          <p:cNvSpPr/>
+          <p:nvPr/>
+        </p:nvSpPr>
+        <p:spPr>
+          <a:xfrm>
+            <a:off x="5852160" y="4869180"/>
+            <a:ext cx="487680" cy="1508760"/>
+          </a:xfrm>
+          <a:prstGeom prst="rect">
+            <a:avLst/>
+          </a:prstGeom>
+          <a:noFill/>
+          <a:ln/>
+        </p:spPr>
+        <p:txBody>
+          <a:bodyPr wrap="square" rtlCol="0" anchor="ctr"/>
+          <a:lstStyle/>
+          <a:p>
+            <a:pPr algn="ctr" indent="0" marL="0">
+              <a:buNone/>
+            </a:pPr>
+            <a:r>
+              <a:rPr lang="fr-FR" sz="1800" b="1" dirty="0">
+                <a:solidFill>
+                  <a:srgbClr val="2E7D32"/>
+                </a:solidFill>
+                <a:latin typeface="Arial" pitchFamily="34" charset="0"/>
+                <a:ea typeface="Arial" pitchFamily="34" charset="-122"/>
+                <a:cs typeface="Arial" pitchFamily="34" charset="-120"/>
+              </a:rPr>
+              <a:t>-&gt;</a:t>
+            </a:r>
+          </a:p>
+        </p:txBody>
+      </p:sp>
+      <p:sp>
+        <p:nvSpPr>
+          <p:cNvPr id="25" name="S25"/>
+          <p:cNvSpPr/>
+          <p:nvPr/>
+        </p:nvSpPr>
+        <p:spPr>
+          <a:xfrm>
+            <a:off x="6461760" y="4869180"/>
+            <a:ext cx="5486400" cy="1508760"/>
+          </a:xfrm>
+          <a:prstGeom prst="rect">
+            <a:avLst/>
+          </a:prstGeom>
+          <a:solidFill>
+            <a:srgbClr val="E8F5E9"/>
+          </a:solidFill>
+          <a:ln w="12700">
+            <a:solidFill>
+              <a:srgbClr val="AADDAA"/>
+            </a:solidFill>
+            <a:prstDash val="solid"/>
+          </a:ln>
+        </p:spPr>
+      </p:sp>
+      <p:sp>
+        <p:nvSpPr>
+          <p:cNvPr id="26" name="T26"/>
+          <p:cNvSpPr/>
+          <p:nvPr/>
+        </p:nvSpPr>
+        <p:spPr>
+          <a:xfrm>
+            <a:off x="6583680" y="4937760"/>
+            <a:ext cx="5242560" cy="411480"/>
+          </a:xfrm>
+          <a:prstGeom prst="rect">
+            <a:avLst/>
+          </a:prstGeom>
+          <a:noFill/>
+          <a:ln/>
+        </p:spPr>
+        <p:txBody>
+          <a:bodyPr wrap="square" rtlCol="0" anchor="t"/>
+          <a:lstStyle/>
+          <a:p>
+            <a:pPr indent="0" marL="0">
+              <a:buNone/>
+            </a:pPr>
+            <a:r>
+              <a:rPr lang="fr-FR" sz="900" b="1" dirty="0">
+                <a:solidFill>
+                  <a:srgbClr val="2E7D32"/>
+                </a:solidFill>
+                <a:latin typeface="Arial" pitchFamily="34" charset="0"/>
+                <a:ea typeface="Arial" pitchFamily="34" charset="-122"/>
+                <a:cs typeface="Arial" pitchFamily="34" charset="-120"/>
+              </a:rPr>
+              <a:t>SOLUTION</a:t>
+            </a:r>
+          </a:p>
+        </p:txBody>
+      </p:sp>
+      <p:sp>
+        <p:nvSpPr>
+          <p:cNvPr id="27" name="T27"/>
+          <p:cNvSpPr/>
+          <p:nvPr/>
+        </p:nvSpPr>
+        <p:spPr>
+          <a:xfrm>
+            <a:off x="6583680" y="5349240"/>
+            <a:ext cx="5242560" cy="960120"/>
+          </a:xfrm>
+          <a:prstGeom prst="rect">
+            <a:avLst/>
+          </a:prstGeom>
+          <a:noFill/>
+          <a:ln/>
+        </p:spPr>
+        <p:txBody>
+          <a:bodyPr wrap="square" rtlCol="0" anchor="t"/>
+          <a:lstStyle/>
+          <a:p>
+            <a:pPr indent="0" marL="0">
+              <a:buNone/>
+            </a:pPr>
+            <a:r>
+              <a:rPr lang="fr-FR" sz="1000" dirty="0">
+                <a:solidFill>
+                  <a:srgbClr val="1A3D1A"/>
+                </a:solidFill>
+                <a:latin typeface="Arial" pitchFamily="34" charset="0"/>
+                <a:ea typeface="Arial" pitchFamily="34" charset="-122"/>
+                <a:cs typeface="Arial" pitchFamily="34" charset="-120"/>
+              </a:rPr>
+              <a:t>Extraction du fichier + configuration .yamllint adaptée</a:t>
+            </a:r>
+          </a:p>
+        </p:txBody>
+      </p:sp>
+    </p:spTree>
+  </p:cSld>
+  <p:clrMapOvr>
+    <a:masterClrMapping/>
+  </p:clrMapOvr>
+</p:sld>
+</file>
+
+<file path=ppt/slides/slide16.xml><?xml version="1.0" encoding="utf-8"?>
+<p:sld xmlns:a="http://schemas.openxmlformats.org/drawingml/2006/main" xmlns:r="http://schemas.openxmlformats.org/officeDocument/2006/relationships" xmlns:p="http://schemas.openxmlformats.org/presentationml/2006/main">
+  <p:cSld>
+    <p:spTree>
+      <p:nvGrpSpPr>
+        <p:cNvPr id="1" name=""/>
+        <p:cNvGrpSpPr/>
+        <p:nvPr/>
+      </p:nvGrpSpPr>
+      <p:grpSpPr>
+        <a:xfrm>
+          <a:off x="0" y="0"/>
+          <a:ext cx="0" cy="0"/>
+          <a:chOff x="0" y="0"/>
+          <a:chExt cx="0" cy="0"/>
+        </a:xfrm>
+      </p:grpSpPr>
+      <p:sp>
+        <p:nvSpPr>
+          <p:cNvPr id="2" name="S2"/>
+          <p:cNvSpPr/>
+          <p:nvPr/>
+        </p:nvSpPr>
+        <p:spPr>
+          <a:xfrm>
+            <a:off x="0" y="0"/>
+            <a:ext cx="12192000" cy="6858000"/>
+          </a:xfrm>
+          <a:prstGeom prst="rect">
+            <a:avLst/>
+          </a:prstGeom>
+          <a:solidFill>
+            <a:srgbClr val="F5F5F5"/>
+          </a:solidFill>
+          <a:ln w="12700">
+            <a:solidFill>
+              <a:srgbClr val="F5F5F5"/>
+            </a:solidFill>
+            <a:prstDash val="solid"/>
+          </a:ln>
+        </p:spPr>
+      </p:sp>
+      <p:sp>
+        <p:nvSpPr>
+          <p:cNvPr id="3" name="S3"/>
+          <p:cNvSpPr/>
+          <p:nvPr/>
+        </p:nvSpPr>
+        <p:spPr>
+          <a:xfrm>
+            <a:off x="0" y="0"/>
+            <a:ext cx="12192000" cy="1234440"/>
+          </a:xfrm>
+          <a:prstGeom prst="rect">
+            <a:avLst/>
+          </a:prstGeom>
+          <a:solidFill>
+            <a:srgbClr val="1A237E"/>
+          </a:solidFill>
+          <a:ln w="12700">
+            <a:solidFill>
+              <a:srgbClr val="1A237E"/>
+            </a:solidFill>
+            <a:prstDash val="solid"/>
+          </a:ln>
+        </p:spPr>
+      </p:sp>
+      <p:sp>
+        <p:nvSpPr>
+          <p:cNvPr id="4" name="S4"/>
+          <p:cNvSpPr/>
+          <p:nvPr/>
+        </p:nvSpPr>
+        <p:spPr>
+          <a:xfrm>
+            <a:off x="0" y="1234440"/>
+            <a:ext cx="12192000" cy="102870"/>
+          </a:xfrm>
+          <a:prstGeom prst="rect">
+            <a:avLst/>
+          </a:prstGeom>
+          <a:solidFill>
+            <a:srgbClr val="00695C"/>
+          </a:solidFill>
+          <a:ln w="12700">
+            <a:solidFill>
+              <a:srgbClr val="00695C"/>
+            </a:solidFill>
+            <a:prstDash val="solid"/>
+          </a:ln>
+        </p:spPr>
+      </p:sp>
+      <p:sp>
+        <p:nvSpPr>
+          <p:cNvPr id="5" name="T5"/>
+          <p:cNvSpPr/>
+          <p:nvPr/>
+        </p:nvSpPr>
+        <p:spPr>
+          <a:xfrm>
+            <a:off x="243840" y="137160"/>
+            <a:ext cx="9753600" cy="822960"/>
+          </a:xfrm>
+          <a:prstGeom prst="rect">
+            <a:avLst/>
+          </a:prstGeom>
+          <a:noFill/>
+          <a:ln/>
+        </p:spPr>
+        <p:txBody>
+          <a:bodyPr wrap="square" rtlCol="0" anchor="ctr"/>
+          <a:lstStyle/>
+          <a:p>
+            <a:pPr indent="0" marL="0">
+              <a:buNone/>
+            </a:pPr>
+            <a:r>
+              <a:rPr lang="fr-FR" sz="2600" b="1" dirty="0">
+                <a:solidFill>
+                  <a:srgbClr val="FFFFFF"/>
+                </a:solidFill>
+                <a:latin typeface="Arial" pitchFamily="34" charset="0"/>
+                <a:ea typeface="Arial" pitchFamily="34" charset="-122"/>
+                <a:cs typeface="Arial" pitchFamily="34" charset="-120"/>
+              </a:rPr>
+              <a:t>Veille &amp; compétences transverses</a:t>
+            </a:r>
+          </a:p>
+        </p:txBody>
+      </p:sp>
+      <p:sp>
+        <p:nvSpPr>
+          <p:cNvPr id="6" name="T6"/>
+          <p:cNvSpPr/>
+          <p:nvPr/>
+        </p:nvSpPr>
+        <p:spPr>
+          <a:xfrm>
+            <a:off x="243840" y="685800"/>
+            <a:ext cx="9753600" cy="548640"/>
+          </a:xfrm>
+          <a:prstGeom prst="rect">
+            <a:avLst/>
+          </a:prstGeom>
+          <a:noFill/>
+          <a:ln/>
+        </p:spPr>
+        <p:txBody>
+          <a:bodyPr wrap="square" rtlCol="0" anchor="ctr"/>
+          <a:lstStyle/>
+          <a:p>
+            <a:pPr indent="0" marL="0">
+              <a:buNone/>
+            </a:pPr>
+            <a:r>
+              <a:rPr lang="fr-FR" sz="1300" i="1" dirty="0">
+                <a:solidFill>
+                  <a:srgbClr val="AACCFF"/>
+                </a:solidFill>
+                <a:latin typeface="Arial" pitchFamily="34" charset="0"/>
+                <a:ea typeface="Arial" pitchFamily="34" charset="-122"/>
+                <a:cs typeface="Arial" pitchFamily="34" charset="-120"/>
+              </a:rPr>
+              <a:t>Au-delà de la technique pure</a:t>
+            </a:r>
+          </a:p>
+        </p:txBody>
+      </p:sp>
+      <p:sp>
+        <p:nvSpPr>
+          <p:cNvPr id="7" name="S7"/>
+          <p:cNvSpPr/>
+          <p:nvPr/>
+        </p:nvSpPr>
+        <p:spPr>
+          <a:xfrm>
+            <a:off x="243840" y="1508760"/>
+            <a:ext cx="5730240" cy="617220"/>
+          </a:xfrm>
+          <a:prstGeom prst="rect">
+            <a:avLst/>
+          </a:prstGeom>
+          <a:solidFill>
+            <a:srgbClr val="00695C"/>
+          </a:solidFill>
+          <a:ln w="12700">
+            <a:solidFill>
+              <a:srgbClr val="00695C"/>
+            </a:solidFill>
+            <a:prstDash val="solid"/>
+          </a:ln>
+        </p:spPr>
+      </p:sp>
+      <p:sp>
+        <p:nvSpPr>
+          <p:cNvPr id="8" name="T8"/>
+          <p:cNvSpPr/>
+          <p:nvPr/>
+        </p:nvSpPr>
+        <p:spPr>
+          <a:xfrm>
+            <a:off x="365760" y="1508760"/>
+            <a:ext cx="5486400" cy="617220"/>
+          </a:xfrm>
+          <a:prstGeom prst="rect">
+            <a:avLst/>
+          </a:prstGeom>
+          <a:noFill/>
+          <a:ln/>
+        </p:spPr>
+        <p:txBody>
+          <a:bodyPr wrap="square" rtlCol="0" anchor="ctr"/>
+          <a:lstStyle/>
+          <a:p>
+            <a:pPr indent="0" marL="0">
+              <a:buNone/>
+            </a:pPr>
+            <a:r>
+              <a:rPr lang="fr-FR" sz="1200" b="1" dirty="0">
+                <a:solidFill>
+                  <a:srgbClr val="FFFFFF"/>
+                </a:solidFill>
+                <a:latin typeface="Arial" pitchFamily="34" charset="0"/>
+                <a:ea typeface="Arial" pitchFamily="34" charset="-122"/>
+                <a:cs typeface="Arial" pitchFamily="34" charset="-120"/>
+              </a:rPr>
+              <a:t>Anglais technique (BC03-CP3)</a:t>
+            </a:r>
+          </a:p>
+        </p:txBody>
+      </p:sp>
+      <p:sp>
+        <p:nvSpPr>
+          <p:cNvPr id="9" name="S9"/>
+          <p:cNvSpPr/>
+          <p:nvPr/>
+        </p:nvSpPr>
+        <p:spPr>
+          <a:xfrm>
+            <a:off x="243840" y="2125980"/>
+            <a:ext cx="5730240" cy="1783080"/>
+          </a:xfrm>
+          <a:prstGeom prst="rect">
+            <a:avLst/>
+          </a:prstGeom>
+          <a:solidFill>
+            <a:srgbClr val="FFFFFF"/>
+          </a:solidFill>
+          <a:ln w="12700">
+            <a:solidFill>
+              <a:srgbClr val="DDDDDD"/>
+            </a:solidFill>
+            <a:prstDash val="solid"/>
+          </a:ln>
+        </p:spPr>
+      </p:sp>
+      <p:sp>
+        <p:nvSpPr>
+          <p:cNvPr id="10" name="T10"/>
+          <p:cNvSpPr/>
+          <p:nvPr/>
+        </p:nvSpPr>
+        <p:spPr>
+          <a:xfrm>
+            <a:off x="365760" y="2228850"/>
+            <a:ext cx="5486400" cy="1577340"/>
+          </a:xfrm>
+          <a:prstGeom prst="rect">
+            <a:avLst/>
+          </a:prstGeom>
+          <a:noFill/>
+          <a:ln/>
+        </p:spPr>
+        <p:txBody>
+          <a:bodyPr wrap="square" rtlCol="0" anchor="t"/>
+          <a:lstStyle/>
+          <a:p>
+            <a:pPr indent="0" marL="0">
+              <a:buNone/>
+            </a:pPr>
+            <a:r>
+              <a:rPr lang="fr-FR" sz="1000" dirty="0">
+                <a:solidFill>
+                  <a:srgbClr val="222222"/>
+                </a:solidFill>
+                <a:latin typeface="Arial" pitchFamily="34" charset="0"/>
+                <a:ea typeface="Arial" pitchFamily="34" charset="-122"/>
+                <a:cs typeface="Arial" pitchFamily="34" charset="-120"/>
+              </a:rPr>
+              <a:t>• Commits, code et CI en anglais</a:t>
+            </a:r>
+          </a:p>
+          <a:p>
+            <a:pPr indent="0" marL="0">
+              <a:buNone/>
+            </a:pPr>
+            <a:r>
+              <a:rPr lang="fr-FR" sz="1000" dirty="0">
+                <a:solidFill>
+                  <a:srgbClr val="222222"/>
+                </a:solidFill>
+                <a:latin typeface="Arial" pitchFamily="34" charset="0"/>
+                <a:ea typeface="Arial" pitchFamily="34" charset="-122"/>
+                <a:cs typeface="Arial" pitchFamily="34" charset="-120"/>
+              </a:rPr>
+              <a:t>• Lecture de la doc officielle en anglais</a:t>
+            </a:r>
+          </a:p>
+          <a:p>
+            <a:pPr indent="0" marL="0">
+              <a:buNone/>
+            </a:pPr>
+            <a:r>
+              <a:rPr lang="fr-FR" sz="1000" dirty="0">
+                <a:solidFill>
+                  <a:srgbClr val="222222"/>
+                </a:solidFill>
+                <a:latin typeface="Arial" pitchFamily="34" charset="0"/>
+                <a:ea typeface="Arial" pitchFamily="34" charset="-122"/>
+                <a:cs typeface="Arial" pitchFamily="34" charset="-120"/>
+              </a:rPr>
+              <a:t>• Vocabulaire DevOps maîtrisé</a:t>
+            </a:r>
+          </a:p>
+        </p:txBody>
+      </p:sp>
+      <p:sp>
+        <p:nvSpPr>
+          <p:cNvPr id="11" name="S11"/>
+          <p:cNvSpPr/>
+          <p:nvPr/>
+        </p:nvSpPr>
+        <p:spPr>
+          <a:xfrm>
+            <a:off x="6217920" y="1508760"/>
+            <a:ext cx="5730240" cy="617220"/>
+          </a:xfrm>
+          <a:prstGeom prst="rect">
+            <a:avLst/>
+          </a:prstGeom>
+          <a:solidFill>
+            <a:srgbClr val="1565C0"/>
+          </a:solidFill>
+          <a:ln w="12700">
+            <a:solidFill>
+              <a:srgbClr val="1565C0"/>
+            </a:solidFill>
+            <a:prstDash val="solid"/>
+          </a:ln>
+        </p:spPr>
+      </p:sp>
+      <p:sp>
+        <p:nvSpPr>
+          <p:cNvPr id="12" name="T12"/>
+          <p:cNvSpPr/>
+          <p:nvPr/>
+        </p:nvSpPr>
+        <p:spPr>
+          <a:xfrm>
+            <a:off x="6339840" y="1508760"/>
+            <a:ext cx="5486400" cy="617220"/>
+          </a:xfrm>
+          <a:prstGeom prst="rect">
+            <a:avLst/>
+          </a:prstGeom>
+          <a:noFill/>
+          <a:ln/>
+        </p:spPr>
+        <p:txBody>
+          <a:bodyPr wrap="square" rtlCol="0" anchor="ctr"/>
+          <a:lstStyle/>
+          <a:p>
+            <a:pPr indent="0" marL="0">
+              <a:buNone/>
+            </a:pPr>
+            <a:r>
+              <a:rPr lang="fr-FR" sz="1200" b="1" dirty="0">
+                <a:solidFill>
+                  <a:srgbClr val="FFFFFF"/>
+                </a:solidFill>
+                <a:latin typeface="Arial" pitchFamily="34" charset="0"/>
+                <a:ea typeface="Arial" pitchFamily="34" charset="-122"/>
+                <a:cs typeface="Arial" pitchFamily="34" charset="-120"/>
+              </a:rPr>
+              <a:t>Veille technologique</a:t>
+            </a:r>
+          </a:p>
+        </p:txBody>
+      </p:sp>
+      <p:sp>
+        <p:nvSpPr>
+          <p:cNvPr id="13" name="S13"/>
+          <p:cNvSpPr/>
+          <p:nvPr/>
+        </p:nvSpPr>
+        <p:spPr>
+          <a:xfrm>
+            <a:off x="6217920" y="2125980"/>
+            <a:ext cx="5730240" cy="1783080"/>
+          </a:xfrm>
+          <a:prstGeom prst="rect">
+            <a:avLst/>
+          </a:prstGeom>
+          <a:solidFill>
+            <a:srgbClr val="FFFFFF"/>
+          </a:solidFill>
+          <a:ln w="12700">
+            <a:solidFill>
+              <a:srgbClr val="DDDDDD"/>
+            </a:solidFill>
+            <a:prstDash val="solid"/>
+          </a:ln>
+        </p:spPr>
+      </p:sp>
+      <p:sp>
+        <p:nvSpPr>
+          <p:cNvPr id="14" name="T14"/>
+          <p:cNvSpPr/>
+          <p:nvPr/>
+        </p:nvSpPr>
+        <p:spPr>
+          <a:xfrm>
+            <a:off x="6339840" y="2228850"/>
+            <a:ext cx="5486400" cy="1577340"/>
+          </a:xfrm>
+          <a:prstGeom prst="rect">
+            <a:avLst/>
+          </a:prstGeom>
+          <a:noFill/>
+          <a:ln/>
+        </p:spPr>
+        <p:txBody>
+          <a:bodyPr wrap="square" rtlCol="0" anchor="t"/>
+          <a:lstStyle/>
+          <a:p>
+            <a:pPr indent="0" marL="0">
+              <a:buNone/>
+            </a:pPr>
+            <a:r>
+              <a:rPr lang="fr-FR" sz="1000" dirty="0">
+                <a:solidFill>
+                  <a:srgbClr val="222222"/>
+                </a:solidFill>
+                <a:latin typeface="Arial" pitchFamily="34" charset="0"/>
+                <a:ea typeface="Arial" pitchFamily="34" charset="-122"/>
+                <a:cs typeface="Arial" pitchFamily="34" charset="-120"/>
+              </a:rPr>
+              <a:t>• Doc Prometheus, Kubernetes, Ansible</a:t>
+            </a:r>
+          </a:p>
+          <a:p>
+            <a:pPr indent="0" marL="0">
+              <a:buNone/>
+            </a:pPr>
+            <a:r>
+              <a:rPr lang="fr-FR" sz="1000" dirty="0">
+                <a:solidFill>
+                  <a:srgbClr val="222222"/>
+                </a:solidFill>
+                <a:latin typeface="Arial" pitchFamily="34" charset="0"/>
+                <a:ea typeface="Arial" pitchFamily="34" charset="-122"/>
+                <a:cs typeface="Arial" pitchFamily="34" charset="-120"/>
+              </a:rPr>
+              <a:t>• Bonnes pratiques DevOps / sécurité</a:t>
+            </a:r>
+          </a:p>
+          <a:p>
+            <a:pPr indent="0" marL="0">
+              <a:buNone/>
+            </a:pPr>
+            <a:r>
+              <a:rPr lang="fr-FR" sz="1000" dirty="0">
+                <a:solidFill>
+                  <a:srgbClr val="222222"/>
+                </a:solidFill>
+                <a:latin typeface="Arial" pitchFamily="34" charset="0"/>
+                <a:ea typeface="Arial" pitchFamily="34" charset="-122"/>
+                <a:cs typeface="Arial" pitchFamily="34" charset="-120"/>
+              </a:rPr>
+              <a:t>• Suivi des versions (MariaDB 11, etc.)</a:t>
+            </a:r>
+          </a:p>
+        </p:txBody>
+      </p:sp>
+      <p:sp>
+        <p:nvSpPr>
+          <p:cNvPr id="15" name="S15"/>
+          <p:cNvSpPr/>
+          <p:nvPr/>
+        </p:nvSpPr>
+        <p:spPr>
+          <a:xfrm>
+            <a:off x="243840" y="4114800"/>
+            <a:ext cx="5730240" cy="617220"/>
+          </a:xfrm>
+          <a:prstGeom prst="rect">
+            <a:avLst/>
+          </a:prstGeom>
+          <a:solidFill>
+            <a:srgbClr val="4A148C"/>
+          </a:solidFill>
+          <a:ln w="12700">
+            <a:solidFill>
+              <a:srgbClr val="4A148C"/>
+            </a:solidFill>
+            <a:prstDash val="solid"/>
+          </a:ln>
+        </p:spPr>
+      </p:sp>
+      <p:sp>
+        <p:nvSpPr>
+          <p:cNvPr id="16" name="T16"/>
+          <p:cNvSpPr/>
+          <p:nvPr/>
+        </p:nvSpPr>
+        <p:spPr>
+          <a:xfrm>
+            <a:off x="365760" y="4114800"/>
+            <a:ext cx="5486400" cy="617220"/>
+          </a:xfrm>
+          <a:prstGeom prst="rect">
+            <a:avLst/>
+          </a:prstGeom>
+          <a:noFill/>
+          <a:ln/>
+        </p:spPr>
+        <p:txBody>
+          <a:bodyPr wrap="square" rtlCol="0" anchor="ctr"/>
+          <a:lstStyle/>
+          <a:p>
+            <a:pPr indent="0" marL="0">
+              <a:buNone/>
+            </a:pPr>
+            <a:r>
+              <a:rPr lang="fr-FR" sz="1200" b="1" dirty="0">
+                <a:solidFill>
+                  <a:srgbClr val="FFFFFF"/>
+                </a:solidFill>
+                <a:latin typeface="Arial" pitchFamily="34" charset="0"/>
+                <a:ea typeface="Arial" pitchFamily="34" charset="-122"/>
+                <a:cs typeface="Arial" pitchFamily="34" charset="-120"/>
+              </a:rPr>
+              <a:t>Compétences réutilisées</a:t>
+            </a:r>
+          </a:p>
+        </p:txBody>
+      </p:sp>
+      <p:sp>
+        <p:nvSpPr>
+          <p:cNvPr id="17" name="S17"/>
+          <p:cNvSpPr/>
+          <p:nvPr/>
+        </p:nvSpPr>
+        <p:spPr>
+          <a:xfrm>
+            <a:off x="243840" y="4732020"/>
+            <a:ext cx="5730240" cy="1783080"/>
+          </a:xfrm>
+          <a:prstGeom prst="rect">
+            <a:avLst/>
+          </a:prstGeom>
+          <a:solidFill>
+            <a:srgbClr val="FFFFFF"/>
+          </a:solidFill>
+          <a:ln w="12700">
+            <a:solidFill>
+              <a:srgbClr val="DDDDDD"/>
+            </a:solidFill>
+            <a:prstDash val="solid"/>
+          </a:ln>
+        </p:spPr>
+      </p:sp>
+      <p:sp>
+        <p:nvSpPr>
+          <p:cNvPr id="18" name="T18"/>
+          <p:cNvSpPr/>
+          <p:nvPr/>
+        </p:nvSpPr>
+        <p:spPr>
+          <a:xfrm>
+            <a:off x="365760" y="4834890"/>
+            <a:ext cx="5486400" cy="1577340"/>
+          </a:xfrm>
+          <a:prstGeom prst="rect">
+            <a:avLst/>
+          </a:prstGeom>
+          <a:noFill/>
+          <a:ln/>
+        </p:spPr>
+        <p:txBody>
+          <a:bodyPr wrap="square" rtlCol="0" anchor="t"/>
+          <a:lstStyle/>
+          <a:p>
+            <a:pPr indent="0" marL="0">
+              <a:buNone/>
+            </a:pPr>
+            <a:r>
+              <a:rPr lang="fr-FR" sz="1000" dirty="0">
+                <a:solidFill>
+                  <a:srgbClr val="222222"/>
+                </a:solidFill>
+                <a:latin typeface="Arial" pitchFamily="34" charset="0"/>
+                <a:ea typeface="Arial" pitchFamily="34" charset="-122"/>
+                <a:cs typeface="Arial" pitchFamily="34" charset="-120"/>
+              </a:rPr>
+              <a:t>• dropshop : déploiement AWS ECS</a:t>
+            </a:r>
+          </a:p>
+          <a:p>
+            <a:pPr indent="0" marL="0">
+              <a:buNone/>
+            </a:pPr>
+            <a:r>
+              <a:rPr lang="fr-FR" sz="1000" dirty="0">
+                <a:solidFill>
+                  <a:srgbClr val="222222"/>
+                </a:solidFill>
+                <a:latin typeface="Arial" pitchFamily="34" charset="0"/>
+                <a:ea typeface="Arial" pitchFamily="34" charset="-122"/>
+                <a:cs typeface="Arial" pitchFamily="34" charset="-120"/>
+              </a:rPr>
+              <a:t>• chatbot-rag : CI/CD GitLab</a:t>
+            </a:r>
+          </a:p>
+          <a:p>
+            <a:pPr indent="0" marL="0">
+              <a:buNone/>
+            </a:pPr>
+            <a:r>
+              <a:rPr lang="fr-FR" sz="1000" dirty="0">
+                <a:solidFill>
+                  <a:srgbClr val="222222"/>
+                </a:solidFill>
+                <a:latin typeface="Arial" pitchFamily="34" charset="0"/>
+                <a:ea typeface="Arial" pitchFamily="34" charset="-122"/>
+                <a:cs typeface="Arial" pitchFamily="34" charset="-120"/>
+              </a:rPr>
+              <a:t>• avance-web : déploiement continu Vercel</a:t>
+            </a:r>
+          </a:p>
+        </p:txBody>
+      </p:sp>
+      <p:sp>
+        <p:nvSpPr>
+          <p:cNvPr id="19" name="S19"/>
+          <p:cNvSpPr/>
+          <p:nvPr/>
+        </p:nvSpPr>
+        <p:spPr>
+          <a:xfrm>
+            <a:off x="6217920" y="4114800"/>
+            <a:ext cx="5730240" cy="617220"/>
+          </a:xfrm>
+          <a:prstGeom prst="rect">
+            <a:avLst/>
+          </a:prstGeom>
+          <a:solidFill>
+            <a:srgbClr val="2E7D32"/>
+          </a:solidFill>
+          <a:ln w="12700">
+            <a:solidFill>
+              <a:srgbClr val="2E7D32"/>
+            </a:solidFill>
+            <a:prstDash val="solid"/>
+          </a:ln>
+        </p:spPr>
+      </p:sp>
+      <p:sp>
+        <p:nvSpPr>
+          <p:cNvPr id="20" name="T20"/>
+          <p:cNvSpPr/>
+          <p:nvPr/>
+        </p:nvSpPr>
+        <p:spPr>
+          <a:xfrm>
+            <a:off x="6339840" y="4114800"/>
+            <a:ext cx="5486400" cy="617220"/>
+          </a:xfrm>
+          <a:prstGeom prst="rect">
+            <a:avLst/>
+          </a:prstGeom>
+          <a:noFill/>
+          <a:ln/>
+        </p:spPr>
+        <p:txBody>
+          <a:bodyPr wrap="square" rtlCol="0" anchor="ctr"/>
+          <a:lstStyle/>
+          <a:p>
+            <a:pPr indent="0" marL="0">
+              <a:buNone/>
+            </a:pPr>
+            <a:r>
+              <a:rPr lang="fr-FR" sz="1200" b="1" dirty="0">
+                <a:solidFill>
+                  <a:srgbClr val="FFFFFF"/>
+                </a:solidFill>
+                <a:latin typeface="Arial" pitchFamily="34" charset="0"/>
+                <a:ea typeface="Arial" pitchFamily="34" charset="-122"/>
+                <a:cs typeface="Arial" pitchFamily="34" charset="-120"/>
+              </a:rPr>
+              <a:t>Posture professionnelle</a:t>
+            </a:r>
+          </a:p>
+        </p:txBody>
+      </p:sp>
+      <p:sp>
+        <p:nvSpPr>
+          <p:cNvPr id="21" name="S21"/>
+          <p:cNvSpPr/>
+          <p:nvPr/>
+        </p:nvSpPr>
+        <p:spPr>
+          <a:xfrm>
+            <a:off x="6217920" y="4732020"/>
+            <a:ext cx="5730240" cy="1783080"/>
+          </a:xfrm>
+          <a:prstGeom prst="rect">
+            <a:avLst/>
+          </a:prstGeom>
+          <a:solidFill>
+            <a:srgbClr val="FFFFFF"/>
+          </a:solidFill>
+          <a:ln w="12700">
+            <a:solidFill>
+              <a:srgbClr val="DDDDDD"/>
+            </a:solidFill>
+            <a:prstDash val="solid"/>
+          </a:ln>
+        </p:spPr>
+      </p:sp>
+      <p:sp>
+        <p:nvSpPr>
+          <p:cNvPr id="22" name="T22"/>
+          <p:cNvSpPr/>
+          <p:nvPr/>
+        </p:nvSpPr>
+        <p:spPr>
+          <a:xfrm>
+            <a:off x="6339840" y="4834890"/>
+            <a:ext cx="5486400" cy="1577340"/>
+          </a:xfrm>
+          <a:prstGeom prst="rect">
+            <a:avLst/>
+          </a:prstGeom>
+          <a:noFill/>
+          <a:ln/>
+        </p:spPr>
+        <p:txBody>
+          <a:bodyPr wrap="square" rtlCol="0" anchor="t"/>
+          <a:lstStyle/>
+          <a:p>
+            <a:pPr indent="0" marL="0">
+              <a:buNone/>
+            </a:pPr>
+            <a:r>
+              <a:rPr lang="fr-FR" sz="1000" dirty="0">
+                <a:solidFill>
+                  <a:srgbClr val="222222"/>
+                </a:solidFill>
+                <a:latin typeface="Arial" pitchFamily="34" charset="0"/>
+                <a:ea typeface="Arial" pitchFamily="34" charset="-122"/>
+                <a:cs typeface="Arial" pitchFamily="34" charset="-120"/>
+              </a:rPr>
+              <a:t>• Autonomie et résolution de problèmes</a:t>
+            </a:r>
+          </a:p>
+          <a:p>
+            <a:pPr indent="0" marL="0">
+              <a:buNone/>
+            </a:pPr>
+            <a:r>
+              <a:rPr lang="fr-FR" sz="1000" dirty="0">
+                <a:solidFill>
+                  <a:srgbClr val="222222"/>
+                </a:solidFill>
+                <a:latin typeface="Arial" pitchFamily="34" charset="0"/>
+                <a:ea typeface="Arial" pitchFamily="34" charset="-122"/>
+                <a:cs typeface="Arial" pitchFamily="34" charset="-120"/>
+              </a:rPr>
+              <a:t>• Prise en compte des retours formateur</a:t>
+            </a:r>
+          </a:p>
+          <a:p>
+            <a:pPr indent="0" marL="0">
+              <a:buNone/>
+            </a:pPr>
+            <a:r>
+              <a:rPr lang="fr-FR" sz="1000" dirty="0">
+                <a:solidFill>
+                  <a:srgbClr val="222222"/>
+                </a:solidFill>
+                <a:latin typeface="Arial" pitchFamily="34" charset="0"/>
+                <a:ea typeface="Arial" pitchFamily="34" charset="-122"/>
+                <a:cs typeface="Arial" pitchFamily="34" charset="-120"/>
+              </a:rPr>
+              <a:t>• Capacité à expliquer chaque ligne livrée</a:t>
+            </a:r>
           </a:p>
         </p:txBody>
       </p:sp>

</xml_diff>

<commit_message>
docs(pptx): replace architecture slide with new nested-box diagram image
Co-Authored-By: Claude Opus 4.8 <noreply@anthropic.com>
</commit_message>
<xml_diff>
--- a/documentation/Presentation_iac-infra_ASD.pptx
+++ b/documentation/Presentation_iac-infra_ASD.pptx
@@ -12459,7 +12459,7 @@
 
 <file path=ppt/slides/slide4.xml><?xml version="1.0" encoding="utf-8"?>
 <p:sld xmlns:a="http://schemas.openxmlformats.org/drawingml/2006/main" xmlns:r="http://schemas.openxmlformats.org/officeDocument/2006/relationships" xmlns:p="http://schemas.openxmlformats.org/presentationml/2006/main">
-  <p:cSld name="Slide 4">
+  <p:cSld>
     <p:spTree>
       <p:nvGrpSpPr>
         <p:cNvPr id="1" name=""/>
@@ -12476,7 +12476,7 @@
       </p:grpSpPr>
       <p:sp>
         <p:nvSpPr>
-          <p:cNvPr id="2" name="Shape 0"/>
+          <p:cNvPr id="2" name="S2"/>
           <p:cNvSpPr/>
           <p:nvPr/>
         </p:nvSpPr>
@@ -12489,11 +12489,11 @@
             <a:avLst/>
           </a:prstGeom>
           <a:solidFill>
-            <a:srgbClr val="0D1B2A"/>
+            <a:srgbClr val="F5F5F5"/>
           </a:solidFill>
           <a:ln w="12700">
             <a:solidFill>
-              <a:srgbClr val="0D1B2A"/>
+              <a:srgbClr val="F5F5F5"/>
             </a:solidFill>
             <a:prstDash val="solid"/>
           </a:ln>
@@ -12501,7 +12501,7 @@
       </p:sp>
       <p:sp>
         <p:nvSpPr>
-          <p:cNvPr id="3" name="Shape 1"/>
+          <p:cNvPr id="3" name="S3"/>
           <p:cNvSpPr/>
           <p:nvPr/>
         </p:nvSpPr>
@@ -12526,7 +12526,7 @@
       </p:sp>
       <p:sp>
         <p:nvSpPr>
-          <p:cNvPr id="4" name="Shape 2"/>
+          <p:cNvPr id="4" name="S4"/>
           <p:cNvSpPr/>
           <p:nvPr/>
         </p:nvSpPr>
@@ -12551,7 +12551,7 @@
       </p:sp>
       <p:sp>
         <p:nvSpPr>
-          <p:cNvPr id="5" name="Text 3"/>
+          <p:cNvPr id="5" name="T5"/>
           <p:cNvSpPr/>
           <p:nvPr/>
         </p:nvSpPr>
@@ -12574,23 +12574,20 @@
               <a:buNone/>
             </a:pPr>
             <a:r>
-              <a:rPr lang="en-US" sz="2600" b="1" dirty="0">
+              <a:rPr lang="fr-FR" sz="2600" b="1" dirty="0">
                 <a:solidFill>
                   <a:srgbClr val="FFFFFF"/>
                 </a:solidFill>
                 <a:latin typeface="Arial" pitchFamily="34" charset="0"/>
-                <a:ea typeface="Arial" pitchFamily="34" charset="-122"/>
-                <a:cs typeface="Arial" pitchFamily="34" charset="-120"/>
               </a:rPr>
               <a:t>Architecture globale</a:t>
             </a:r>
-            <a:endParaRPr lang="en-US" sz="2600" dirty="0"/>
-          </a:p>
-        </p:txBody>
-      </p:sp>
-      <p:sp>
-        <p:nvSpPr>
-          <p:cNvPr id="6" name="Text 4"/>
+          </a:p>
+        </p:txBody>
+      </p:sp>
+      <p:sp>
+        <p:nvSpPr>
+          <p:cNvPr id="6" name="T6"/>
           <p:cNvSpPr/>
           <p:nvPr/>
         </p:nvSpPr>
@@ -12613,1585 +12610,41 @@
               <a:buNone/>
             </a:pPr>
             <a:r>
-              <a:rPr lang="en-US" sz="1300" i="1" dirty="0">
+              <a:rPr lang="fr-FR" sz="1300" i="1" dirty="0">
                 <a:solidFill>
                   <a:srgbClr val="AACCFF"/>
                 </a:solidFill>
                 <a:latin typeface="Arial" pitchFamily="34" charset="0"/>
-                <a:ea typeface="Arial" pitchFamily="34" charset="-122"/>
-                <a:cs typeface="Arial" pitchFamily="34" charset="-120"/>
               </a:rPr>
               <a:t>Vue d'ensemble du système iac-infra</a:t>
             </a:r>
-            <a:endParaRPr lang="en-US" sz="1300" dirty="0"/>
-          </a:p>
-        </p:txBody>
-      </p:sp>
-      <p:sp>
-        <p:nvSpPr>
-          <p:cNvPr id="7" name="Shape 5"/>
-          <p:cNvSpPr/>
-          <p:nvPr/>
-        </p:nvSpPr>
-        <p:spPr>
-          <a:xfrm>
-            <a:off x="244145" y="1371600"/>
-            <a:ext cx="2437790" cy="4937760"/>
-          </a:xfrm>
-          <a:prstGeom prst="roundRect">
-            <a:avLst>
-              <a:gd name="adj" fmla="val 3001"/>
-            </a:avLst>
-          </a:prstGeom>
-          <a:solidFill>
-            <a:srgbClr val="00695C"/>
-          </a:solidFill>
-          <a:ln w="12700">
-            <a:solidFill>
-              <a:srgbClr val="00695C"/>
-            </a:solidFill>
-            <a:prstDash val="solid"/>
-          </a:ln>
-        </p:spPr>
-      </p:sp>
-      <p:sp>
-        <p:nvSpPr>
-          <p:cNvPr id="8" name="Text 6"/>
-          <p:cNvSpPr/>
-          <p:nvPr/>
-        </p:nvSpPr>
-        <p:spPr>
-          <a:xfrm>
-            <a:off x="244145" y="1371600"/>
-            <a:ext cx="2437790" cy="822960"/>
-          </a:xfrm>
-          <a:prstGeom prst="rect">
-            <a:avLst/>
-          </a:prstGeom>
-          <a:noFill/>
-          <a:ln/>
-        </p:spPr>
-        <p:txBody>
-          <a:bodyPr wrap="square" rtlCol="0" anchor="ctr"/>
-          <a:lstStyle/>
-          <a:p>
-            <a:pPr algn="ctr" indent="0" marL="0">
-              <a:buNone/>
-            </a:pPr>
-            <a:r>
-              <a:rPr lang="en-US" sz="1100" b="1" dirty="0">
-                <a:solidFill>
-                  <a:srgbClr val="FFFFFF"/>
-                </a:solidFill>
-                <a:latin typeface="Arial" pitchFamily="34" charset="0"/>
-                <a:ea typeface="Arial" pitchFamily="34" charset="-122"/>
-                <a:cs typeface="Arial" pitchFamily="34" charset="-120"/>
-              </a:rPr>
-              <a:t>COUCHE 1</a:t>
-            </a:r>
-            <a:endParaRPr lang="en-US" sz="1100" dirty="0"/>
-          </a:p>
-          <a:p>
-            <a:pPr algn="ctr" indent="0" marL="0">
-              <a:buNone/>
-            </a:pPr>
-            <a:r>
-              <a:rPr lang="en-US" sz="1100" b="1" dirty="0">
-                <a:solidFill>
-                  <a:srgbClr val="FFFFFF"/>
-                </a:solidFill>
-                <a:latin typeface="Arial" pitchFamily="34" charset="0"/>
-                <a:ea typeface="Arial" pitchFamily="34" charset="-122"/>
-                <a:cs typeface="Arial" pitchFamily="34" charset="-120"/>
-              </a:rPr>
-              <a:t>IaC &amp; Config</a:t>
-            </a:r>
-            <a:endParaRPr lang="en-US" sz="1100" dirty="0"/>
-          </a:p>
-        </p:txBody>
-      </p:sp>
-      <p:sp>
-        <p:nvSpPr>
-          <p:cNvPr id="9" name="Shape 7"/>
-          <p:cNvSpPr/>
-          <p:nvPr/>
-        </p:nvSpPr>
-        <p:spPr>
-          <a:xfrm>
-            <a:off x="365760" y="2331720"/>
-            <a:ext cx="2193646" cy="1028700"/>
-          </a:xfrm>
-          <a:prstGeom prst="roundRect">
-            <a:avLst>
-              <a:gd name="adj" fmla="val 5333"/>
-            </a:avLst>
-          </a:prstGeom>
-          <a:solidFill>
-            <a:srgbClr val="FFFFFF">
-              <a:alpha val="85000"/>
-            </a:srgbClr>
-          </a:solidFill>
-          <a:ln w="12700">
-            <a:solidFill>
-              <a:srgbClr val="FFFFFF">
-                <a:alpha val="60000"/>
-              </a:srgbClr>
-            </a:solidFill>
-            <a:prstDash val="solid"/>
-          </a:ln>
-        </p:spPr>
-      </p:sp>
-      <p:sp>
-        <p:nvSpPr>
-          <p:cNvPr id="10" name="Text 8"/>
-          <p:cNvSpPr/>
-          <p:nvPr/>
-        </p:nvSpPr>
-        <p:spPr>
-          <a:xfrm>
-            <a:off x="365760" y="2331720"/>
-            <a:ext cx="2193646" cy="1028700"/>
-          </a:xfrm>
-          <a:prstGeom prst="rect">
-            <a:avLst/>
-          </a:prstGeom>
-          <a:noFill/>
-          <a:ln/>
-        </p:spPr>
-        <p:txBody>
-          <a:bodyPr wrap="square" rtlCol="0" anchor="ctr"/>
-          <a:lstStyle/>
-          <a:p>
-            <a:pPr algn="ctr" indent="0" marL="0">
-              <a:buNone/>
-            </a:pPr>
-            <a:r>
-              <a:rPr lang="en-US" sz="1000" b="1" dirty="0">
-                <a:solidFill>
-                  <a:srgbClr val="FFFFFF"/>
-                </a:solidFill>
-                <a:latin typeface="Arial" pitchFamily="34" charset="0"/>
-                <a:ea typeface="Arial" pitchFamily="34" charset="-122"/>
-                <a:cs typeface="Arial" pitchFamily="34" charset="-120"/>
-              </a:rPr>
-              <a:t>Vagrantfile</a:t>
-            </a:r>
-            <a:endParaRPr lang="en-US" sz="1000" dirty="0"/>
-          </a:p>
-        </p:txBody>
-      </p:sp>
-      <p:sp>
-        <p:nvSpPr>
-          <p:cNvPr id="11" name="Shape 9"/>
-          <p:cNvSpPr/>
-          <p:nvPr/>
-        </p:nvSpPr>
-        <p:spPr>
-          <a:xfrm>
-            <a:off x="365760" y="3566160"/>
-            <a:ext cx="2193646" cy="1028700"/>
-          </a:xfrm>
-          <a:prstGeom prst="roundRect">
-            <a:avLst>
-              <a:gd name="adj" fmla="val 5333"/>
-            </a:avLst>
-          </a:prstGeom>
-          <a:solidFill>
-            <a:srgbClr val="FFFFFF">
-              <a:alpha val="85000"/>
-            </a:srgbClr>
-          </a:solidFill>
-          <a:ln w="12700">
-            <a:solidFill>
-              <a:srgbClr val="FFFFFF">
-                <a:alpha val="60000"/>
-              </a:srgbClr>
-            </a:solidFill>
-            <a:prstDash val="solid"/>
-          </a:ln>
-        </p:spPr>
-      </p:sp>
-      <p:sp>
-        <p:nvSpPr>
-          <p:cNvPr id="12" name="Text 10"/>
-          <p:cNvSpPr/>
-          <p:nvPr/>
-        </p:nvSpPr>
-        <p:spPr>
-          <a:xfrm>
-            <a:off x="365760" y="3566160"/>
-            <a:ext cx="2193646" cy="1028700"/>
-          </a:xfrm>
-          <a:prstGeom prst="rect">
-            <a:avLst/>
-          </a:prstGeom>
-          <a:noFill/>
-          <a:ln/>
-        </p:spPr>
-        <p:txBody>
-          <a:bodyPr wrap="square" rtlCol="0" anchor="ctr"/>
-          <a:lstStyle/>
-          <a:p>
-            <a:pPr algn="ctr" indent="0" marL="0">
-              <a:buNone/>
-            </a:pPr>
-            <a:r>
-              <a:rPr lang="en-US" sz="1000" b="1" dirty="0">
-                <a:solidFill>
-                  <a:srgbClr val="FFFFFF"/>
-                </a:solidFill>
-                <a:latin typeface="Arial" pitchFamily="34" charset="0"/>
-                <a:ea typeface="Arial" pitchFamily="34" charset="-122"/>
-                <a:cs typeface="Arial" pitchFamily="34" charset="-120"/>
-              </a:rPr>
-              <a:t>Ansible</a:t>
-            </a:r>
-            <a:endParaRPr lang="en-US" sz="1000" dirty="0"/>
-          </a:p>
-          <a:p>
-            <a:pPr algn="ctr" indent="0" marL="0">
-              <a:buNone/>
-            </a:pPr>
-            <a:r>
-              <a:rPr lang="en-US" sz="1000" b="1" dirty="0">
-                <a:solidFill>
-                  <a:srgbClr val="FFFFFF"/>
-                </a:solidFill>
-                <a:latin typeface="Arial" pitchFamily="34" charset="0"/>
-                <a:ea typeface="Arial" pitchFamily="34" charset="-122"/>
-                <a:cs typeface="Arial" pitchFamily="34" charset="-120"/>
-              </a:rPr>
-              <a:t>3 rôles</a:t>
-            </a:r>
-            <a:endParaRPr lang="en-US" sz="1000" dirty="0"/>
-          </a:p>
-        </p:txBody>
-      </p:sp>
-      <p:sp>
-        <p:nvSpPr>
-          <p:cNvPr id="13" name="Shape 11"/>
-          <p:cNvSpPr/>
-          <p:nvPr/>
-        </p:nvSpPr>
-        <p:spPr>
-          <a:xfrm>
-            <a:off x="365760" y="4800600"/>
-            <a:ext cx="2193646" cy="1028700"/>
-          </a:xfrm>
-          <a:prstGeom prst="roundRect">
-            <a:avLst>
-              <a:gd name="adj" fmla="val 5333"/>
-            </a:avLst>
-          </a:prstGeom>
-          <a:solidFill>
-            <a:srgbClr val="FFFFFF">
-              <a:alpha val="85000"/>
-            </a:srgbClr>
-          </a:solidFill>
-          <a:ln w="12700">
-            <a:solidFill>
-              <a:srgbClr val="FFFFFF">
-                <a:alpha val="60000"/>
-              </a:srgbClr>
-            </a:solidFill>
-            <a:prstDash val="solid"/>
-          </a:ln>
-        </p:spPr>
-      </p:sp>
-      <p:sp>
-        <p:nvSpPr>
-          <p:cNvPr id="14" name="Text 12"/>
-          <p:cNvSpPr/>
-          <p:nvPr/>
-        </p:nvSpPr>
-        <p:spPr>
-          <a:xfrm>
-            <a:off x="365760" y="4800600"/>
-            <a:ext cx="2193646" cy="1028700"/>
-          </a:xfrm>
-          <a:prstGeom prst="rect">
-            <a:avLst/>
-          </a:prstGeom>
-          <a:noFill/>
-          <a:ln/>
-        </p:spPr>
-        <p:txBody>
-          <a:bodyPr wrap="square" rtlCol="0" anchor="ctr"/>
-          <a:lstStyle/>
-          <a:p>
-            <a:pPr algn="ctr" indent="0" marL="0">
-              <a:buNone/>
-            </a:pPr>
-            <a:r>
-              <a:rPr lang="en-US" sz="1000" b="1" dirty="0">
-                <a:solidFill>
-                  <a:srgbClr val="FFFFFF"/>
-                </a:solidFill>
-                <a:latin typeface="Arial" pitchFamily="34" charset="0"/>
-                <a:ea typeface="Arial" pitchFamily="34" charset="-122"/>
-                <a:cs typeface="Arial" pitchFamily="34" charset="-120"/>
-              </a:rPr>
-              <a:t>Terraform</a:t>
-            </a:r>
-            <a:endParaRPr lang="en-US" sz="1000" dirty="0"/>
-          </a:p>
-          <a:p>
-            <a:pPr algn="ctr" indent="0" marL="0">
-              <a:buNone/>
-            </a:pPr>
-            <a:r>
-              <a:rPr lang="en-US" sz="1000" b="1" dirty="0">
-                <a:solidFill>
-                  <a:srgbClr val="FFFFFF"/>
-                </a:solidFill>
-                <a:latin typeface="Arial" pitchFamily="34" charset="0"/>
-                <a:ea typeface="Arial" pitchFamily="34" charset="-122"/>
-                <a:cs typeface="Arial" pitchFamily="34" charset="-120"/>
-              </a:rPr>
-              <a:t>main.tf</a:t>
-            </a:r>
-            <a:endParaRPr lang="en-US" sz="1000" dirty="0"/>
-          </a:p>
-        </p:txBody>
-      </p:sp>
-      <p:sp>
-        <p:nvSpPr>
-          <p:cNvPr id="15" name="Shape 13"/>
-          <p:cNvSpPr/>
-          <p:nvPr/>
-        </p:nvSpPr>
-        <p:spPr>
-          <a:xfrm>
-            <a:off x="2681935" y="3566160"/>
-            <a:ext cx="365760" cy="137160"/>
-          </a:xfrm>
-          <a:prstGeom prst="rect">
-            <a:avLst/>
-          </a:prstGeom>
-          <a:solidFill>
-            <a:srgbClr val="1565C0"/>
-          </a:solidFill>
-          <a:ln w="12700">
-            <a:solidFill>
-              <a:srgbClr val="1565C0"/>
-            </a:solidFill>
-            <a:prstDash val="solid"/>
-          </a:ln>
-        </p:spPr>
-      </p:sp>
-      <p:sp>
-        <p:nvSpPr>
-          <p:cNvPr id="16" name="Text 14"/>
-          <p:cNvSpPr/>
-          <p:nvPr/>
-        </p:nvSpPr>
-        <p:spPr>
-          <a:xfrm>
-            <a:off x="2681935" y="3291840"/>
-            <a:ext cx="365760" cy="617220"/>
-          </a:xfrm>
-          <a:prstGeom prst="rect">
-            <a:avLst/>
-          </a:prstGeom>
-          <a:noFill/>
-          <a:ln/>
-        </p:spPr>
-        <p:txBody>
-          <a:bodyPr wrap="square" rtlCol="0" anchor="ctr"/>
-          <a:lstStyle/>
-          <a:p>
-            <a:pPr algn="ctr" indent="0" marL="0">
-              <a:buNone/>
-            </a:pPr>
-            <a:r>
-              <a:rPr lang="en-US" sz="1800" dirty="0">
-                <a:solidFill>
-                  <a:srgbClr val="1565C0"/>
-                </a:solidFill>
-                <a:latin typeface="Arial" pitchFamily="34" charset="0"/>
-                <a:ea typeface="Arial" pitchFamily="34" charset="-122"/>
-                <a:cs typeface="Arial" pitchFamily="34" charset="-120"/>
-              </a:rPr>
-              <a:t>→</a:t>
-            </a:r>
-            <a:endParaRPr lang="en-US" sz="1800" dirty="0"/>
-          </a:p>
-        </p:txBody>
-      </p:sp>
-      <p:sp>
-        <p:nvSpPr>
-          <p:cNvPr id="17" name="Shape 15"/>
-          <p:cNvSpPr/>
-          <p:nvPr/>
-        </p:nvSpPr>
-        <p:spPr>
-          <a:xfrm>
-            <a:off x="3047695" y="1371600"/>
-            <a:ext cx="2681935" cy="4937760"/>
-          </a:xfrm>
-          <a:prstGeom prst="roundRect">
-            <a:avLst>
-              <a:gd name="adj" fmla="val 2728"/>
-            </a:avLst>
-          </a:prstGeom>
-          <a:solidFill>
-            <a:srgbClr val="1A237E"/>
-          </a:solidFill>
-          <a:ln w="12700">
-            <a:solidFill>
-              <a:srgbClr val="1A237E"/>
-            </a:solidFill>
-            <a:prstDash val="solid"/>
-          </a:ln>
-        </p:spPr>
-      </p:sp>
-      <p:sp>
-        <p:nvSpPr>
-          <p:cNvPr id="18" name="Text 16"/>
-          <p:cNvSpPr/>
-          <p:nvPr/>
-        </p:nvSpPr>
-        <p:spPr>
-          <a:xfrm>
-            <a:off x="3047695" y="1371600"/>
-            <a:ext cx="2681935" cy="960120"/>
-          </a:xfrm>
-          <a:prstGeom prst="rect">
-            <a:avLst/>
-          </a:prstGeom>
-          <a:noFill/>
-          <a:ln/>
-        </p:spPr>
-        <p:txBody>
-          <a:bodyPr wrap="square" rtlCol="0" anchor="ctr"/>
-          <a:lstStyle/>
-          <a:p>
-            <a:pPr algn="ctr" indent="0" marL="0">
-              <a:buNone/>
-            </a:pPr>
-            <a:r>
-              <a:rPr lang="en-US" sz="1000" b="1" dirty="0">
-                <a:solidFill>
-                  <a:srgbClr val="FFFFFF"/>
-                </a:solidFill>
-                <a:latin typeface="Arial" pitchFamily="34" charset="0"/>
-                <a:ea typeface="Arial" pitchFamily="34" charset="-122"/>
-                <a:cs typeface="Arial" pitchFamily="34" charset="-120"/>
-              </a:rPr>
-              <a:t>COUCHE 2</a:t>
-            </a:r>
-            <a:endParaRPr lang="en-US" sz="1000" dirty="0"/>
-          </a:p>
-          <a:p>
-            <a:pPr algn="ctr" indent="0" marL="0">
-              <a:buNone/>
-            </a:pPr>
-            <a:r>
-              <a:rPr lang="en-US" sz="1000" b="1" dirty="0">
-                <a:solidFill>
-                  <a:srgbClr val="FFFFFF"/>
-                </a:solidFill>
-                <a:latin typeface="Arial" pitchFamily="34" charset="0"/>
-                <a:ea typeface="Arial" pitchFamily="34" charset="-122"/>
-                <a:cs typeface="Arial" pitchFamily="34" charset="-120"/>
-              </a:rPr>
-              <a:t>VM Ubuntu 22.04</a:t>
-            </a:r>
-            <a:endParaRPr lang="en-US" sz="1000" dirty="0"/>
-          </a:p>
-          <a:p>
-            <a:pPr algn="ctr" indent="0" marL="0">
-              <a:buNone/>
-            </a:pPr>
-            <a:r>
-              <a:rPr lang="en-US" sz="1000" b="1" dirty="0">
-                <a:solidFill>
-                  <a:srgbClr val="FFFFFF"/>
-                </a:solidFill>
-                <a:latin typeface="Arial" pitchFamily="34" charset="0"/>
-                <a:ea typeface="Arial" pitchFamily="34" charset="-122"/>
-                <a:cs typeface="Arial" pitchFamily="34" charset="-120"/>
-              </a:rPr>
-              <a:t>192.168.56.10</a:t>
-            </a:r>
-            <a:endParaRPr lang="en-US" sz="1000" dirty="0"/>
-          </a:p>
-        </p:txBody>
-      </p:sp>
-      <p:sp>
-        <p:nvSpPr>
-          <p:cNvPr id="19" name="Shape 17"/>
-          <p:cNvSpPr/>
-          <p:nvPr/>
-        </p:nvSpPr>
-        <p:spPr>
-          <a:xfrm>
-            <a:off x="3169310" y="2400300"/>
-            <a:ext cx="2437790" cy="1028700"/>
-          </a:xfrm>
-          <a:prstGeom prst="roundRect">
-            <a:avLst>
-              <a:gd name="adj" fmla="val 5333"/>
-            </a:avLst>
-          </a:prstGeom>
-          <a:solidFill>
-            <a:srgbClr val="FFFFFF">
-              <a:alpha val="90000"/>
-            </a:srgbClr>
-          </a:solidFill>
-          <a:ln w="12700">
-            <a:solidFill>
-              <a:srgbClr val="FFFFFF">
-                <a:alpha val="70000"/>
-              </a:srgbClr>
-            </a:solidFill>
-            <a:prstDash val="solid"/>
-          </a:ln>
-        </p:spPr>
-      </p:sp>
-      <p:sp>
-        <p:nvSpPr>
-          <p:cNvPr id="20" name="Text 18"/>
-          <p:cNvSpPr/>
-          <p:nvPr/>
-        </p:nvSpPr>
-        <p:spPr>
-          <a:xfrm>
-            <a:off x="3169310" y="2400300"/>
-            <a:ext cx="2437790" cy="1028700"/>
-          </a:xfrm>
-          <a:prstGeom prst="rect">
-            <a:avLst/>
-          </a:prstGeom>
-          <a:noFill/>
-          <a:ln/>
-        </p:spPr>
-        <p:txBody>
-          <a:bodyPr wrap="square" rtlCol="0" anchor="ctr"/>
-          <a:lstStyle/>
-          <a:p>
-            <a:pPr algn="ctr" indent="0" marL="0">
-              <a:buNone/>
-            </a:pPr>
-            <a:r>
-              <a:rPr lang="en-US" sz="1000" b="1" dirty="0">
-                <a:solidFill>
-                  <a:srgbClr val="FFFFFF"/>
-                </a:solidFill>
-                <a:latin typeface="Arial" pitchFamily="34" charset="0"/>
-                <a:ea typeface="Arial" pitchFamily="34" charset="-122"/>
-                <a:cs typeface="Arial" pitchFamily="34" charset="-120"/>
-              </a:rPr>
-              <a:t>WordPress :80</a:t>
-            </a:r>
-            <a:endParaRPr lang="en-US" sz="1000" dirty="0"/>
-          </a:p>
-        </p:txBody>
-      </p:sp>
-      <p:sp>
-        <p:nvSpPr>
-          <p:cNvPr id="21" name="Shape 19"/>
-          <p:cNvSpPr/>
-          <p:nvPr/>
-        </p:nvSpPr>
-        <p:spPr>
-          <a:xfrm>
-            <a:off x="3169310" y="3634740"/>
-            <a:ext cx="2437790" cy="1028700"/>
-          </a:xfrm>
-          <a:prstGeom prst="roundRect">
-            <a:avLst>
-              <a:gd name="adj" fmla="val 5333"/>
-            </a:avLst>
-          </a:prstGeom>
-          <a:solidFill>
-            <a:srgbClr val="FFFFFF">
-              <a:alpha val="90000"/>
-            </a:srgbClr>
-          </a:solidFill>
-          <a:ln w="12700">
-            <a:solidFill>
-              <a:srgbClr val="FFFFFF">
-                <a:alpha val="70000"/>
-              </a:srgbClr>
-            </a:solidFill>
-            <a:prstDash val="solid"/>
-          </a:ln>
-        </p:spPr>
-      </p:sp>
-      <p:sp>
-        <p:nvSpPr>
-          <p:cNvPr id="22" name="Text 20"/>
-          <p:cNvSpPr/>
-          <p:nvPr/>
-        </p:nvSpPr>
-        <p:spPr>
-          <a:xfrm>
-            <a:off x="3169310" y="3634740"/>
-            <a:ext cx="2437790" cy="1028700"/>
-          </a:xfrm>
-          <a:prstGeom prst="rect">
-            <a:avLst/>
-          </a:prstGeom>
-          <a:noFill/>
-          <a:ln/>
-        </p:spPr>
-        <p:txBody>
-          <a:bodyPr wrap="square" rtlCol="0" anchor="ctr"/>
-          <a:lstStyle/>
-          <a:p>
-            <a:pPr algn="ctr" indent="0" marL="0">
-              <a:buNone/>
-            </a:pPr>
-            <a:r>
-              <a:rPr lang="en-US" sz="1000" b="1" dirty="0">
-                <a:solidFill>
-                  <a:srgbClr val="FFFFFF"/>
-                </a:solidFill>
-                <a:latin typeface="Arial" pitchFamily="34" charset="0"/>
-                <a:ea typeface="Arial" pitchFamily="34" charset="-122"/>
-                <a:cs typeface="Arial" pitchFamily="34" charset="-120"/>
-              </a:rPr>
-              <a:t>UFW + SSH</a:t>
-            </a:r>
-            <a:endParaRPr lang="en-US" sz="1000" dirty="0"/>
-          </a:p>
-          <a:p>
-            <a:pPr algn="ctr" indent="0" marL="0">
-              <a:buNone/>
-            </a:pPr>
-            <a:r>
-              <a:rPr lang="en-US" sz="1000" b="1" dirty="0">
-                <a:solidFill>
-                  <a:srgbClr val="FFFFFF"/>
-                </a:solidFill>
-                <a:latin typeface="Arial" pitchFamily="34" charset="0"/>
-                <a:ea typeface="Arial" pitchFamily="34" charset="-122"/>
-                <a:cs typeface="Arial" pitchFamily="34" charset="-120"/>
-              </a:rPr>
-              <a:t>hardening</a:t>
-            </a:r>
-            <a:endParaRPr lang="en-US" sz="1000" dirty="0"/>
-          </a:p>
-        </p:txBody>
-      </p:sp>
-      <p:sp>
-        <p:nvSpPr>
-          <p:cNvPr id="23" name="Shape 21"/>
-          <p:cNvSpPr/>
-          <p:nvPr/>
-        </p:nvSpPr>
-        <p:spPr>
-          <a:xfrm>
-            <a:off x="3169310" y="4869180"/>
-            <a:ext cx="2437790" cy="1028700"/>
-          </a:xfrm>
-          <a:prstGeom prst="roundRect">
-            <a:avLst>
-              <a:gd name="adj" fmla="val 5333"/>
-            </a:avLst>
-          </a:prstGeom>
-          <a:solidFill>
-            <a:srgbClr val="FFFFFF">
-              <a:alpha val="90000"/>
-            </a:srgbClr>
-          </a:solidFill>
-          <a:ln w="12700">
-            <a:solidFill>
-              <a:srgbClr val="FFFFFF">
-                <a:alpha val="70000"/>
-              </a:srgbClr>
-            </a:solidFill>
-            <a:prstDash val="solid"/>
-          </a:ln>
-        </p:spPr>
-      </p:sp>
-      <p:sp>
-        <p:nvSpPr>
-          <p:cNvPr id="24" name="Text 22"/>
-          <p:cNvSpPr/>
-          <p:nvPr/>
-        </p:nvSpPr>
-        <p:spPr>
-          <a:xfrm>
-            <a:off x="3169310" y="4869180"/>
-            <a:ext cx="2437790" cy="1028700"/>
-          </a:xfrm>
-          <a:prstGeom prst="rect">
-            <a:avLst/>
-          </a:prstGeom>
-          <a:noFill/>
-          <a:ln/>
-        </p:spPr>
-        <p:txBody>
-          <a:bodyPr wrap="square" rtlCol="0" anchor="ctr"/>
-          <a:lstStyle/>
-          <a:p>
-            <a:pPr algn="ctr" indent="0" marL="0">
-              <a:buNone/>
-            </a:pPr>
-            <a:r>
-              <a:rPr lang="en-US" sz="1000" b="1" dirty="0">
-                <a:solidFill>
-                  <a:srgbClr val="FFFFFF"/>
-                </a:solidFill>
-                <a:latin typeface="Arial" pitchFamily="34" charset="0"/>
-                <a:ea typeface="Arial" pitchFamily="34" charset="-122"/>
-                <a:cs typeface="Arial" pitchFamily="34" charset="-120"/>
-              </a:rPr>
-              <a:t>Docker</a:t>
-            </a:r>
-            <a:endParaRPr lang="en-US" sz="1000" dirty="0"/>
-          </a:p>
-          <a:p>
-            <a:pPr algn="ctr" indent="0" marL="0">
-              <a:buNone/>
-            </a:pPr>
-            <a:r>
-              <a:rPr lang="en-US" sz="1000" b="1" dirty="0">
-                <a:solidFill>
-                  <a:srgbClr val="FFFFFF"/>
-                </a:solidFill>
-                <a:latin typeface="Arial" pitchFamily="34" charset="0"/>
-                <a:ea typeface="Arial" pitchFamily="34" charset="-122"/>
-                <a:cs typeface="Arial" pitchFamily="34" charset="-120"/>
-              </a:rPr>
-              <a:t>Monitoring</a:t>
-            </a:r>
-            <a:endParaRPr lang="en-US" sz="1000" dirty="0"/>
-          </a:p>
-        </p:txBody>
-      </p:sp>
-      <p:sp>
-        <p:nvSpPr>
-          <p:cNvPr id="25" name="Text 23"/>
-          <p:cNvSpPr/>
-          <p:nvPr/>
-        </p:nvSpPr>
-        <p:spPr>
-          <a:xfrm>
-            <a:off x="5728716" y="3291840"/>
-            <a:ext cx="487375" cy="617220"/>
-          </a:xfrm>
-          <a:prstGeom prst="rect">
-            <a:avLst/>
-          </a:prstGeom>
-          <a:noFill/>
-          <a:ln/>
-        </p:spPr>
-        <p:txBody>
-          <a:bodyPr wrap="square" rtlCol="0" anchor="ctr"/>
-          <a:lstStyle/>
-          <a:p>
-            <a:pPr algn="ctr" indent="0" marL="0">
-              <a:buNone/>
-            </a:pPr>
-            <a:r>
-              <a:rPr lang="en-US" sz="1800" dirty="0">
-                <a:solidFill>
-                  <a:srgbClr val="4A148C"/>
-                </a:solidFill>
-                <a:latin typeface="Arial" pitchFamily="34" charset="0"/>
-                <a:ea typeface="Arial" pitchFamily="34" charset="-122"/>
-                <a:cs typeface="Arial" pitchFamily="34" charset="-120"/>
-              </a:rPr>
-              <a:t>→</a:t>
-            </a:r>
-            <a:endParaRPr lang="en-US" sz="1800" dirty="0"/>
-          </a:p>
-        </p:txBody>
-      </p:sp>
-      <p:sp>
-        <p:nvSpPr>
-          <p:cNvPr id="26" name="Shape 24"/>
-          <p:cNvSpPr/>
-          <p:nvPr/>
-        </p:nvSpPr>
-        <p:spPr>
-          <a:xfrm>
-            <a:off x="6216091" y="1371600"/>
-            <a:ext cx="2681935" cy="4937760"/>
-          </a:xfrm>
-          <a:prstGeom prst="roundRect">
-            <a:avLst>
-              <a:gd name="adj" fmla="val 2728"/>
-            </a:avLst>
-          </a:prstGeom>
-          <a:solidFill>
-            <a:srgbClr val="4A148C"/>
-          </a:solidFill>
-          <a:ln w="12700">
-            <a:solidFill>
-              <a:srgbClr val="4A148C"/>
-            </a:solidFill>
-            <a:prstDash val="solid"/>
-          </a:ln>
-        </p:spPr>
-      </p:sp>
-      <p:sp>
-        <p:nvSpPr>
-          <p:cNvPr id="27" name="Text 25"/>
-          <p:cNvSpPr/>
-          <p:nvPr/>
-        </p:nvSpPr>
-        <p:spPr>
-          <a:xfrm>
-            <a:off x="6216091" y="1371600"/>
-            <a:ext cx="2681935" cy="685800"/>
-          </a:xfrm>
-          <a:prstGeom prst="rect">
-            <a:avLst/>
-          </a:prstGeom>
-          <a:noFill/>
-          <a:ln/>
-        </p:spPr>
-        <p:txBody>
-          <a:bodyPr wrap="square" rtlCol="0" anchor="ctr"/>
-          <a:lstStyle/>
-          <a:p>
-            <a:pPr algn="ctr" indent="0" marL="0">
-              <a:buNone/>
-            </a:pPr>
-            <a:r>
-              <a:rPr lang="en-US" sz="1100" b="1" dirty="0">
-                <a:solidFill>
-                  <a:srgbClr val="FFFFFF"/>
-                </a:solidFill>
-                <a:latin typeface="Arial" pitchFamily="34" charset="0"/>
-                <a:ea typeface="Arial" pitchFamily="34" charset="-122"/>
-                <a:cs typeface="Arial" pitchFamily="34" charset="-120"/>
-              </a:rPr>
-              <a:t>COUCHE 3</a:t>
-            </a:r>
-            <a:endParaRPr lang="en-US" sz="1100" dirty="0"/>
-          </a:p>
-          <a:p>
-            <a:pPr algn="ctr" indent="0" marL="0">
-              <a:buNone/>
-            </a:pPr>
-            <a:r>
-              <a:rPr lang="en-US" sz="1100" b="1" dirty="0">
-                <a:solidFill>
-                  <a:srgbClr val="FFFFFF"/>
-                </a:solidFill>
-                <a:latin typeface="Arial" pitchFamily="34" charset="0"/>
-                <a:ea typeface="Arial" pitchFamily="34" charset="-122"/>
-                <a:cs typeface="Arial" pitchFamily="34" charset="-120"/>
-              </a:rPr>
-              <a:t>Kubernetes</a:t>
-            </a:r>
-            <a:endParaRPr lang="en-US" sz="1100" dirty="0"/>
-          </a:p>
-        </p:txBody>
-      </p:sp>
-      <p:sp>
-        <p:nvSpPr>
-          <p:cNvPr id="28" name="Shape 26"/>
-          <p:cNvSpPr/>
-          <p:nvPr/>
-        </p:nvSpPr>
-        <p:spPr>
-          <a:xfrm>
-            <a:off x="6338621" y="2194560"/>
-            <a:ext cx="2437790" cy="1097280"/>
-          </a:xfrm>
-          <a:prstGeom prst="roundRect">
-            <a:avLst>
-              <a:gd name="adj" fmla="val 5000"/>
-            </a:avLst>
-          </a:prstGeom>
-          <a:solidFill>
-            <a:srgbClr val="FFFFFF">
-              <a:alpha val="88000"/>
-            </a:srgbClr>
-          </a:solidFill>
-          <a:ln w="12700">
-            <a:solidFill>
-              <a:srgbClr val="FFFFFF">
-                <a:alpha val="70000"/>
-              </a:srgbClr>
-            </a:solidFill>
-            <a:prstDash val="solid"/>
-          </a:ln>
-        </p:spPr>
-      </p:sp>
-      <p:sp>
-        <p:nvSpPr>
-          <p:cNvPr id="29" name="Text 27"/>
-          <p:cNvSpPr/>
-          <p:nvPr/>
-        </p:nvSpPr>
-        <p:spPr>
-          <a:xfrm>
-            <a:off x="6338621" y="2194560"/>
-            <a:ext cx="2437790" cy="1097280"/>
-          </a:xfrm>
-          <a:prstGeom prst="rect">
-            <a:avLst/>
-          </a:prstGeom>
-          <a:noFill/>
-          <a:ln/>
-        </p:spPr>
-        <p:txBody>
-          <a:bodyPr wrap="square" rtlCol="0" anchor="ctr"/>
-          <a:lstStyle/>
-          <a:p>
-            <a:pPr algn="ctr" indent="0" marL="0">
-              <a:buNone/>
-            </a:pPr>
-            <a:r>
-              <a:rPr lang="en-US" sz="1000" b="1" dirty="0">
-                <a:solidFill>
-                  <a:srgbClr val="FFFFFF"/>
-                </a:solidFill>
-                <a:latin typeface="Arial" pitchFamily="34" charset="0"/>
-                <a:ea typeface="Arial" pitchFamily="34" charset="-122"/>
-                <a:cs typeface="Arial" pitchFamily="34" charset="-120"/>
-              </a:rPr>
-              <a:t>WordPress</a:t>
-            </a:r>
-            <a:endParaRPr lang="en-US" sz="1000" dirty="0"/>
-          </a:p>
-          <a:p>
-            <a:pPr algn="ctr" indent="0" marL="0">
-              <a:buNone/>
-            </a:pPr>
-            <a:r>
-              <a:rPr lang="en-US" sz="1000" b="1" dirty="0">
-                <a:solidFill>
-                  <a:srgbClr val="FFFFFF"/>
-                </a:solidFill>
-                <a:latin typeface="Arial" pitchFamily="34" charset="0"/>
-                <a:ea typeface="Arial" pitchFamily="34" charset="-122"/>
-                <a:cs typeface="Arial" pitchFamily="34" charset="-120"/>
-              </a:rPr>
-              <a:t>Deployment</a:t>
-            </a:r>
-            <a:endParaRPr lang="en-US" sz="1000" dirty="0"/>
-          </a:p>
-        </p:txBody>
-      </p:sp>
-      <p:sp>
-        <p:nvSpPr>
-          <p:cNvPr id="30" name="Shape 28"/>
-          <p:cNvSpPr/>
-          <p:nvPr/>
-        </p:nvSpPr>
-        <p:spPr>
-          <a:xfrm>
-            <a:off x="6338621" y="3497580"/>
-            <a:ext cx="2437790" cy="1097280"/>
-          </a:xfrm>
-          <a:prstGeom prst="roundRect">
-            <a:avLst>
-              <a:gd name="adj" fmla="val 5000"/>
-            </a:avLst>
-          </a:prstGeom>
-          <a:solidFill>
-            <a:srgbClr val="FFFFFF">
-              <a:alpha val="88000"/>
-            </a:srgbClr>
-          </a:solidFill>
-          <a:ln w="12700">
-            <a:solidFill>
-              <a:srgbClr val="FFFFFF">
-                <a:alpha val="70000"/>
-              </a:srgbClr>
-            </a:solidFill>
-            <a:prstDash val="solid"/>
-          </a:ln>
-        </p:spPr>
-      </p:sp>
-      <p:sp>
-        <p:nvSpPr>
-          <p:cNvPr id="31" name="Text 29"/>
-          <p:cNvSpPr/>
-          <p:nvPr/>
-        </p:nvSpPr>
-        <p:spPr>
-          <a:xfrm>
-            <a:off x="6338621" y="3497580"/>
-            <a:ext cx="2437790" cy="1097280"/>
-          </a:xfrm>
-          <a:prstGeom prst="rect">
-            <a:avLst/>
-          </a:prstGeom>
-          <a:noFill/>
-          <a:ln/>
-        </p:spPr>
-        <p:txBody>
-          <a:bodyPr wrap="square" rtlCol="0" anchor="ctr"/>
-          <a:lstStyle/>
-          <a:p>
-            <a:pPr algn="ctr" indent="0" marL="0">
-              <a:buNone/>
-            </a:pPr>
-            <a:r>
-              <a:rPr lang="en-US" sz="1000" b="1" dirty="0">
-                <a:solidFill>
-                  <a:srgbClr val="FFFFFF"/>
-                </a:solidFill>
-                <a:latin typeface="Arial" pitchFamily="34" charset="0"/>
-                <a:ea typeface="Arial" pitchFamily="34" charset="-122"/>
-                <a:cs typeface="Arial" pitchFamily="34" charset="-120"/>
-              </a:rPr>
-              <a:t>MariaDB</a:t>
-            </a:r>
-            <a:endParaRPr lang="en-US" sz="1000" dirty="0"/>
-          </a:p>
-          <a:p>
-            <a:pPr algn="ctr" indent="0" marL="0">
-              <a:buNone/>
-            </a:pPr>
-            <a:r>
-              <a:rPr lang="en-US" sz="1000" b="1" dirty="0">
-                <a:solidFill>
-                  <a:srgbClr val="FFFFFF"/>
-                </a:solidFill>
-                <a:latin typeface="Arial" pitchFamily="34" charset="0"/>
-                <a:ea typeface="Arial" pitchFamily="34" charset="-122"/>
-                <a:cs typeface="Arial" pitchFamily="34" charset="-120"/>
-              </a:rPr>
-              <a:t>+ PVC + Secret</a:t>
-            </a:r>
-            <a:endParaRPr lang="en-US" sz="1000" dirty="0"/>
-          </a:p>
-        </p:txBody>
-      </p:sp>
-      <p:sp>
-        <p:nvSpPr>
-          <p:cNvPr id="32" name="Shape 30"/>
-          <p:cNvSpPr/>
-          <p:nvPr/>
-        </p:nvSpPr>
-        <p:spPr>
-          <a:xfrm>
-            <a:off x="6338621" y="4800600"/>
-            <a:ext cx="2437790" cy="1097280"/>
-          </a:xfrm>
-          <a:prstGeom prst="roundRect">
-            <a:avLst>
-              <a:gd name="adj" fmla="val 5000"/>
-            </a:avLst>
-          </a:prstGeom>
-          <a:solidFill>
-            <a:srgbClr val="FFFFFF">
-              <a:alpha val="88000"/>
-            </a:srgbClr>
-          </a:solidFill>
-          <a:ln w="12700">
-            <a:solidFill>
-              <a:srgbClr val="FFFFFF">
-                <a:alpha val="70000"/>
-              </a:srgbClr>
-            </a:solidFill>
-            <a:prstDash val="solid"/>
-          </a:ln>
-        </p:spPr>
-      </p:sp>
-      <p:sp>
-        <p:nvSpPr>
-          <p:cNvPr id="33" name="Text 31"/>
-          <p:cNvSpPr/>
-          <p:nvPr/>
-        </p:nvSpPr>
-        <p:spPr>
-          <a:xfrm>
-            <a:off x="6338621" y="4800600"/>
-            <a:ext cx="2437790" cy="1097280"/>
-          </a:xfrm>
-          <a:prstGeom prst="rect">
-            <a:avLst/>
-          </a:prstGeom>
-          <a:noFill/>
-          <a:ln/>
-        </p:spPr>
-        <p:txBody>
-          <a:bodyPr wrap="square" rtlCol="0" anchor="ctr"/>
-          <a:lstStyle/>
-          <a:p>
-            <a:pPr algn="ctr" indent="0" marL="0">
-              <a:buNone/>
-            </a:pPr>
-            <a:r>
-              <a:rPr lang="en-US" sz="1000" b="1" dirty="0">
-                <a:solidFill>
-                  <a:srgbClr val="FFFFFF"/>
-                </a:solidFill>
-                <a:latin typeface="Arial" pitchFamily="34" charset="0"/>
-                <a:ea typeface="Arial" pitchFamily="34" charset="-122"/>
-                <a:cs typeface="Arial" pitchFamily="34" charset="-120"/>
-              </a:rPr>
-              <a:t>HPA</a:t>
-            </a:r>
-            <a:endParaRPr lang="en-US" sz="1000" dirty="0"/>
-          </a:p>
-          <a:p>
-            <a:pPr algn="ctr" indent="0" marL="0">
-              <a:buNone/>
-            </a:pPr>
-            <a:r>
-              <a:rPr lang="en-US" sz="1000" b="1" dirty="0">
-                <a:solidFill>
-                  <a:srgbClr val="FFFFFF"/>
-                </a:solidFill>
-                <a:latin typeface="Arial" pitchFamily="34" charset="0"/>
-                <a:ea typeface="Arial" pitchFamily="34" charset="-122"/>
-                <a:cs typeface="Arial" pitchFamily="34" charset="-120"/>
-              </a:rPr>
-              <a:t>2-10 réplicas</a:t>
-            </a:r>
-            <a:endParaRPr lang="en-US" sz="1000" dirty="0"/>
-          </a:p>
-        </p:txBody>
-      </p:sp>
-      <p:sp>
-        <p:nvSpPr>
-          <p:cNvPr id="34" name="Text 32"/>
-          <p:cNvSpPr/>
-          <p:nvPr/>
-        </p:nvSpPr>
-        <p:spPr>
-          <a:xfrm>
-            <a:off x="8898026" y="3291840"/>
-            <a:ext cx="487375" cy="617220"/>
-          </a:xfrm>
-          <a:prstGeom prst="rect">
-            <a:avLst/>
-          </a:prstGeom>
-          <a:noFill/>
-          <a:ln/>
-        </p:spPr>
-        <p:txBody>
-          <a:bodyPr wrap="square" rtlCol="0" anchor="ctr"/>
-          <a:lstStyle/>
-          <a:p>
-            <a:pPr algn="ctr" indent="0" marL="0">
-              <a:buNone/>
-            </a:pPr>
-            <a:r>
-              <a:rPr lang="en-US" sz="1800" dirty="0">
-                <a:solidFill>
-                  <a:srgbClr val="E65100"/>
-                </a:solidFill>
-                <a:latin typeface="Arial" pitchFamily="34" charset="0"/>
-                <a:ea typeface="Arial" pitchFamily="34" charset="-122"/>
-                <a:cs typeface="Arial" pitchFamily="34" charset="-120"/>
-              </a:rPr>
-              <a:t>→</a:t>
-            </a:r>
-            <a:endParaRPr lang="en-US" sz="1800" dirty="0"/>
-          </a:p>
-        </p:txBody>
-      </p:sp>
-      <p:sp>
-        <p:nvSpPr>
-          <p:cNvPr id="35" name="Shape 33"/>
-          <p:cNvSpPr/>
-          <p:nvPr/>
-        </p:nvSpPr>
-        <p:spPr>
-          <a:xfrm>
-            <a:off x="9385402" y="1371600"/>
-            <a:ext cx="2559406" cy="4937760"/>
-          </a:xfrm>
-          <a:prstGeom prst="roundRect">
-            <a:avLst>
-              <a:gd name="adj" fmla="val 2858"/>
-            </a:avLst>
-          </a:prstGeom>
-          <a:solidFill>
-            <a:srgbClr val="E65100"/>
-          </a:solidFill>
-          <a:ln w="12700">
-            <a:solidFill>
-              <a:srgbClr val="E65100"/>
-            </a:solidFill>
-            <a:prstDash val="solid"/>
-          </a:ln>
-        </p:spPr>
-      </p:sp>
-      <p:sp>
-        <p:nvSpPr>
-          <p:cNvPr id="36" name="Text 34"/>
-          <p:cNvSpPr/>
-          <p:nvPr/>
-        </p:nvSpPr>
-        <p:spPr>
-          <a:xfrm>
-            <a:off x="9385402" y="1371600"/>
-            <a:ext cx="2559406" cy="685800"/>
-          </a:xfrm>
-          <a:prstGeom prst="rect">
-            <a:avLst/>
-          </a:prstGeom>
-          <a:noFill/>
-          <a:ln/>
-        </p:spPr>
-        <p:txBody>
-          <a:bodyPr wrap="square" rtlCol="0" anchor="ctr"/>
-          <a:lstStyle/>
-          <a:p>
-            <a:pPr algn="ctr" indent="0" marL="0">
-              <a:buNone/>
-            </a:pPr>
-            <a:r>
-              <a:rPr lang="en-US" sz="1100" b="1" dirty="0">
-                <a:solidFill>
-                  <a:srgbClr val="FFFFFF"/>
-                </a:solidFill>
-                <a:latin typeface="Arial" pitchFamily="34" charset="0"/>
-                <a:ea typeface="Arial" pitchFamily="34" charset="-122"/>
-                <a:cs typeface="Arial" pitchFamily="34" charset="-120"/>
-              </a:rPr>
-              <a:t>COUCHE 4</a:t>
-            </a:r>
-            <a:endParaRPr lang="en-US" sz="1100" dirty="0"/>
-          </a:p>
-          <a:p>
-            <a:pPr algn="ctr" indent="0" marL="0">
-              <a:buNone/>
-            </a:pPr>
-            <a:r>
-              <a:rPr lang="en-US" sz="1100" b="1" dirty="0">
-                <a:solidFill>
-                  <a:srgbClr val="FFFFFF"/>
-                </a:solidFill>
-                <a:latin typeface="Arial" pitchFamily="34" charset="0"/>
-                <a:ea typeface="Arial" pitchFamily="34" charset="-122"/>
-                <a:cs typeface="Arial" pitchFamily="34" charset="-120"/>
-              </a:rPr>
-              <a:t>Supervision</a:t>
-            </a:r>
-            <a:endParaRPr lang="en-US" sz="1100" dirty="0"/>
-          </a:p>
-        </p:txBody>
-      </p:sp>
-      <p:sp>
-        <p:nvSpPr>
-          <p:cNvPr id="37" name="Shape 35"/>
-          <p:cNvSpPr/>
-          <p:nvPr/>
-        </p:nvSpPr>
-        <p:spPr>
-          <a:xfrm>
-            <a:off x="9507017" y="2194560"/>
-            <a:ext cx="2316175" cy="1097280"/>
-          </a:xfrm>
-          <a:prstGeom prst="roundRect">
-            <a:avLst>
-              <a:gd name="adj" fmla="val 5000"/>
-            </a:avLst>
-          </a:prstGeom>
-          <a:solidFill>
-            <a:srgbClr val="FFFFFF">
-              <a:alpha val="88000"/>
-            </a:srgbClr>
-          </a:solidFill>
-          <a:ln w="12700">
-            <a:solidFill>
-              <a:srgbClr val="FFFFFF">
-                <a:alpha val="70000"/>
-              </a:srgbClr>
-            </a:solidFill>
-            <a:prstDash val="solid"/>
-          </a:ln>
-        </p:spPr>
-      </p:sp>
-      <p:sp>
-        <p:nvSpPr>
-          <p:cNvPr id="38" name="Text 36"/>
-          <p:cNvSpPr/>
-          <p:nvPr/>
-        </p:nvSpPr>
-        <p:spPr>
-          <a:xfrm>
-            <a:off x="9507017" y="2194560"/>
-            <a:ext cx="2316175" cy="1097280"/>
-          </a:xfrm>
-          <a:prstGeom prst="rect">
-            <a:avLst/>
-          </a:prstGeom>
-          <a:noFill/>
-          <a:ln/>
-        </p:spPr>
-        <p:txBody>
-          <a:bodyPr wrap="square" rtlCol="0" anchor="ctr"/>
-          <a:lstStyle/>
-          <a:p>
-            <a:pPr algn="ctr" indent="0" marL="0">
-              <a:buNone/>
-            </a:pPr>
-            <a:r>
-              <a:rPr lang="en-US" sz="1000" b="1" dirty="0">
-                <a:solidFill>
-                  <a:srgbClr val="FFFFFF"/>
-                </a:solidFill>
-                <a:latin typeface="Arial" pitchFamily="34" charset="0"/>
-                <a:ea typeface="Arial" pitchFamily="34" charset="-122"/>
-                <a:cs typeface="Arial" pitchFamily="34" charset="-120"/>
-              </a:rPr>
-              <a:t>Prometheus</a:t>
-            </a:r>
-            <a:endParaRPr lang="en-US" sz="1000" dirty="0"/>
-          </a:p>
-          <a:p>
-            <a:pPr algn="ctr" indent="0" marL="0">
-              <a:buNone/>
-            </a:pPr>
-            <a:r>
-              <a:rPr lang="en-US" sz="1000" b="1" dirty="0">
-                <a:solidFill>
-                  <a:srgbClr val="FFFFFF"/>
-                </a:solidFill>
-                <a:latin typeface="Arial" pitchFamily="34" charset="0"/>
-                <a:ea typeface="Arial" pitchFamily="34" charset="-122"/>
-                <a:cs typeface="Arial" pitchFamily="34" charset="-120"/>
-              </a:rPr>
-              <a:t>:9090</a:t>
-            </a:r>
-            <a:endParaRPr lang="en-US" sz="1000" dirty="0"/>
-          </a:p>
-        </p:txBody>
-      </p:sp>
-      <p:sp>
-        <p:nvSpPr>
-          <p:cNvPr id="39" name="Shape 37"/>
-          <p:cNvSpPr/>
-          <p:nvPr/>
-        </p:nvSpPr>
-        <p:spPr>
-          <a:xfrm>
-            <a:off x="9507017" y="3497580"/>
-            <a:ext cx="2316175" cy="1097280"/>
-          </a:xfrm>
-          <a:prstGeom prst="roundRect">
-            <a:avLst>
-              <a:gd name="adj" fmla="val 5000"/>
-            </a:avLst>
-          </a:prstGeom>
-          <a:solidFill>
-            <a:srgbClr val="FFFFFF">
-              <a:alpha val="88000"/>
-            </a:srgbClr>
-          </a:solidFill>
-          <a:ln w="12700">
-            <a:solidFill>
-              <a:srgbClr val="FFFFFF">
-                <a:alpha val="70000"/>
-              </a:srgbClr>
-            </a:solidFill>
-            <a:prstDash val="solid"/>
-          </a:ln>
-        </p:spPr>
-      </p:sp>
-      <p:sp>
-        <p:nvSpPr>
-          <p:cNvPr id="40" name="Text 38"/>
-          <p:cNvSpPr/>
-          <p:nvPr/>
-        </p:nvSpPr>
-        <p:spPr>
-          <a:xfrm>
-            <a:off x="9507017" y="3497580"/>
-            <a:ext cx="2316175" cy="1097280"/>
-          </a:xfrm>
-          <a:prstGeom prst="rect">
-            <a:avLst/>
-          </a:prstGeom>
-          <a:noFill/>
-          <a:ln/>
-        </p:spPr>
-        <p:txBody>
-          <a:bodyPr wrap="square" rtlCol="0" anchor="ctr"/>
-          <a:lstStyle/>
-          <a:p>
-            <a:pPr algn="ctr" indent="0" marL="0">
-              <a:buNone/>
-            </a:pPr>
-            <a:r>
-              <a:rPr lang="en-US" sz="1000" b="1" dirty="0">
-                <a:solidFill>
-                  <a:srgbClr val="FFFFFF"/>
-                </a:solidFill>
-                <a:latin typeface="Arial" pitchFamily="34" charset="0"/>
-                <a:ea typeface="Arial" pitchFamily="34" charset="-122"/>
-                <a:cs typeface="Arial" pitchFamily="34" charset="-120"/>
-              </a:rPr>
-              <a:t>Grafana</a:t>
-            </a:r>
-            <a:endParaRPr lang="en-US" sz="1000" dirty="0"/>
-          </a:p>
-          <a:p>
-            <a:pPr algn="ctr" indent="0" marL="0">
-              <a:buNone/>
-            </a:pPr>
-            <a:r>
-              <a:rPr lang="en-US" sz="1000" b="1" dirty="0">
-                <a:solidFill>
-                  <a:srgbClr val="FFFFFF"/>
-                </a:solidFill>
-                <a:latin typeface="Arial" pitchFamily="34" charset="0"/>
-                <a:ea typeface="Arial" pitchFamily="34" charset="-122"/>
-                <a:cs typeface="Arial" pitchFamily="34" charset="-120"/>
-              </a:rPr>
-              <a:t>:3000</a:t>
-            </a:r>
-            <a:endParaRPr lang="en-US" sz="1000" dirty="0"/>
-          </a:p>
-        </p:txBody>
-      </p:sp>
-      <p:sp>
-        <p:nvSpPr>
-          <p:cNvPr id="41" name="Shape 39"/>
-          <p:cNvSpPr/>
-          <p:nvPr/>
-        </p:nvSpPr>
-        <p:spPr>
-          <a:xfrm>
-            <a:off x="9507017" y="4800600"/>
-            <a:ext cx="2316175" cy="1097280"/>
-          </a:xfrm>
-          <a:prstGeom prst="roundRect">
-            <a:avLst>
-              <a:gd name="adj" fmla="val 5000"/>
-            </a:avLst>
-          </a:prstGeom>
-          <a:solidFill>
-            <a:srgbClr val="FFFFFF">
-              <a:alpha val="88000"/>
-            </a:srgbClr>
-          </a:solidFill>
-          <a:ln w="12700">
-            <a:solidFill>
-              <a:srgbClr val="FFFFFF">
-                <a:alpha val="70000"/>
-              </a:srgbClr>
-            </a:solidFill>
-            <a:prstDash val="solid"/>
-          </a:ln>
-        </p:spPr>
-      </p:sp>
-      <p:sp>
-        <p:nvSpPr>
-          <p:cNvPr id="42" name="Text 40"/>
-          <p:cNvSpPr/>
-          <p:nvPr/>
-        </p:nvSpPr>
-        <p:spPr>
-          <a:xfrm>
-            <a:off x="9507017" y="4800600"/>
-            <a:ext cx="2316175" cy="1097280"/>
-          </a:xfrm>
-          <a:prstGeom prst="rect">
-            <a:avLst/>
-          </a:prstGeom>
-          <a:noFill/>
-          <a:ln/>
-        </p:spPr>
-        <p:txBody>
-          <a:bodyPr wrap="square" rtlCol="0" anchor="ctr"/>
-          <a:lstStyle/>
-          <a:p>
-            <a:pPr algn="ctr" indent="0" marL="0">
-              <a:buNone/>
-            </a:pPr>
-            <a:r>
-              <a:rPr lang="en-US" sz="1000" b="1" dirty="0">
-                <a:solidFill>
-                  <a:srgbClr val="FFFFFF"/>
-                </a:solidFill>
-                <a:latin typeface="Arial" pitchFamily="34" charset="0"/>
-                <a:ea typeface="Arial" pitchFamily="34" charset="-122"/>
-                <a:cs typeface="Arial" pitchFamily="34" charset="-120"/>
-              </a:rPr>
-              <a:t>Alertmanager</a:t>
-            </a:r>
-            <a:endParaRPr lang="en-US" sz="1000" dirty="0"/>
-          </a:p>
-          <a:p>
-            <a:pPr algn="ctr" indent="0" marL="0">
-              <a:buNone/>
-            </a:pPr>
-            <a:r>
-              <a:rPr lang="en-US" sz="1000" b="1" dirty="0">
-                <a:solidFill>
-                  <a:srgbClr val="FFFFFF"/>
-                </a:solidFill>
-                <a:latin typeface="Arial" pitchFamily="34" charset="0"/>
-                <a:ea typeface="Arial" pitchFamily="34" charset="-122"/>
-                <a:cs typeface="Arial" pitchFamily="34" charset="-120"/>
-              </a:rPr>
-              <a:t>→ Discord</a:t>
-            </a:r>
-            <a:endParaRPr lang="en-US" sz="1000" dirty="0"/>
-          </a:p>
-        </p:txBody>
-      </p:sp>
-      <p:sp>
-        <p:nvSpPr>
-          <p:cNvPr id="43" name="Shape 41"/>
-          <p:cNvSpPr/>
-          <p:nvPr/>
-        </p:nvSpPr>
-        <p:spPr>
-          <a:xfrm>
-            <a:off x="244145" y="6377940"/>
-            <a:ext cx="11701577" cy="342900"/>
-          </a:xfrm>
-          <a:prstGeom prst="rect">
-            <a:avLst/>
-          </a:prstGeom>
-          <a:solidFill>
-            <a:srgbClr val="455A64"/>
-          </a:solidFill>
-          <a:ln w="12700">
-            <a:solidFill>
-              <a:srgbClr val="455A64"/>
-            </a:solidFill>
-            <a:prstDash val="solid"/>
-          </a:ln>
-        </p:spPr>
-      </p:sp>
-      <p:sp>
-        <p:nvSpPr>
-          <p:cNvPr id="44" name="Text 42"/>
-          <p:cNvSpPr/>
-          <p:nvPr/>
-        </p:nvSpPr>
-        <p:spPr>
-          <a:xfrm>
-            <a:off x="365760" y="6377940"/>
-            <a:ext cx="11457432" cy="342900"/>
-          </a:xfrm>
-          <a:prstGeom prst="rect">
-            <a:avLst/>
-          </a:prstGeom>
-          <a:noFill/>
-          <a:ln/>
-        </p:spPr>
-        <p:txBody>
-          <a:bodyPr wrap="square" rtlCol="0" anchor="ctr"/>
-          <a:lstStyle/>
-          <a:p>
-            <a:pPr algn="ctr" indent="0" marL="0">
-              <a:buNone/>
-            </a:pPr>
-            <a:r>
-              <a:rPr lang="en-US" sz="1000" dirty="0">
-                <a:solidFill>
-                  <a:srgbClr val="FFFFFF"/>
-                </a:solidFill>
-                <a:latin typeface="Arial" pitchFamily="34" charset="0"/>
-                <a:ea typeface="Arial" pitchFamily="34" charset="-122"/>
-                <a:cs typeface="Arial" pitchFamily="34" charset="-120"/>
-              </a:rPr>
-              <a:t>CI/CD GitHub Actions  ·  Lint  →  Build + Push DockerHub  →  Validate K8s  (déclenché à chaque git push)</a:t>
-            </a:r>
-            <a:endParaRPr lang="en-US" sz="1000" dirty="0"/>
-          </a:p>
-        </p:txBody>
-      </p:sp>
+          </a:p>
+        </p:txBody>
+      </p:sp>
+      <p:pic>
+        <p:nvPicPr>
+          <p:cNvPr id="50" name="Architecture iac-infra"/>
+          <p:cNvPicPr>
+            <a:picLocks noChangeAspect="1"/>
+          </p:cNvPicPr>
+          <p:nvPr/>
+        </p:nvPicPr>
+        <p:blipFill>
+          <a:blip r:embed="rId3"/>
+          <a:stretch>
+            <a:fillRect/>
+          </a:stretch>
+        </p:blipFill>
+        <p:spPr>
+          <a:xfrm>
+            <a:off x="2121000" y="1480000"/>
+            <a:ext cx="7950000" cy="5300000"/>
+          </a:xfrm>
+          <a:prstGeom prst="rect">
+            <a:avLst/>
+          </a:prstGeom>
+        </p:spPr>
+      </p:pic>
     </p:spTree>
   </p:cSld>
   <p:clrMapOvr>

</xml_diff>